<commit_message>
Remove local paths from final presentation notes
</commit_message>
<xml_diff>
--- a/deliverables/ReproGuard答辩PPT-优化版.pptx
+++ b/deliverables/ReproGuard答辩PPT-优化版.pptx
@@ -2,22 +2,22 @@
 <file path=ppt/presentation.xml><?xml version="1.0" encoding="utf-8"?>
 <p:presentation xmlns:p="http://schemas.openxmlformats.org/presentationml/2006/main">
   <p:sldMasterIdLst>
-    <p:sldMasterId xmlns:r="http://schemas.openxmlformats.org/officeDocument/2006/relationships" id="2147483648" r:id="R5c2c4658fa6d4df6"/>
+    <p:sldMasterId xmlns:r="http://schemas.openxmlformats.org/officeDocument/2006/relationships" id="2147483648" r:id="Rb379545a003d42d3"/>
   </p:sldMasterIdLst>
   <p:notesMasterIdLst>
-    <p:notesMasterId xmlns:r="http://schemas.openxmlformats.org/officeDocument/2006/relationships" r:id="R2575dec161314ad5"/>
+    <p:notesMasterId xmlns:r="http://schemas.openxmlformats.org/officeDocument/2006/relationships" r:id="R5a6337b866a64a0c"/>
   </p:notesMasterIdLst>
   <p:sldIdLst>
-    <p:sldId xmlns:r="http://schemas.openxmlformats.org/officeDocument/2006/relationships" id="256" r:id="R60c069d92029474b"/>
-    <p:sldId xmlns:r="http://schemas.openxmlformats.org/officeDocument/2006/relationships" id="257" r:id="Re56269d8f28d4b7d"/>
-    <p:sldId xmlns:r="http://schemas.openxmlformats.org/officeDocument/2006/relationships" id="258" r:id="R550dae19151c4701"/>
-    <p:sldId xmlns:r="http://schemas.openxmlformats.org/officeDocument/2006/relationships" id="259" r:id="Ra58b489c597b490c"/>
-    <p:sldId xmlns:r="http://schemas.openxmlformats.org/officeDocument/2006/relationships" id="260" r:id="Rf609aea0ddf84866"/>
-    <p:sldId xmlns:r="http://schemas.openxmlformats.org/officeDocument/2006/relationships" id="261" r:id="R74d91c6ef90842d1"/>
-    <p:sldId xmlns:r="http://schemas.openxmlformats.org/officeDocument/2006/relationships" id="262" r:id="Rb8e07dcb5706452b"/>
-    <p:sldId xmlns:r="http://schemas.openxmlformats.org/officeDocument/2006/relationships" id="263" r:id="R0ed3795aad8140ae"/>
-    <p:sldId xmlns:r="http://schemas.openxmlformats.org/officeDocument/2006/relationships" id="264" r:id="Rb5a9230840884157"/>
-    <p:sldId xmlns:r="http://schemas.openxmlformats.org/officeDocument/2006/relationships" id="265" r:id="R5908e920979e47c0"/>
+    <p:sldId xmlns:r="http://schemas.openxmlformats.org/officeDocument/2006/relationships" id="256" r:id="Rf85c0da8349f4b49"/>
+    <p:sldId xmlns:r="http://schemas.openxmlformats.org/officeDocument/2006/relationships" id="257" r:id="R56f169680d2e4608"/>
+    <p:sldId xmlns:r="http://schemas.openxmlformats.org/officeDocument/2006/relationships" id="258" r:id="Rbac632b6c3f742a8"/>
+    <p:sldId xmlns:r="http://schemas.openxmlformats.org/officeDocument/2006/relationships" id="259" r:id="Rae4206e5bd874393"/>
+    <p:sldId xmlns:r="http://schemas.openxmlformats.org/officeDocument/2006/relationships" id="260" r:id="R5c1c44ed4ae3473c"/>
+    <p:sldId xmlns:r="http://schemas.openxmlformats.org/officeDocument/2006/relationships" id="261" r:id="R290f5994ab9643e0"/>
+    <p:sldId xmlns:r="http://schemas.openxmlformats.org/officeDocument/2006/relationships" id="262" r:id="R4336fcd26db44b18"/>
+    <p:sldId xmlns:r="http://schemas.openxmlformats.org/officeDocument/2006/relationships" id="263" r:id="R5cd2302a080d419e"/>
+    <p:sldId xmlns:r="http://schemas.openxmlformats.org/officeDocument/2006/relationships" id="264" r:id="Rb897023a6cc04d55"/>
+    <p:sldId xmlns:r="http://schemas.openxmlformats.org/officeDocument/2006/relationships" id="265" r:id="Rfe8caa960bab4ef2"/>
   </p:sldIdLst>
   <p:sldSz cx="12192000" cy="6858000"/>
   <p:notesSz cx="6858000" cy="9144000"/>
@@ -936,7 +936,7 @@
           </a:p>
           <a:p xmlns:a="http://schemas.openxmlformats.org/drawingml/2006/main">
             <a:r>
-              <a:t>截图：D:/codex/proplem/reproguard-action-summary.png</a:t>
+              <a:t>截图证据：公开仓库 Action 运行页面</a:t>
             </a:r>
           </a:p>
           <a:p xmlns:a="http://schemas.openxmlformats.org/drawingml/2006/main">
@@ -1264,7 +1264,7 @@
   </p:cSld>
   <p:clrMap bg1="lt1" tx1="dk1" bg2="lt2" tx2="dk2" accent1="accent1" accent2="accent2" accent3="accent3" accent4="accent4" accent5="accent5" accent6="accent6" hlink="hlink" folHlink="folHlink"/>
   <p:sldLayoutIdLst>
-    <p:sldLayoutId xmlns:r="http://schemas.openxmlformats.org/officeDocument/2006/relationships" id="2147483649" r:id="Rf04aa25945994215"/>
+    <p:sldLayoutId xmlns:r="http://schemas.openxmlformats.org/officeDocument/2006/relationships" id="2147483649" r:id="R4f900205b42d434e"/>
   </p:sldLayoutIdLst>
   <p:txStyles>
     <p:titleStyle>
@@ -1815,7 +1815,7 @@
           <p:cNvPr id="7" name="title-kicker">
             <a:extLst xmlns:a="http://schemas.openxmlformats.org/drawingml/2006/main">
               <a:ext uri="{FF2B5EF4-FFF2-40B4-BE49-F238E27FC236}">
-                <a16:creationId xmlns:a16="http://schemas.microsoft.com/office/drawing/2014/main" id="{5332ABDA-50D6-4E1C-B308-8875897090DE}"/>
+                <a16:creationId xmlns:a16="http://schemas.microsoft.com/office/drawing/2014/main" id="{E698460B-2984-4C54-B8F5-B665F950B9A8}"/>
               </a:ext>
             </a:extLst>
           </p:cNvPr>
@@ -1865,7 +1865,7 @@
           <p:cNvPr id="2" name="title-main">
             <a:extLst xmlns:a="http://schemas.openxmlformats.org/drawingml/2006/main">
               <a:ext uri="{FF2B5EF4-FFF2-40B4-BE49-F238E27FC236}">
-                <a16:creationId xmlns:a16="http://schemas.microsoft.com/office/drawing/2014/main" id="{899AA401-FA54-4432-B3CB-0C2672A059B0}"/>
+                <a16:creationId xmlns:a16="http://schemas.microsoft.com/office/drawing/2014/main" id="{7ECED063-2B84-45AA-B5FA-1BB06B4A2CB3}"/>
               </a:ext>
             </a:extLst>
           </p:cNvPr>
@@ -1932,7 +1932,7 @@
           <p:cNvPr id="3" name="title-sub">
             <a:extLst xmlns:a="http://schemas.openxmlformats.org/drawingml/2006/main">
               <a:ext uri="{FF2B5EF4-FFF2-40B4-BE49-F238E27FC236}">
-                <a16:creationId xmlns:a16="http://schemas.microsoft.com/office/drawing/2014/main" id="{725BC031-F21C-4FC6-A2CA-9DA3C3B523A8}"/>
+                <a16:creationId xmlns:a16="http://schemas.microsoft.com/office/drawing/2014/main" id="{CB423AEB-3A82-4478-AD3B-AB69924D72DD}"/>
               </a:ext>
             </a:extLst>
           </p:cNvPr>
@@ -1982,7 +1982,7 @@
           <p:cNvPr id="4" name="title-team">
             <a:extLst xmlns:a="http://schemas.openxmlformats.org/drawingml/2006/main">
               <a:ext uri="{FF2B5EF4-FFF2-40B4-BE49-F238E27FC236}">
-                <a16:creationId xmlns:a16="http://schemas.microsoft.com/office/drawing/2014/main" id="{F40BDB1C-66EE-400E-92AB-75F162B133D5}"/>
+                <a16:creationId xmlns:a16="http://schemas.microsoft.com/office/drawing/2014/main" id="{9B5478DC-FE18-436C-9679-719B5060F5EE}"/>
               </a:ext>
             </a:extLst>
           </p:cNvPr>
@@ -2032,7 +2032,7 @@
           <p:cNvPr id="5" name="title-accent">
             <a:extLst xmlns:a="http://schemas.openxmlformats.org/drawingml/2006/main">
               <a:ext uri="{FF2B5EF4-FFF2-40B4-BE49-F238E27FC236}">
-                <a16:creationId xmlns:a16="http://schemas.microsoft.com/office/drawing/2014/main" id="{7720CDD3-1730-457A-B427-94809CB682B5}"/>
+                <a16:creationId xmlns:a16="http://schemas.microsoft.com/office/drawing/2014/main" id="{23867FDE-7B30-4560-AF4D-5AFA131CE3F2}"/>
               </a:ext>
             </a:extLst>
           </p:cNvPr>
@@ -2065,7 +2065,7 @@
           <p:cNvPr id="6" name="title-side">
             <a:extLst xmlns:a="http://schemas.openxmlformats.org/drawingml/2006/main">
               <a:ext uri="{FF2B5EF4-FFF2-40B4-BE49-F238E27FC236}">
-                <a16:creationId xmlns:a16="http://schemas.microsoft.com/office/drawing/2014/main" id="{CBC40955-AD17-4A1D-80BE-AD0362761E6C}"/>
+                <a16:creationId xmlns:a16="http://schemas.microsoft.com/office/drawing/2014/main" id="{1F5A36E6-7DE2-4036-9945-80F550B23D24}"/>
               </a:ext>
             </a:extLst>
           </p:cNvPr>
@@ -2181,7 +2181,7 @@
     </p:spTree>
     <p:extLst>
       <p:ext uri="{BB962C8B-B14F-4D97-AF65-F5344CB8AC3E}">
-        <p14:creationId xmlns:p14="http://schemas.microsoft.com/office/powerpoint/2010/main" val="656538162"/>
+        <p14:creationId xmlns:p14="http://schemas.microsoft.com/office/powerpoint/2010/main" val="600379165"/>
       </p:ext>
     </p:extLst>
   </p:cSld>
@@ -2212,7 +2212,7 @@
           <p:cNvPr id="7" name="close-kicker">
             <a:extLst xmlns:a="http://schemas.openxmlformats.org/drawingml/2006/main">
               <a:ext uri="{FF2B5EF4-FFF2-40B4-BE49-F238E27FC236}">
-                <a16:creationId xmlns:a16="http://schemas.microsoft.com/office/drawing/2014/main" id="{AC865EEF-3DC8-467E-84B0-10C2835A0A03}"/>
+                <a16:creationId xmlns:a16="http://schemas.microsoft.com/office/drawing/2014/main" id="{8320D7F8-12B0-471C-9E49-E5AE145A2BBE}"/>
               </a:ext>
             </a:extLst>
           </p:cNvPr>
@@ -2262,7 +2262,7 @@
           <p:cNvPr id="2" name="close-main">
             <a:extLst xmlns:a="http://schemas.openxmlformats.org/drawingml/2006/main">
               <a:ext uri="{FF2B5EF4-FFF2-40B4-BE49-F238E27FC236}">
-                <a16:creationId xmlns:a16="http://schemas.microsoft.com/office/drawing/2014/main" id="{5F7AEB45-CA26-4CA8-BF5C-884C429F78A9}"/>
+                <a16:creationId xmlns:a16="http://schemas.microsoft.com/office/drawing/2014/main" id="{0FC5113D-1562-4976-A163-22E9FFDBF2E8}"/>
               </a:ext>
             </a:extLst>
           </p:cNvPr>
@@ -2329,7 +2329,7 @@
           <p:cNvPr id="3" name="close-rule">
             <a:extLst xmlns:a="http://schemas.openxmlformats.org/drawingml/2006/main">
               <a:ext uri="{FF2B5EF4-FFF2-40B4-BE49-F238E27FC236}">
-                <a16:creationId xmlns:a16="http://schemas.microsoft.com/office/drawing/2014/main" id="{D275B8EF-C087-4780-8D43-A2A2A3E583FA}"/>
+                <a16:creationId xmlns:a16="http://schemas.microsoft.com/office/drawing/2014/main" id="{824E90CF-F0E1-437F-92CB-6EB122A927F8}"/>
               </a:ext>
             </a:extLst>
           </p:cNvPr>
@@ -2362,7 +2362,7 @@
           <p:cNvPr id="4" name="close-status">
             <a:extLst xmlns:a="http://schemas.openxmlformats.org/drawingml/2006/main">
               <a:ext uri="{FF2B5EF4-FFF2-40B4-BE49-F238E27FC236}">
-                <a16:creationId xmlns:a16="http://schemas.microsoft.com/office/drawing/2014/main" id="{D1728140-29AE-45FF-B094-25E7650E116F}"/>
+                <a16:creationId xmlns:a16="http://schemas.microsoft.com/office/drawing/2014/main" id="{A9BC851B-425C-497F-BC4C-B852DAAC28CE}"/>
               </a:ext>
             </a:extLst>
           </p:cNvPr>
@@ -2412,7 +2412,7 @@
           <p:cNvPr id="5" name="close-next">
             <a:extLst xmlns:a="http://schemas.openxmlformats.org/drawingml/2006/main">
               <a:ext uri="{FF2B5EF4-FFF2-40B4-BE49-F238E27FC236}">
-                <a16:creationId xmlns:a16="http://schemas.microsoft.com/office/drawing/2014/main" id="{A2D6910F-96EE-472D-BFA9-2BA91E8988A6}"/>
+                <a16:creationId xmlns:a16="http://schemas.microsoft.com/office/drawing/2014/main" id="{B69A0081-B716-4BA9-836D-0D962DF13BF3}"/>
               </a:ext>
             </a:extLst>
           </p:cNvPr>
@@ -2462,7 +2462,7 @@
           <p:cNvPr id="6" name="close-accent">
             <a:extLst xmlns:a="http://schemas.openxmlformats.org/drawingml/2006/main">
               <a:ext uri="{FF2B5EF4-FFF2-40B4-BE49-F238E27FC236}">
-                <a16:creationId xmlns:a16="http://schemas.microsoft.com/office/drawing/2014/main" id="{0EE4DE05-6D27-47EF-82FD-409075A63360}"/>
+                <a16:creationId xmlns:a16="http://schemas.microsoft.com/office/drawing/2014/main" id="{A80867D0-98F4-4D1F-9018-EED830AC3D3D}"/>
               </a:ext>
             </a:extLst>
           </p:cNvPr>
@@ -2493,7 +2493,7 @@
     </p:spTree>
     <p:extLst>
       <p:ext uri="{BB962C8B-B14F-4D97-AF65-F5344CB8AC3E}">
-        <p14:creationId xmlns:p14="http://schemas.microsoft.com/office/powerpoint/2010/main" val="246416652"/>
+        <p14:creationId xmlns:p14="http://schemas.microsoft.com/office/powerpoint/2010/main" val="661857869"/>
       </p:ext>
     </p:extLst>
   </p:cSld>
@@ -2524,7 +2524,7 @@
           <p:cNvPr id="13" name="kicker-2">
             <a:extLst xmlns:a="http://schemas.openxmlformats.org/drawingml/2006/main">
               <a:ext uri="{FF2B5EF4-FFF2-40B4-BE49-F238E27FC236}">
-                <a16:creationId xmlns:a16="http://schemas.microsoft.com/office/drawing/2014/main" id="{066CEE1C-7396-42DE-83C1-3570BC0A5E02}"/>
+                <a16:creationId xmlns:a16="http://schemas.microsoft.com/office/drawing/2014/main" id="{43A15C60-7613-4120-975B-992DB68531F0}"/>
               </a:ext>
             </a:extLst>
           </p:cNvPr>
@@ -2574,7 +2574,7 @@
           <p:cNvPr id="2" name="title-2">
             <a:extLst xmlns:a="http://schemas.openxmlformats.org/drawingml/2006/main">
               <a:ext uri="{FF2B5EF4-FFF2-40B4-BE49-F238E27FC236}">
-                <a16:creationId xmlns:a16="http://schemas.microsoft.com/office/drawing/2014/main" id="{E4323054-A5E5-4C49-BDEF-07DD23B43C36}"/>
+                <a16:creationId xmlns:a16="http://schemas.microsoft.com/office/drawing/2014/main" id="{5E8B453B-D4DB-4E04-883F-933D31F87B4F}"/>
               </a:ext>
             </a:extLst>
           </p:cNvPr>
@@ -2624,7 +2624,7 @@
           <p:cNvPr id="3" name="rule-2">
             <a:extLst xmlns:a="http://schemas.openxmlformats.org/drawingml/2006/main">
               <a:ext uri="{FF2B5EF4-FFF2-40B4-BE49-F238E27FC236}">
-                <a16:creationId xmlns:a16="http://schemas.microsoft.com/office/drawing/2014/main" id="{9E53DEF9-5DE9-4913-BEAA-30C480E4690F}"/>
+                <a16:creationId xmlns:a16="http://schemas.microsoft.com/office/drawing/2014/main" id="{DC2FF730-FBF7-4EB4-81AC-F3DAE81CA7B0}"/>
               </a:ext>
             </a:extLst>
           </p:cNvPr>
@@ -2657,7 +2657,7 @@
           <p:cNvPr id="4" name="page-2">
             <a:extLst xmlns:a="http://schemas.openxmlformats.org/drawingml/2006/main">
               <a:ext uri="{FF2B5EF4-FFF2-40B4-BE49-F238E27FC236}">
-                <a16:creationId xmlns:a16="http://schemas.microsoft.com/office/drawing/2014/main" id="{6B6C41EE-CE8F-4DE0-9107-879946DB8A54}"/>
+                <a16:creationId xmlns:a16="http://schemas.microsoft.com/office/drawing/2014/main" id="{E3295B7C-34BC-45D6-B949-C1F3E4031BC9}"/>
               </a:ext>
             </a:extLst>
           </p:cNvPr>
@@ -2707,7 +2707,7 @@
           <p:cNvPr id="5" name="problem-left-label">
             <a:extLst xmlns:a="http://schemas.openxmlformats.org/drawingml/2006/main">
               <a:ext uri="{FF2B5EF4-FFF2-40B4-BE49-F238E27FC236}">
-                <a16:creationId xmlns:a16="http://schemas.microsoft.com/office/drawing/2014/main" id="{6F2FB5C5-AA20-4101-9A5C-F4365E512A31}"/>
+                <a16:creationId xmlns:a16="http://schemas.microsoft.com/office/drawing/2014/main" id="{17E34B5C-6A04-4A0C-AB0F-BA9F1976332F}"/>
               </a:ext>
             </a:extLst>
           </p:cNvPr>
@@ -2757,7 +2757,7 @@
           <p:cNvPr id="6" name="problem-left">
             <a:extLst xmlns:a="http://schemas.openxmlformats.org/drawingml/2006/main">
               <a:ext uri="{FF2B5EF4-FFF2-40B4-BE49-F238E27FC236}">
-                <a16:creationId xmlns:a16="http://schemas.microsoft.com/office/drawing/2014/main" id="{0F626BF3-CEB2-432B-B497-5E89CBEE655D}"/>
+                <a16:creationId xmlns:a16="http://schemas.microsoft.com/office/drawing/2014/main" id="{2295CA51-E10D-4968-A151-2437B986D51D}"/>
               </a:ext>
             </a:extLst>
           </p:cNvPr>
@@ -2858,7 +2858,7 @@
           <p:cNvPr id="7" name="problem-gap">
             <a:extLst xmlns:a="http://schemas.openxmlformats.org/drawingml/2006/main">
               <a:ext uri="{FF2B5EF4-FFF2-40B4-BE49-F238E27FC236}">
-                <a16:creationId xmlns:a16="http://schemas.microsoft.com/office/drawing/2014/main" id="{48F5A4BD-3AB2-467A-88BC-D34AB9310A04}"/>
+                <a16:creationId xmlns:a16="http://schemas.microsoft.com/office/drawing/2014/main" id="{6C3889CF-D072-4335-A4DF-887BA343B9C1}"/>
               </a:ext>
             </a:extLst>
           </p:cNvPr>
@@ -2908,7 +2908,7 @@
           <p:cNvPr id="8" name="problem-gap-line">
             <a:extLst xmlns:a="http://schemas.openxmlformats.org/drawingml/2006/main">
               <a:ext uri="{FF2B5EF4-FFF2-40B4-BE49-F238E27FC236}">
-                <a16:creationId xmlns:a16="http://schemas.microsoft.com/office/drawing/2014/main" id="{A24E0C83-C947-4D84-8F54-2E20D0FA71FD}"/>
+                <a16:creationId xmlns:a16="http://schemas.microsoft.com/office/drawing/2014/main" id="{58EFCE44-152C-427C-85AA-6D648EE63522}"/>
               </a:ext>
             </a:extLst>
           </p:cNvPr>
@@ -2941,7 +2941,7 @@
           <p:cNvPr id="9" name="problem-right-label">
             <a:extLst xmlns:a="http://schemas.openxmlformats.org/drawingml/2006/main">
               <a:ext uri="{FF2B5EF4-FFF2-40B4-BE49-F238E27FC236}">
-                <a16:creationId xmlns:a16="http://schemas.microsoft.com/office/drawing/2014/main" id="{1ECAB61D-5668-4083-8AF0-96C99F851AA5}"/>
+                <a16:creationId xmlns:a16="http://schemas.microsoft.com/office/drawing/2014/main" id="{6C30B190-1B05-4EEA-BF26-F975DD329ACD}"/>
               </a:ext>
             </a:extLst>
           </p:cNvPr>
@@ -2991,7 +2991,7 @@
           <p:cNvPr id="10" name="problem-right">
             <a:extLst xmlns:a="http://schemas.openxmlformats.org/drawingml/2006/main">
               <a:ext uri="{FF2B5EF4-FFF2-40B4-BE49-F238E27FC236}">
-                <a16:creationId xmlns:a16="http://schemas.microsoft.com/office/drawing/2014/main" id="{DE0AB7B8-E599-4BC9-B8FE-7E07F16A8563}"/>
+                <a16:creationId xmlns:a16="http://schemas.microsoft.com/office/drawing/2014/main" id="{FFA4EE9D-0BE0-433A-B6AB-ECD98FDFD2E1}"/>
               </a:ext>
             </a:extLst>
           </p:cNvPr>
@@ -3092,7 +3092,7 @@
           <p:cNvPr id="11" name="problem-takeaway-bg">
             <a:extLst xmlns:a="http://schemas.openxmlformats.org/drawingml/2006/main">
               <a:ext uri="{FF2B5EF4-FFF2-40B4-BE49-F238E27FC236}">
-                <a16:creationId xmlns:a16="http://schemas.microsoft.com/office/drawing/2014/main" id="{2384B486-FA65-4CB5-B95A-C5E7CB705DD6}"/>
+                <a16:creationId xmlns:a16="http://schemas.microsoft.com/office/drawing/2014/main" id="{007A69DF-B2A5-4620-9453-F3AA34E05260}"/>
               </a:ext>
             </a:extLst>
           </p:cNvPr>
@@ -3125,7 +3125,7 @@
           <p:cNvPr id="12" name="problem-takeaway">
             <a:extLst xmlns:a="http://schemas.openxmlformats.org/drawingml/2006/main">
               <a:ext uri="{FF2B5EF4-FFF2-40B4-BE49-F238E27FC236}">
-                <a16:creationId xmlns:a16="http://schemas.microsoft.com/office/drawing/2014/main" id="{9F818FCC-09F3-4666-ABF3-4AAEE265EB28}"/>
+                <a16:creationId xmlns:a16="http://schemas.microsoft.com/office/drawing/2014/main" id="{9319DF8D-3844-492D-9E19-1D84262CA2B2}"/>
               </a:ext>
             </a:extLst>
           </p:cNvPr>
@@ -3173,7 +3173,7 @@
     </p:spTree>
     <p:extLst>
       <p:ext uri="{BB962C8B-B14F-4D97-AF65-F5344CB8AC3E}">
-        <p14:creationId xmlns:p14="http://schemas.microsoft.com/office/powerpoint/2010/main" val="521481508"/>
+        <p14:creationId xmlns:p14="http://schemas.microsoft.com/office/powerpoint/2010/main" val="963226804"/>
       </p:ext>
     </p:extLst>
   </p:cSld>
@@ -3204,7 +3204,7 @@
           <p:cNvPr id="30" name="kicker-3">
             <a:extLst xmlns:a="http://schemas.openxmlformats.org/drawingml/2006/main">
               <a:ext uri="{FF2B5EF4-FFF2-40B4-BE49-F238E27FC236}">
-                <a16:creationId xmlns:a16="http://schemas.microsoft.com/office/drawing/2014/main" id="{78FD3E9B-4609-475E-9952-E1FD7C637E8B}"/>
+                <a16:creationId xmlns:a16="http://schemas.microsoft.com/office/drawing/2014/main" id="{898AABE6-F3C3-48B3-AA2E-8BEDEB254C32}"/>
               </a:ext>
             </a:extLst>
           </p:cNvPr>
@@ -3254,7 +3254,7 @@
           <p:cNvPr id="2" name="title-3">
             <a:extLst xmlns:a="http://schemas.openxmlformats.org/drawingml/2006/main">
               <a:ext uri="{FF2B5EF4-FFF2-40B4-BE49-F238E27FC236}">
-                <a16:creationId xmlns:a16="http://schemas.microsoft.com/office/drawing/2014/main" id="{DF418119-E607-4DCA-A4BB-904057F44A40}"/>
+                <a16:creationId xmlns:a16="http://schemas.microsoft.com/office/drawing/2014/main" id="{CAC6B127-8AB1-41DA-9EA1-A0FEBFE73365}"/>
               </a:ext>
             </a:extLst>
           </p:cNvPr>
@@ -3304,7 +3304,7 @@
           <p:cNvPr id="3" name="rule-3">
             <a:extLst xmlns:a="http://schemas.openxmlformats.org/drawingml/2006/main">
               <a:ext uri="{FF2B5EF4-FFF2-40B4-BE49-F238E27FC236}">
-                <a16:creationId xmlns:a16="http://schemas.microsoft.com/office/drawing/2014/main" id="{A0C3BEFF-6FCE-4CB5-8CAC-5F01EB7B78BC}"/>
+                <a16:creationId xmlns:a16="http://schemas.microsoft.com/office/drawing/2014/main" id="{1CD9B76F-036D-4A1D-B4D4-C57BF5E2760A}"/>
               </a:ext>
             </a:extLst>
           </p:cNvPr>
@@ -3337,7 +3337,7 @@
           <p:cNvPr id="4" name="page-3">
             <a:extLst xmlns:a="http://schemas.openxmlformats.org/drawingml/2006/main">
               <a:ext uri="{FF2B5EF4-FFF2-40B4-BE49-F238E27FC236}">
-                <a16:creationId xmlns:a16="http://schemas.microsoft.com/office/drawing/2014/main" id="{7D6EF7B1-C885-472B-B1CC-854490BCEBAD}"/>
+                <a16:creationId xmlns:a16="http://schemas.microsoft.com/office/drawing/2014/main" id="{4CE1454E-9D1C-4594-9691-C3EF8C695069}"/>
               </a:ext>
             </a:extLst>
           </p:cNvPr>
@@ -3387,7 +3387,7 @@
           <p:cNvPr id="5" name="flow-edge-0">
             <a:extLst xmlns:a="http://schemas.openxmlformats.org/drawingml/2006/main">
               <a:ext uri="{FF2B5EF4-FFF2-40B4-BE49-F238E27FC236}">
-                <a16:creationId xmlns:a16="http://schemas.microsoft.com/office/drawing/2014/main" id="{CA5CE6C7-CE98-4F69-B872-03EDA9021F6B}"/>
+                <a16:creationId xmlns:a16="http://schemas.microsoft.com/office/drawing/2014/main" id="{81C2CC70-317A-4C97-AAD7-3E13ECAC1084}"/>
               </a:ext>
             </a:extLst>
           </p:cNvPr>
@@ -3420,7 +3420,7 @@
           <p:cNvPr id="6" name="flow-node-0">
             <a:extLst xmlns:a="http://schemas.openxmlformats.org/drawingml/2006/main">
               <a:ext uri="{FF2B5EF4-FFF2-40B4-BE49-F238E27FC236}">
-                <a16:creationId xmlns:a16="http://schemas.microsoft.com/office/drawing/2014/main" id="{61B00ACB-AF31-43D8-AC3F-E9521D5ED466}"/>
+                <a16:creationId xmlns:a16="http://schemas.microsoft.com/office/drawing/2014/main" id="{BE7192B4-F610-4584-91C8-AEA9E8DDD340}"/>
               </a:ext>
             </a:extLst>
           </p:cNvPr>
@@ -3453,7 +3453,7 @@
           <p:cNvPr id="7" name="flow-num-0">
             <a:extLst xmlns:a="http://schemas.openxmlformats.org/drawingml/2006/main">
               <a:ext uri="{FF2B5EF4-FFF2-40B4-BE49-F238E27FC236}">
-                <a16:creationId xmlns:a16="http://schemas.microsoft.com/office/drawing/2014/main" id="{566210EB-CAE1-4861-A2CA-AA6A0D9957CB}"/>
+                <a16:creationId xmlns:a16="http://schemas.microsoft.com/office/drawing/2014/main" id="{8C164B96-9AE4-4088-B71D-EEC16DF4B950}"/>
               </a:ext>
             </a:extLst>
           </p:cNvPr>
@@ -3503,7 +3503,7 @@
           <p:cNvPr id="8" name="flow-label-0">
             <a:extLst xmlns:a="http://schemas.openxmlformats.org/drawingml/2006/main">
               <a:ext uri="{FF2B5EF4-FFF2-40B4-BE49-F238E27FC236}">
-                <a16:creationId xmlns:a16="http://schemas.microsoft.com/office/drawing/2014/main" id="{F1EED3C2-5B14-4DDD-AF05-66F9A6E51BF8}"/>
+                <a16:creationId xmlns:a16="http://schemas.microsoft.com/office/drawing/2014/main" id="{BDD60326-2117-4D01-85C8-87A0B7683ACA}"/>
               </a:ext>
             </a:extLst>
           </p:cNvPr>
@@ -3553,7 +3553,7 @@
           <p:cNvPr id="9" name="flow-edge-1">
             <a:extLst xmlns:a="http://schemas.openxmlformats.org/drawingml/2006/main">
               <a:ext uri="{FF2B5EF4-FFF2-40B4-BE49-F238E27FC236}">
-                <a16:creationId xmlns:a16="http://schemas.microsoft.com/office/drawing/2014/main" id="{D39AE923-E499-45D9-A434-EFA9BE85E6A9}"/>
+                <a16:creationId xmlns:a16="http://schemas.microsoft.com/office/drawing/2014/main" id="{A7A9F0CE-E972-409D-8FB5-8CD48E9F13C0}"/>
               </a:ext>
             </a:extLst>
           </p:cNvPr>
@@ -3586,7 +3586,7 @@
           <p:cNvPr id="10" name="flow-node-1">
             <a:extLst xmlns:a="http://schemas.openxmlformats.org/drawingml/2006/main">
               <a:ext uri="{FF2B5EF4-FFF2-40B4-BE49-F238E27FC236}">
-                <a16:creationId xmlns:a16="http://schemas.microsoft.com/office/drawing/2014/main" id="{613E8CA9-DA15-437B-851F-D87E8D6B50FC}"/>
+                <a16:creationId xmlns:a16="http://schemas.microsoft.com/office/drawing/2014/main" id="{8AAEFD5B-1790-4651-A86A-52FDC896E107}"/>
               </a:ext>
             </a:extLst>
           </p:cNvPr>
@@ -3619,7 +3619,7 @@
           <p:cNvPr id="11" name="flow-num-1">
             <a:extLst xmlns:a="http://schemas.openxmlformats.org/drawingml/2006/main">
               <a:ext uri="{FF2B5EF4-FFF2-40B4-BE49-F238E27FC236}">
-                <a16:creationId xmlns:a16="http://schemas.microsoft.com/office/drawing/2014/main" id="{CDA14A17-866B-4CAF-B115-41F185A9DCD7}"/>
+                <a16:creationId xmlns:a16="http://schemas.microsoft.com/office/drawing/2014/main" id="{ABE5FE3F-107B-4863-A2DD-405298BE25DF}"/>
               </a:ext>
             </a:extLst>
           </p:cNvPr>
@@ -3669,7 +3669,7 @@
           <p:cNvPr id="12" name="flow-label-1">
             <a:extLst xmlns:a="http://schemas.openxmlformats.org/drawingml/2006/main">
               <a:ext uri="{FF2B5EF4-FFF2-40B4-BE49-F238E27FC236}">
-                <a16:creationId xmlns:a16="http://schemas.microsoft.com/office/drawing/2014/main" id="{E3EFA9E0-3952-4ADA-8082-BCC290F75AEF}"/>
+                <a16:creationId xmlns:a16="http://schemas.microsoft.com/office/drawing/2014/main" id="{F197E598-2404-4438-B402-5F63A2DEEB6C}"/>
               </a:ext>
             </a:extLst>
           </p:cNvPr>
@@ -3719,7 +3719,7 @@
           <p:cNvPr id="13" name="flow-edge-2">
             <a:extLst xmlns:a="http://schemas.openxmlformats.org/drawingml/2006/main">
               <a:ext uri="{FF2B5EF4-FFF2-40B4-BE49-F238E27FC236}">
-                <a16:creationId xmlns:a16="http://schemas.microsoft.com/office/drawing/2014/main" id="{0DC79DF7-0D63-4E3A-AEAB-AA6CB848B3A6}"/>
+                <a16:creationId xmlns:a16="http://schemas.microsoft.com/office/drawing/2014/main" id="{3CF97B69-79B5-43AE-B4E2-5D71F42C3EE4}"/>
               </a:ext>
             </a:extLst>
           </p:cNvPr>
@@ -3752,7 +3752,7 @@
           <p:cNvPr id="14" name="flow-node-2">
             <a:extLst xmlns:a="http://schemas.openxmlformats.org/drawingml/2006/main">
               <a:ext uri="{FF2B5EF4-FFF2-40B4-BE49-F238E27FC236}">
-                <a16:creationId xmlns:a16="http://schemas.microsoft.com/office/drawing/2014/main" id="{A2457175-CD5D-4EFE-BC2A-DAB443C4162A}"/>
+                <a16:creationId xmlns:a16="http://schemas.microsoft.com/office/drawing/2014/main" id="{2E6CC8D9-C141-4020-A243-E5044901280A}"/>
               </a:ext>
             </a:extLst>
           </p:cNvPr>
@@ -3785,7 +3785,7 @@
           <p:cNvPr id="15" name="flow-num-2">
             <a:extLst xmlns:a="http://schemas.openxmlformats.org/drawingml/2006/main">
               <a:ext uri="{FF2B5EF4-FFF2-40B4-BE49-F238E27FC236}">
-                <a16:creationId xmlns:a16="http://schemas.microsoft.com/office/drawing/2014/main" id="{2F5AC950-41C7-42A1-943C-0F1D5C3F3D22}"/>
+                <a16:creationId xmlns:a16="http://schemas.microsoft.com/office/drawing/2014/main" id="{C5B50183-CEC1-4373-8474-612838E0620B}"/>
               </a:ext>
             </a:extLst>
           </p:cNvPr>
@@ -3835,7 +3835,7 @@
           <p:cNvPr id="16" name="flow-label-2">
             <a:extLst xmlns:a="http://schemas.openxmlformats.org/drawingml/2006/main">
               <a:ext uri="{FF2B5EF4-FFF2-40B4-BE49-F238E27FC236}">
-                <a16:creationId xmlns:a16="http://schemas.microsoft.com/office/drawing/2014/main" id="{7E61CFB5-8C04-416A-AD47-A9A6574873F4}"/>
+                <a16:creationId xmlns:a16="http://schemas.microsoft.com/office/drawing/2014/main" id="{03EBE55C-E93F-470B-9D27-15EF6609BD47}"/>
               </a:ext>
             </a:extLst>
           </p:cNvPr>
@@ -3885,7 +3885,7 @@
           <p:cNvPr id="17" name="flow-edge-3">
             <a:extLst xmlns:a="http://schemas.openxmlformats.org/drawingml/2006/main">
               <a:ext uri="{FF2B5EF4-FFF2-40B4-BE49-F238E27FC236}">
-                <a16:creationId xmlns:a16="http://schemas.microsoft.com/office/drawing/2014/main" id="{D178B44D-4825-4CBF-BA11-74B8492E0941}"/>
+                <a16:creationId xmlns:a16="http://schemas.microsoft.com/office/drawing/2014/main" id="{AEA833E6-DD7D-4CB2-8F3E-B14E3625B893}"/>
               </a:ext>
             </a:extLst>
           </p:cNvPr>
@@ -3918,7 +3918,7 @@
           <p:cNvPr id="18" name="flow-node-3">
             <a:extLst xmlns:a="http://schemas.openxmlformats.org/drawingml/2006/main">
               <a:ext uri="{FF2B5EF4-FFF2-40B4-BE49-F238E27FC236}">
-                <a16:creationId xmlns:a16="http://schemas.microsoft.com/office/drawing/2014/main" id="{E40A8FDC-4BCC-4462-A45F-BCB3DA488B07}"/>
+                <a16:creationId xmlns:a16="http://schemas.microsoft.com/office/drawing/2014/main" id="{DE2D2908-7052-4A5B-91EA-623B30AAE13B}"/>
               </a:ext>
             </a:extLst>
           </p:cNvPr>
@@ -3951,7 +3951,7 @@
           <p:cNvPr id="19" name="flow-num-3">
             <a:extLst xmlns:a="http://schemas.openxmlformats.org/drawingml/2006/main">
               <a:ext uri="{FF2B5EF4-FFF2-40B4-BE49-F238E27FC236}">
-                <a16:creationId xmlns:a16="http://schemas.microsoft.com/office/drawing/2014/main" id="{FA7C2376-AF87-4610-9DDB-BC16DB98A549}"/>
+                <a16:creationId xmlns:a16="http://schemas.microsoft.com/office/drawing/2014/main" id="{21E5BF85-BF81-4284-899D-9B9C300059CD}"/>
               </a:ext>
             </a:extLst>
           </p:cNvPr>
@@ -4001,7 +4001,7 @@
           <p:cNvPr id="20" name="flow-label-3">
             <a:extLst xmlns:a="http://schemas.openxmlformats.org/drawingml/2006/main">
               <a:ext uri="{FF2B5EF4-FFF2-40B4-BE49-F238E27FC236}">
-                <a16:creationId xmlns:a16="http://schemas.microsoft.com/office/drawing/2014/main" id="{58216104-AA64-4050-AC10-1971142545B9}"/>
+                <a16:creationId xmlns:a16="http://schemas.microsoft.com/office/drawing/2014/main" id="{26F8D32A-7711-4DB8-BD8E-6623F675747E}"/>
               </a:ext>
             </a:extLst>
           </p:cNvPr>
@@ -4051,7 +4051,7 @@
           <p:cNvPr id="21" name="flow-edge-4">
             <a:extLst xmlns:a="http://schemas.openxmlformats.org/drawingml/2006/main">
               <a:ext uri="{FF2B5EF4-FFF2-40B4-BE49-F238E27FC236}">
-                <a16:creationId xmlns:a16="http://schemas.microsoft.com/office/drawing/2014/main" id="{415652C0-B44F-4B05-9A47-FA3164D30B36}"/>
+                <a16:creationId xmlns:a16="http://schemas.microsoft.com/office/drawing/2014/main" id="{4FCDD011-95EF-4391-A1A9-5016EC0C7208}"/>
               </a:ext>
             </a:extLst>
           </p:cNvPr>
@@ -4084,7 +4084,7 @@
           <p:cNvPr id="22" name="flow-node-4">
             <a:extLst xmlns:a="http://schemas.openxmlformats.org/drawingml/2006/main">
               <a:ext uri="{FF2B5EF4-FFF2-40B4-BE49-F238E27FC236}">
-                <a16:creationId xmlns:a16="http://schemas.microsoft.com/office/drawing/2014/main" id="{A067732C-6D91-45BF-A323-A9231E2F322C}"/>
+                <a16:creationId xmlns:a16="http://schemas.microsoft.com/office/drawing/2014/main" id="{92BA7F8C-6C2F-4E93-83B0-DA1F037EA382}"/>
               </a:ext>
             </a:extLst>
           </p:cNvPr>
@@ -4117,7 +4117,7 @@
           <p:cNvPr id="23" name="flow-num-4">
             <a:extLst xmlns:a="http://schemas.openxmlformats.org/drawingml/2006/main">
               <a:ext uri="{FF2B5EF4-FFF2-40B4-BE49-F238E27FC236}">
-                <a16:creationId xmlns:a16="http://schemas.microsoft.com/office/drawing/2014/main" id="{67BC67A5-EEE6-4EC3-B270-6F15B348A9F1}"/>
+                <a16:creationId xmlns:a16="http://schemas.microsoft.com/office/drawing/2014/main" id="{11A4FE5E-2082-49C7-85D4-BFA039C8F786}"/>
               </a:ext>
             </a:extLst>
           </p:cNvPr>
@@ -4167,7 +4167,7 @@
           <p:cNvPr id="24" name="flow-label-4">
             <a:extLst xmlns:a="http://schemas.openxmlformats.org/drawingml/2006/main">
               <a:ext uri="{FF2B5EF4-FFF2-40B4-BE49-F238E27FC236}">
-                <a16:creationId xmlns:a16="http://schemas.microsoft.com/office/drawing/2014/main" id="{B59F4A01-0127-4AA0-AC36-9D2BC932E959}"/>
+                <a16:creationId xmlns:a16="http://schemas.microsoft.com/office/drawing/2014/main" id="{CF7ADEE2-118B-4A45-98B4-3B094B8DD471}"/>
               </a:ext>
             </a:extLst>
           </p:cNvPr>
@@ -4217,7 +4217,7 @@
           <p:cNvPr id="25" name="flow-node-5">
             <a:extLst xmlns:a="http://schemas.openxmlformats.org/drawingml/2006/main">
               <a:ext uri="{FF2B5EF4-FFF2-40B4-BE49-F238E27FC236}">
-                <a16:creationId xmlns:a16="http://schemas.microsoft.com/office/drawing/2014/main" id="{12BF6CD3-F756-446A-A7AF-C34E21B660A7}"/>
+                <a16:creationId xmlns:a16="http://schemas.microsoft.com/office/drawing/2014/main" id="{7586AF14-0A8B-4FCF-828A-6FD76113B476}"/>
               </a:ext>
             </a:extLst>
           </p:cNvPr>
@@ -4250,7 +4250,7 @@
           <p:cNvPr id="26" name="flow-num-5">
             <a:extLst xmlns:a="http://schemas.openxmlformats.org/drawingml/2006/main">
               <a:ext uri="{FF2B5EF4-FFF2-40B4-BE49-F238E27FC236}">
-                <a16:creationId xmlns:a16="http://schemas.microsoft.com/office/drawing/2014/main" id="{1F945163-6531-452B-9DE0-EC100143A803}"/>
+                <a16:creationId xmlns:a16="http://schemas.microsoft.com/office/drawing/2014/main" id="{666819FC-9E80-494B-87FF-DF959B710204}"/>
               </a:ext>
             </a:extLst>
           </p:cNvPr>
@@ -4300,7 +4300,7 @@
           <p:cNvPr id="27" name="flow-label-5">
             <a:extLst xmlns:a="http://schemas.openxmlformats.org/drawingml/2006/main">
               <a:ext uri="{FF2B5EF4-FFF2-40B4-BE49-F238E27FC236}">
-                <a16:creationId xmlns:a16="http://schemas.microsoft.com/office/drawing/2014/main" id="{83E1EEBE-2957-4521-BFE1-404DD4579E67}"/>
+                <a16:creationId xmlns:a16="http://schemas.microsoft.com/office/drawing/2014/main" id="{DB7E76B8-D646-40AF-9376-5312443A0224}"/>
               </a:ext>
             </a:extLst>
           </p:cNvPr>
@@ -4350,7 +4350,7 @@
           <p:cNvPr id="28" name="flow-boundary-bg">
             <a:extLst xmlns:a="http://schemas.openxmlformats.org/drawingml/2006/main">
               <a:ext uri="{FF2B5EF4-FFF2-40B4-BE49-F238E27FC236}">
-                <a16:creationId xmlns:a16="http://schemas.microsoft.com/office/drawing/2014/main" id="{D8E63EEC-0D24-467F-BBF4-CD3BB1178E68}"/>
+                <a16:creationId xmlns:a16="http://schemas.microsoft.com/office/drawing/2014/main" id="{ED6590D5-12F9-4458-9FAC-E47E9EC9C272}"/>
               </a:ext>
             </a:extLst>
           </p:cNvPr>
@@ -4383,7 +4383,7 @@
           <p:cNvPr id="29" name="flow-boundary">
             <a:extLst xmlns:a="http://schemas.openxmlformats.org/drawingml/2006/main">
               <a:ext uri="{FF2B5EF4-FFF2-40B4-BE49-F238E27FC236}">
-                <a16:creationId xmlns:a16="http://schemas.microsoft.com/office/drawing/2014/main" id="{CAF83DAA-D2A8-4235-A54C-671DB5B1CD33}"/>
+                <a16:creationId xmlns:a16="http://schemas.microsoft.com/office/drawing/2014/main" id="{A69960E6-2A9E-41F5-BDD4-C4AC5C175AE9}"/>
               </a:ext>
             </a:extLst>
           </p:cNvPr>
@@ -4431,7 +4431,7 @@
     </p:spTree>
     <p:extLst>
       <p:ext uri="{BB962C8B-B14F-4D97-AF65-F5344CB8AC3E}">
-        <p14:creationId xmlns:p14="http://schemas.microsoft.com/office/powerpoint/2010/main" val="1149947896"/>
+        <p14:creationId xmlns:p14="http://schemas.microsoft.com/office/powerpoint/2010/main" val="269667093"/>
       </p:ext>
     </p:extLst>
   </p:cSld>
@@ -4462,7 +4462,7 @@
           <p:cNvPr id="16" name="kicker-4">
             <a:extLst xmlns:a="http://schemas.openxmlformats.org/drawingml/2006/main">
               <a:ext uri="{FF2B5EF4-FFF2-40B4-BE49-F238E27FC236}">
-                <a16:creationId xmlns:a16="http://schemas.microsoft.com/office/drawing/2014/main" id="{BB4486D5-9001-4147-9305-70AE8D7E1F6D}"/>
+                <a16:creationId xmlns:a16="http://schemas.microsoft.com/office/drawing/2014/main" id="{AA0EC150-B320-4328-BFB5-A84AF5B11C88}"/>
               </a:ext>
             </a:extLst>
           </p:cNvPr>
@@ -4512,7 +4512,7 @@
           <p:cNvPr id="2" name="title-4">
             <a:extLst xmlns:a="http://schemas.openxmlformats.org/drawingml/2006/main">
               <a:ext uri="{FF2B5EF4-FFF2-40B4-BE49-F238E27FC236}">
-                <a16:creationId xmlns:a16="http://schemas.microsoft.com/office/drawing/2014/main" id="{DC3B6B38-D24A-40A6-95FA-F14F6CADC839}"/>
+                <a16:creationId xmlns:a16="http://schemas.microsoft.com/office/drawing/2014/main" id="{7E016446-B10F-4691-B7C1-2BDB3B67F14F}"/>
               </a:ext>
             </a:extLst>
           </p:cNvPr>
@@ -4562,7 +4562,7 @@
           <p:cNvPr id="3" name="rule-4">
             <a:extLst xmlns:a="http://schemas.openxmlformats.org/drawingml/2006/main">
               <a:ext uri="{FF2B5EF4-FFF2-40B4-BE49-F238E27FC236}">
-                <a16:creationId xmlns:a16="http://schemas.microsoft.com/office/drawing/2014/main" id="{6E58DC8F-4C5A-4D17-9122-5AB77A781222}"/>
+                <a16:creationId xmlns:a16="http://schemas.microsoft.com/office/drawing/2014/main" id="{304196E5-BFCA-4ACE-807B-B27524A2A652}"/>
               </a:ext>
             </a:extLst>
           </p:cNvPr>
@@ -4595,7 +4595,7 @@
           <p:cNvPr id="4" name="page-4">
             <a:extLst xmlns:a="http://schemas.openxmlformats.org/drawingml/2006/main">
               <a:ext uri="{FF2B5EF4-FFF2-40B4-BE49-F238E27FC236}">
-                <a16:creationId xmlns:a16="http://schemas.microsoft.com/office/drawing/2014/main" id="{4546DFEC-95FF-47A8-8D29-01B964E7B4FF}"/>
+                <a16:creationId xmlns:a16="http://schemas.microsoft.com/office/drawing/2014/main" id="{7208C482-915E-4E4E-8847-5F432D0E774A}"/>
               </a:ext>
             </a:extLst>
           </p:cNvPr>
@@ -4645,7 +4645,7 @@
           <p:cNvPr id="5" name="innovation-accent-0">
             <a:extLst xmlns:a="http://schemas.openxmlformats.org/drawingml/2006/main">
               <a:ext uri="{FF2B5EF4-FFF2-40B4-BE49-F238E27FC236}">
-                <a16:creationId xmlns:a16="http://schemas.microsoft.com/office/drawing/2014/main" id="{3984B4E6-2FF3-4D65-9068-AB717D5E5ED3}"/>
+                <a16:creationId xmlns:a16="http://schemas.microsoft.com/office/drawing/2014/main" id="{66660273-DC3E-4971-A5D6-1ED7E1298107}"/>
               </a:ext>
             </a:extLst>
           </p:cNvPr>
@@ -4678,7 +4678,7 @@
           <p:cNvPr id="6" name="innovation-title-0">
             <a:extLst xmlns:a="http://schemas.openxmlformats.org/drawingml/2006/main">
               <a:ext uri="{FF2B5EF4-FFF2-40B4-BE49-F238E27FC236}">
-                <a16:creationId xmlns:a16="http://schemas.microsoft.com/office/drawing/2014/main" id="{924EADBD-F016-4DBB-B748-FBCB2775B62B}"/>
+                <a16:creationId xmlns:a16="http://schemas.microsoft.com/office/drawing/2014/main" id="{B761B322-0986-4F93-B9A5-DEFDC89FDB86}"/>
               </a:ext>
             </a:extLst>
           </p:cNvPr>
@@ -4728,7 +4728,7 @@
           <p:cNvPr id="7" name="innovation-body-0">
             <a:extLst xmlns:a="http://schemas.openxmlformats.org/drawingml/2006/main">
               <a:ext uri="{FF2B5EF4-FFF2-40B4-BE49-F238E27FC236}">
-                <a16:creationId xmlns:a16="http://schemas.microsoft.com/office/drawing/2014/main" id="{123C5A32-CF25-4F0C-B490-48A828AA6C76}"/>
+                <a16:creationId xmlns:a16="http://schemas.microsoft.com/office/drawing/2014/main" id="{69F50967-93EA-4601-A45F-D6DB8FA8AACA}"/>
               </a:ext>
             </a:extLst>
           </p:cNvPr>
@@ -4778,7 +4778,7 @@
           <p:cNvPr id="8" name="innovation-accent-1">
             <a:extLst xmlns:a="http://schemas.openxmlformats.org/drawingml/2006/main">
               <a:ext uri="{FF2B5EF4-FFF2-40B4-BE49-F238E27FC236}">
-                <a16:creationId xmlns:a16="http://schemas.microsoft.com/office/drawing/2014/main" id="{06B9BDA6-A5C9-4D20-83C4-10168F741629}"/>
+                <a16:creationId xmlns:a16="http://schemas.microsoft.com/office/drawing/2014/main" id="{C15F1E01-6740-45C7-AABA-08D2A84F8234}"/>
               </a:ext>
             </a:extLst>
           </p:cNvPr>
@@ -4811,7 +4811,7 @@
           <p:cNvPr id="9" name="innovation-title-1">
             <a:extLst xmlns:a="http://schemas.openxmlformats.org/drawingml/2006/main">
               <a:ext uri="{FF2B5EF4-FFF2-40B4-BE49-F238E27FC236}">
-                <a16:creationId xmlns:a16="http://schemas.microsoft.com/office/drawing/2014/main" id="{75D12066-0985-4710-82D8-6D0DFF2FC153}"/>
+                <a16:creationId xmlns:a16="http://schemas.microsoft.com/office/drawing/2014/main" id="{DBEF640B-5455-4D3D-8EA1-12997AACED33}"/>
               </a:ext>
             </a:extLst>
           </p:cNvPr>
@@ -4861,7 +4861,7 @@
           <p:cNvPr id="10" name="innovation-body-1">
             <a:extLst xmlns:a="http://schemas.openxmlformats.org/drawingml/2006/main">
               <a:ext uri="{FF2B5EF4-FFF2-40B4-BE49-F238E27FC236}">
-                <a16:creationId xmlns:a16="http://schemas.microsoft.com/office/drawing/2014/main" id="{C23F46F0-F9C3-4939-913D-096E99A70A0B}"/>
+                <a16:creationId xmlns:a16="http://schemas.microsoft.com/office/drawing/2014/main" id="{F46609EF-08B9-466A-A5E5-4981DD3AC386}"/>
               </a:ext>
             </a:extLst>
           </p:cNvPr>
@@ -4911,7 +4911,7 @@
           <p:cNvPr id="11" name="innovation-accent-2">
             <a:extLst xmlns:a="http://schemas.openxmlformats.org/drawingml/2006/main">
               <a:ext uri="{FF2B5EF4-FFF2-40B4-BE49-F238E27FC236}">
-                <a16:creationId xmlns:a16="http://schemas.microsoft.com/office/drawing/2014/main" id="{B104B84E-ED3B-4A1A-97B1-529069EBCF01}"/>
+                <a16:creationId xmlns:a16="http://schemas.microsoft.com/office/drawing/2014/main" id="{1DF26909-6891-4B6B-986A-1A0723C2D9FD}"/>
               </a:ext>
             </a:extLst>
           </p:cNvPr>
@@ -4944,7 +4944,7 @@
           <p:cNvPr id="12" name="innovation-title-2">
             <a:extLst xmlns:a="http://schemas.openxmlformats.org/drawingml/2006/main">
               <a:ext uri="{FF2B5EF4-FFF2-40B4-BE49-F238E27FC236}">
-                <a16:creationId xmlns:a16="http://schemas.microsoft.com/office/drawing/2014/main" id="{1EBAABAD-7172-41AF-8496-6567AE7FD422}"/>
+                <a16:creationId xmlns:a16="http://schemas.microsoft.com/office/drawing/2014/main" id="{F3A3CA84-A93D-4646-8673-C6D7625E41B8}"/>
               </a:ext>
             </a:extLst>
           </p:cNvPr>
@@ -4994,7 +4994,7 @@
           <p:cNvPr id="13" name="innovation-body-2">
             <a:extLst xmlns:a="http://schemas.openxmlformats.org/drawingml/2006/main">
               <a:ext uri="{FF2B5EF4-FFF2-40B4-BE49-F238E27FC236}">
-                <a16:creationId xmlns:a16="http://schemas.microsoft.com/office/drawing/2014/main" id="{FA7F9777-ACAB-4D7E-9D0F-A3FB4306D71F}"/>
+                <a16:creationId xmlns:a16="http://schemas.microsoft.com/office/drawing/2014/main" id="{523F68DF-1B5D-433C-80BF-106E2866D922}"/>
               </a:ext>
             </a:extLst>
           </p:cNvPr>
@@ -5044,7 +5044,7 @@
           <p:cNvPr id="14" name="innovation-bottom-rule">
             <a:extLst xmlns:a="http://schemas.openxmlformats.org/drawingml/2006/main">
               <a:ext uri="{FF2B5EF4-FFF2-40B4-BE49-F238E27FC236}">
-                <a16:creationId xmlns:a16="http://schemas.microsoft.com/office/drawing/2014/main" id="{83A0BEDA-3007-4152-8055-969875CB86D9}"/>
+                <a16:creationId xmlns:a16="http://schemas.microsoft.com/office/drawing/2014/main" id="{31454C5B-341E-4D5D-9A32-092A71BB8491}"/>
               </a:ext>
             </a:extLst>
           </p:cNvPr>
@@ -5077,7 +5077,7 @@
           <p:cNvPr id="15" name="innovation-bottom">
             <a:extLst xmlns:a="http://schemas.openxmlformats.org/drawingml/2006/main">
               <a:ext uri="{FF2B5EF4-FFF2-40B4-BE49-F238E27FC236}">
-                <a16:creationId xmlns:a16="http://schemas.microsoft.com/office/drawing/2014/main" id="{DEDBABF7-075E-4CCA-87BB-8D2EC627D925}"/>
+                <a16:creationId xmlns:a16="http://schemas.microsoft.com/office/drawing/2014/main" id="{E7474967-96B1-4F02-AC85-5D29ED0422B8}"/>
               </a:ext>
             </a:extLst>
           </p:cNvPr>
@@ -5125,7 +5125,7 @@
     </p:spTree>
     <p:extLst>
       <p:ext uri="{BB962C8B-B14F-4D97-AF65-F5344CB8AC3E}">
-        <p14:creationId xmlns:p14="http://schemas.microsoft.com/office/powerpoint/2010/main" val="655928056"/>
+        <p14:creationId xmlns:p14="http://schemas.microsoft.com/office/powerpoint/2010/main" val="1769081727"/>
       </p:ext>
     </p:extLst>
   </p:cSld>
@@ -5156,7 +5156,7 @@
           <p:cNvPr id="18" name="kicker-5">
             <a:extLst xmlns:a="http://schemas.openxmlformats.org/drawingml/2006/main">
               <a:ext uri="{FF2B5EF4-FFF2-40B4-BE49-F238E27FC236}">
-                <a16:creationId xmlns:a16="http://schemas.microsoft.com/office/drawing/2014/main" id="{24297377-4EA7-44D0-8E9A-A088BFDE4994}"/>
+                <a16:creationId xmlns:a16="http://schemas.microsoft.com/office/drawing/2014/main" id="{1CCF4AB7-7324-4C33-9D02-762225CA4B91}"/>
               </a:ext>
             </a:extLst>
           </p:cNvPr>
@@ -5206,7 +5206,7 @@
           <p:cNvPr id="2" name="title-5">
             <a:extLst xmlns:a="http://schemas.openxmlformats.org/drawingml/2006/main">
               <a:ext uri="{FF2B5EF4-FFF2-40B4-BE49-F238E27FC236}">
-                <a16:creationId xmlns:a16="http://schemas.microsoft.com/office/drawing/2014/main" id="{A3C82192-BE38-4B56-AEB7-5A5C893ED4BA}"/>
+                <a16:creationId xmlns:a16="http://schemas.microsoft.com/office/drawing/2014/main" id="{CF0F75DD-AE24-40B0-821E-A1868A0A9B1C}"/>
               </a:ext>
             </a:extLst>
           </p:cNvPr>
@@ -5256,7 +5256,7 @@
           <p:cNvPr id="3" name="rule-5">
             <a:extLst xmlns:a="http://schemas.openxmlformats.org/drawingml/2006/main">
               <a:ext uri="{FF2B5EF4-FFF2-40B4-BE49-F238E27FC236}">
-                <a16:creationId xmlns:a16="http://schemas.microsoft.com/office/drawing/2014/main" id="{25812A49-0FBD-418B-AE62-304A3CB3602F}"/>
+                <a16:creationId xmlns:a16="http://schemas.microsoft.com/office/drawing/2014/main" id="{4014066B-5E4A-4444-A5DE-DF76CCAF9B65}"/>
               </a:ext>
             </a:extLst>
           </p:cNvPr>
@@ -5289,7 +5289,7 @@
           <p:cNvPr id="4" name="page-5">
             <a:extLst xmlns:a="http://schemas.openxmlformats.org/drawingml/2006/main">
               <a:ext uri="{FF2B5EF4-FFF2-40B4-BE49-F238E27FC236}">
-                <a16:creationId xmlns:a16="http://schemas.microsoft.com/office/drawing/2014/main" id="{C408D550-9A2A-4694-8E5F-972C6F712DE1}"/>
+                <a16:creationId xmlns:a16="http://schemas.microsoft.com/office/drawing/2014/main" id="{4F4410A3-6306-4913-8068-7A619AA8AF21}"/>
               </a:ext>
             </a:extLst>
           </p:cNvPr>
@@ -5339,7 +5339,7 @@
           <p:cNvPr id="5" name="case-fact">
             <a:extLst xmlns:a="http://schemas.openxmlformats.org/drawingml/2006/main">
               <a:ext uri="{FF2B5EF4-FFF2-40B4-BE49-F238E27FC236}">
-                <a16:creationId xmlns:a16="http://schemas.microsoft.com/office/drawing/2014/main" id="{76986680-41EF-4365-A404-8F44CEF9B080}"/>
+                <a16:creationId xmlns:a16="http://schemas.microsoft.com/office/drawing/2014/main" id="{84B9C7C4-ED10-4DD2-B315-9163AD2DC4F3}"/>
               </a:ext>
             </a:extLst>
           </p:cNvPr>
@@ -5389,7 +5389,7 @@
           <p:cNvPr id="6" name="case-num-0">
             <a:extLst xmlns:a="http://schemas.openxmlformats.org/drawingml/2006/main">
               <a:ext uri="{FF2B5EF4-FFF2-40B4-BE49-F238E27FC236}">
-                <a16:creationId xmlns:a16="http://schemas.microsoft.com/office/drawing/2014/main" id="{23792836-854D-4713-B0FB-D79C3D35374C}"/>
+                <a16:creationId xmlns:a16="http://schemas.microsoft.com/office/drawing/2014/main" id="{408E90AA-53BA-41AD-9120-C40ED131CAD3}"/>
               </a:ext>
             </a:extLst>
           </p:cNvPr>
@@ -5439,7 +5439,7 @@
           <p:cNvPr id="7" name="case-title-0">
             <a:extLst xmlns:a="http://schemas.openxmlformats.org/drawingml/2006/main">
               <a:ext uri="{FF2B5EF4-FFF2-40B4-BE49-F238E27FC236}">
-                <a16:creationId xmlns:a16="http://schemas.microsoft.com/office/drawing/2014/main" id="{0C55A48B-B844-4954-ABC0-A7C9BFE9445A}"/>
+                <a16:creationId xmlns:a16="http://schemas.microsoft.com/office/drawing/2014/main" id="{D6C53855-31DA-4E79-86E5-62C50AB9D654}"/>
               </a:ext>
             </a:extLst>
           </p:cNvPr>
@@ -5489,7 +5489,7 @@
           <p:cNvPr id="8" name="case-body-0">
             <a:extLst xmlns:a="http://schemas.openxmlformats.org/drawingml/2006/main">
               <a:ext uri="{FF2B5EF4-FFF2-40B4-BE49-F238E27FC236}">
-                <a16:creationId xmlns:a16="http://schemas.microsoft.com/office/drawing/2014/main" id="{13A8EB01-B5EA-4A49-A464-B0C8F4E5CF2A}"/>
+                <a16:creationId xmlns:a16="http://schemas.microsoft.com/office/drawing/2014/main" id="{8784322B-3781-44B8-92C8-21317A9C1511}"/>
               </a:ext>
             </a:extLst>
           </p:cNvPr>
@@ -5539,7 +5539,7 @@
           <p:cNvPr id="9" name="case-rule-0">
             <a:extLst xmlns:a="http://schemas.openxmlformats.org/drawingml/2006/main">
               <a:ext uri="{FF2B5EF4-FFF2-40B4-BE49-F238E27FC236}">
-                <a16:creationId xmlns:a16="http://schemas.microsoft.com/office/drawing/2014/main" id="{1C32517C-0598-4664-969A-68F715719BF1}"/>
+                <a16:creationId xmlns:a16="http://schemas.microsoft.com/office/drawing/2014/main" id="{17B4FF45-F582-4829-8200-8EED7A071938}"/>
               </a:ext>
             </a:extLst>
           </p:cNvPr>
@@ -5572,7 +5572,7 @@
           <p:cNvPr id="10" name="case-num-1">
             <a:extLst xmlns:a="http://schemas.openxmlformats.org/drawingml/2006/main">
               <a:ext uri="{FF2B5EF4-FFF2-40B4-BE49-F238E27FC236}">
-                <a16:creationId xmlns:a16="http://schemas.microsoft.com/office/drawing/2014/main" id="{77743478-552A-49C6-AB2A-123A78A76246}"/>
+                <a16:creationId xmlns:a16="http://schemas.microsoft.com/office/drawing/2014/main" id="{4FEAAF4B-232B-449E-9E76-E9581B57D557}"/>
               </a:ext>
             </a:extLst>
           </p:cNvPr>
@@ -5622,7 +5622,7 @@
           <p:cNvPr id="11" name="case-title-1">
             <a:extLst xmlns:a="http://schemas.openxmlformats.org/drawingml/2006/main">
               <a:ext uri="{FF2B5EF4-FFF2-40B4-BE49-F238E27FC236}">
-                <a16:creationId xmlns:a16="http://schemas.microsoft.com/office/drawing/2014/main" id="{84FB45BC-4332-44C8-8DE9-B674FAA3A527}"/>
+                <a16:creationId xmlns:a16="http://schemas.microsoft.com/office/drawing/2014/main" id="{7715C675-67D0-45C2-BE4F-9C0C2AC37985}"/>
               </a:ext>
             </a:extLst>
           </p:cNvPr>
@@ -5672,7 +5672,7 @@
           <p:cNvPr id="12" name="case-body-1">
             <a:extLst xmlns:a="http://schemas.openxmlformats.org/drawingml/2006/main">
               <a:ext uri="{FF2B5EF4-FFF2-40B4-BE49-F238E27FC236}">
-                <a16:creationId xmlns:a16="http://schemas.microsoft.com/office/drawing/2014/main" id="{E610C8CE-D1B9-459F-93C5-5502AE72DF51}"/>
+                <a16:creationId xmlns:a16="http://schemas.microsoft.com/office/drawing/2014/main" id="{62F5E1EE-2EE8-43E8-9379-234ADBC414BE}"/>
               </a:ext>
             </a:extLst>
           </p:cNvPr>
@@ -5722,7 +5722,7 @@
           <p:cNvPr id="13" name="case-rule-1">
             <a:extLst xmlns:a="http://schemas.openxmlformats.org/drawingml/2006/main">
               <a:ext uri="{FF2B5EF4-FFF2-40B4-BE49-F238E27FC236}">
-                <a16:creationId xmlns:a16="http://schemas.microsoft.com/office/drawing/2014/main" id="{055DD03B-A433-4C31-826E-C65CCA79ED82}"/>
+                <a16:creationId xmlns:a16="http://schemas.microsoft.com/office/drawing/2014/main" id="{6E1756EE-4CE3-4C2C-AD4E-95D1A7E503CE}"/>
               </a:ext>
             </a:extLst>
           </p:cNvPr>
@@ -5755,7 +5755,7 @@
           <p:cNvPr id="14" name="case-num-2">
             <a:extLst xmlns:a="http://schemas.openxmlformats.org/drawingml/2006/main">
               <a:ext uri="{FF2B5EF4-FFF2-40B4-BE49-F238E27FC236}">
-                <a16:creationId xmlns:a16="http://schemas.microsoft.com/office/drawing/2014/main" id="{BDFD9CA0-E10F-4D89-A07D-4AD095F69ED5}"/>
+                <a16:creationId xmlns:a16="http://schemas.microsoft.com/office/drawing/2014/main" id="{0820911E-695D-40B4-8466-E337D90B429F}"/>
               </a:ext>
             </a:extLst>
           </p:cNvPr>
@@ -5805,7 +5805,7 @@
           <p:cNvPr id="15" name="case-title-2">
             <a:extLst xmlns:a="http://schemas.openxmlformats.org/drawingml/2006/main">
               <a:ext uri="{FF2B5EF4-FFF2-40B4-BE49-F238E27FC236}">
-                <a16:creationId xmlns:a16="http://schemas.microsoft.com/office/drawing/2014/main" id="{ABADE0EF-2DB7-41D2-A96C-F9DE14B0843D}"/>
+                <a16:creationId xmlns:a16="http://schemas.microsoft.com/office/drawing/2014/main" id="{6C6852D8-7CD4-4B5C-94AE-750EA06F1A95}"/>
               </a:ext>
             </a:extLst>
           </p:cNvPr>
@@ -5855,7 +5855,7 @@
           <p:cNvPr id="16" name="case-body-2">
             <a:extLst xmlns:a="http://schemas.openxmlformats.org/drawingml/2006/main">
               <a:ext uri="{FF2B5EF4-FFF2-40B4-BE49-F238E27FC236}">
-                <a16:creationId xmlns:a16="http://schemas.microsoft.com/office/drawing/2014/main" id="{C414E7B0-16F6-4C2C-9729-E71311A624E5}"/>
+                <a16:creationId xmlns:a16="http://schemas.microsoft.com/office/drawing/2014/main" id="{954FDAA3-5D9E-4BA6-9E36-04B827867C64}"/>
               </a:ext>
             </a:extLst>
           </p:cNvPr>
@@ -5905,7 +5905,7 @@
           <p:cNvPr id="17" name="case-caveat">
             <a:extLst xmlns:a="http://schemas.openxmlformats.org/drawingml/2006/main">
               <a:ext uri="{FF2B5EF4-FFF2-40B4-BE49-F238E27FC236}">
-                <a16:creationId xmlns:a16="http://schemas.microsoft.com/office/drawing/2014/main" id="{C3C9F64B-631B-4194-AA4C-0139D24898A8}"/>
+                <a16:creationId xmlns:a16="http://schemas.microsoft.com/office/drawing/2014/main" id="{31722133-34CC-44AF-BC09-319EA2DC4687}"/>
               </a:ext>
             </a:extLst>
           </p:cNvPr>
@@ -5953,7 +5953,7 @@
     </p:spTree>
     <p:extLst>
       <p:ext uri="{BB962C8B-B14F-4D97-AF65-F5344CB8AC3E}">
-        <p14:creationId xmlns:p14="http://schemas.microsoft.com/office/powerpoint/2010/main" val="993202352"/>
+        <p14:creationId xmlns:p14="http://schemas.microsoft.com/office/powerpoint/2010/main" val="157872095"/>
       </p:ext>
     </p:extLst>
   </p:cSld>
@@ -5984,7 +5984,7 @@
           <p:cNvPr id="11" name="kicker-6">
             <a:extLst xmlns:a="http://schemas.openxmlformats.org/drawingml/2006/main">
               <a:ext uri="{FF2B5EF4-FFF2-40B4-BE49-F238E27FC236}">
-                <a16:creationId xmlns:a16="http://schemas.microsoft.com/office/drawing/2014/main" id="{F0450538-C627-40F5-90F7-483D19F8268C}"/>
+                <a16:creationId xmlns:a16="http://schemas.microsoft.com/office/drawing/2014/main" id="{6A7D0944-4E02-4063-A41C-74817247748C}"/>
               </a:ext>
             </a:extLst>
           </p:cNvPr>
@@ -6034,7 +6034,7 @@
           <p:cNvPr id="2" name="title-6">
             <a:extLst xmlns:a="http://schemas.openxmlformats.org/drawingml/2006/main">
               <a:ext uri="{FF2B5EF4-FFF2-40B4-BE49-F238E27FC236}">
-                <a16:creationId xmlns:a16="http://schemas.microsoft.com/office/drawing/2014/main" id="{398CED1A-929B-4937-94B6-682447135B2C}"/>
+                <a16:creationId xmlns:a16="http://schemas.microsoft.com/office/drawing/2014/main" id="{1F58A9C3-D390-4695-A877-F5AD7FFFD3BF}"/>
               </a:ext>
             </a:extLst>
           </p:cNvPr>
@@ -6084,7 +6084,7 @@
           <p:cNvPr id="3" name="rule-6">
             <a:extLst xmlns:a="http://schemas.openxmlformats.org/drawingml/2006/main">
               <a:ext uri="{FF2B5EF4-FFF2-40B4-BE49-F238E27FC236}">
-                <a16:creationId xmlns:a16="http://schemas.microsoft.com/office/drawing/2014/main" id="{31CEFBF4-2E70-4448-9AC1-FE32047D49AC}"/>
+                <a16:creationId xmlns:a16="http://schemas.microsoft.com/office/drawing/2014/main" id="{919E8F12-2EC2-45AC-B322-5D9A991C9205}"/>
               </a:ext>
             </a:extLst>
           </p:cNvPr>
@@ -6117,7 +6117,7 @@
           <p:cNvPr id="4" name="page-6">
             <a:extLst xmlns:a="http://schemas.openxmlformats.org/drawingml/2006/main">
               <a:ext uri="{FF2B5EF4-FFF2-40B4-BE49-F238E27FC236}">
-                <a16:creationId xmlns:a16="http://schemas.microsoft.com/office/drawing/2014/main" id="{3DD3EA0C-83CD-4160-AF48-02C6D98B0CC8}"/>
+                <a16:creationId xmlns:a16="http://schemas.microsoft.com/office/drawing/2014/main" id="{E2A6C53B-3929-42B5-8E41-10E7877421CF}"/>
               </a:ext>
             </a:extLst>
           </p:cNvPr>
@@ -6167,7 +6167,7 @@
           <p:cNvPr id="5" name="action-frame">
             <a:extLst xmlns:a="http://schemas.openxmlformats.org/drawingml/2006/main">
               <a:ext uri="{FF2B5EF4-FFF2-40B4-BE49-F238E27FC236}">
-                <a16:creationId xmlns:a16="http://schemas.microsoft.com/office/drawing/2014/main" id="{5533DAEA-74F7-4D39-8D7F-A93BC22D87EF}"/>
+                <a16:creationId xmlns:a16="http://schemas.microsoft.com/office/drawing/2014/main" id="{760E133E-DDB3-41DA-B666-254E67C3B76D}"/>
               </a:ext>
             </a:extLst>
           </p:cNvPr>
@@ -6204,7 +6204,7 @@
           <p:nvPr/>
         </p:nvPicPr>
         <p:blipFill>
-          <a:blip xmlns:r="http://schemas.openxmlformats.org/officeDocument/2006/relationships" xmlns:a="http://schemas.openxmlformats.org/drawingml/2006/main" r:embed="R24b55eddfce84e44"/>
+          <a:blip xmlns:r="http://schemas.openxmlformats.org/officeDocument/2006/relationships" xmlns:a="http://schemas.openxmlformats.org/drawingml/2006/main" r:embed="Rd9936e20b1d64efd"/>
           <a:stretch xmlns:a="http://schemas.openxmlformats.org/drawingml/2006/main"/>
         </p:blipFill>
         <p:spPr>
@@ -6222,7 +6222,7 @@
           <p:cNvPr id="7" name="action-proof-title">
             <a:extLst xmlns:a="http://schemas.openxmlformats.org/drawingml/2006/main">
               <a:ext uri="{FF2B5EF4-FFF2-40B4-BE49-F238E27FC236}">
-                <a16:creationId xmlns:a16="http://schemas.microsoft.com/office/drawing/2014/main" id="{05651357-37AF-41E2-9C9F-218D8FFF8810}"/>
+                <a16:creationId xmlns:a16="http://schemas.microsoft.com/office/drawing/2014/main" id="{F25EFBFE-B4B0-4A06-8B90-A437D976D563}"/>
               </a:ext>
             </a:extLst>
           </p:cNvPr>
@@ -6272,7 +6272,7 @@
           <p:cNvPr id="8" name="action-proof-list">
             <a:extLst xmlns:a="http://schemas.openxmlformats.org/drawingml/2006/main">
               <a:ext uri="{FF2B5EF4-FFF2-40B4-BE49-F238E27FC236}">
-                <a16:creationId xmlns:a16="http://schemas.microsoft.com/office/drawing/2014/main" id="{9FD9CDC1-86BE-4AEE-86E4-3613958731A0}"/>
+                <a16:creationId xmlns:a16="http://schemas.microsoft.com/office/drawing/2014/main" id="{1FCDE4FB-8384-45AE-8C2D-F5BE6AE3C89F}"/>
               </a:ext>
             </a:extLst>
           </p:cNvPr>
@@ -6373,7 +6373,7 @@
           <p:cNvPr id="9" name="action-boundary-bg">
             <a:extLst xmlns:a="http://schemas.openxmlformats.org/drawingml/2006/main">
               <a:ext uri="{FF2B5EF4-FFF2-40B4-BE49-F238E27FC236}">
-                <a16:creationId xmlns:a16="http://schemas.microsoft.com/office/drawing/2014/main" id="{DF16F852-F265-4BE9-B11A-9AD79D7C4FC6}"/>
+                <a16:creationId xmlns:a16="http://schemas.microsoft.com/office/drawing/2014/main" id="{46FCE9E2-F006-48E3-8DE0-E8410EBCEF5A}"/>
               </a:ext>
             </a:extLst>
           </p:cNvPr>
@@ -6406,7 +6406,7 @@
           <p:cNvPr id="10" name="action-boundary">
             <a:extLst xmlns:a="http://schemas.openxmlformats.org/drawingml/2006/main">
               <a:ext uri="{FF2B5EF4-FFF2-40B4-BE49-F238E27FC236}">
-                <a16:creationId xmlns:a16="http://schemas.microsoft.com/office/drawing/2014/main" id="{10A2CB0C-B89A-44BE-84BD-24A417E04C0A}"/>
+                <a16:creationId xmlns:a16="http://schemas.microsoft.com/office/drawing/2014/main" id="{9B425BAF-3213-4761-93E0-4B65529502D7}"/>
               </a:ext>
             </a:extLst>
           </p:cNvPr>
@@ -6454,7 +6454,7 @@
     </p:spTree>
     <p:extLst>
       <p:ext uri="{BB962C8B-B14F-4D97-AF65-F5344CB8AC3E}">
-        <p14:creationId xmlns:p14="http://schemas.microsoft.com/office/powerpoint/2010/main" val="269558552"/>
+        <p14:creationId xmlns:p14="http://schemas.microsoft.com/office/powerpoint/2010/main" val="1823013144"/>
       </p:ext>
     </p:extLst>
   </p:cSld>
@@ -6485,7 +6485,7 @@
           <p:cNvPr id="14" name="kicker-7">
             <a:extLst xmlns:a="http://schemas.openxmlformats.org/drawingml/2006/main">
               <a:ext uri="{FF2B5EF4-FFF2-40B4-BE49-F238E27FC236}">
-                <a16:creationId xmlns:a16="http://schemas.microsoft.com/office/drawing/2014/main" id="{1CE836D3-428A-4A1F-8C9A-090522C2DF82}"/>
+                <a16:creationId xmlns:a16="http://schemas.microsoft.com/office/drawing/2014/main" id="{51B58B98-2EC6-4427-B96D-3B92D177DEE6}"/>
               </a:ext>
             </a:extLst>
           </p:cNvPr>
@@ -6535,7 +6535,7 @@
           <p:cNvPr id="2" name="title-7">
             <a:extLst xmlns:a="http://schemas.openxmlformats.org/drawingml/2006/main">
               <a:ext uri="{FF2B5EF4-FFF2-40B4-BE49-F238E27FC236}">
-                <a16:creationId xmlns:a16="http://schemas.microsoft.com/office/drawing/2014/main" id="{203C6420-6AB1-44AA-AF72-D7EBD67B7BFF}"/>
+                <a16:creationId xmlns:a16="http://schemas.microsoft.com/office/drawing/2014/main" id="{0758E86D-7C47-48AD-AA49-9D8A84901C6F}"/>
               </a:ext>
             </a:extLst>
           </p:cNvPr>
@@ -6585,7 +6585,7 @@
           <p:cNvPr id="3" name="rule-7">
             <a:extLst xmlns:a="http://schemas.openxmlformats.org/drawingml/2006/main">
               <a:ext uri="{FF2B5EF4-FFF2-40B4-BE49-F238E27FC236}">
-                <a16:creationId xmlns:a16="http://schemas.microsoft.com/office/drawing/2014/main" id="{167ABD8B-37D2-4488-AADC-A081B77D8F05}"/>
+                <a16:creationId xmlns:a16="http://schemas.microsoft.com/office/drawing/2014/main" id="{6B2C4634-F4E8-4E92-90D6-E2043664F980}"/>
               </a:ext>
             </a:extLst>
           </p:cNvPr>
@@ -6618,7 +6618,7 @@
           <p:cNvPr id="4" name="page-7">
             <a:extLst xmlns:a="http://schemas.openxmlformats.org/drawingml/2006/main">
               <a:ext uri="{FF2B5EF4-FFF2-40B4-BE49-F238E27FC236}">
-                <a16:creationId xmlns:a16="http://schemas.microsoft.com/office/drawing/2014/main" id="{7A331448-99C5-4BF6-A32B-65362D3B2AA5}"/>
+                <a16:creationId xmlns:a16="http://schemas.microsoft.com/office/drawing/2014/main" id="{5442678F-94DA-4D4D-9485-AC89FA97CEDA}"/>
               </a:ext>
             </a:extLst>
           </p:cNvPr>
@@ -6668,7 +6668,7 @@
           <p:cNvPr id="5" name="项自动化测试全部通过-value">
             <a:extLst xmlns:a="http://schemas.openxmlformats.org/drawingml/2006/main">
               <a:ext uri="{FF2B5EF4-FFF2-40B4-BE49-F238E27FC236}">
-                <a16:creationId xmlns:a16="http://schemas.microsoft.com/office/drawing/2014/main" id="{E8BCACE2-4CE5-4BB1-A610-6970ED3FAE97}"/>
+                <a16:creationId xmlns:a16="http://schemas.microsoft.com/office/drawing/2014/main" id="{B08328D5-F38B-4A10-B7F8-7E70EC90B872}"/>
               </a:ext>
             </a:extLst>
           </p:cNvPr>
@@ -6718,7 +6718,7 @@
           <p:cNvPr id="6" name="项自动化测试全部通过-label">
             <a:extLst xmlns:a="http://schemas.openxmlformats.org/drawingml/2006/main">
               <a:ext uri="{FF2B5EF4-FFF2-40B4-BE49-F238E27FC236}">
-                <a16:creationId xmlns:a16="http://schemas.microsoft.com/office/drawing/2014/main" id="{0EF06EA5-8F0B-4EA4-9584-C9F23617951F}"/>
+                <a16:creationId xmlns:a16="http://schemas.microsoft.com/office/drawing/2014/main" id="{3A107B25-6A1A-41FB-B71E-2B2818985EF8}"/>
               </a:ext>
             </a:extLst>
           </p:cNvPr>
@@ -6768,7 +6768,7 @@
           <p:cNvPr id="7" name="条核心规则完成逐条人工评测-value">
             <a:extLst xmlns:a="http://schemas.openxmlformats.org/drawingml/2006/main">
               <a:ext uri="{FF2B5EF4-FFF2-40B4-BE49-F238E27FC236}">
-                <a16:creationId xmlns:a16="http://schemas.microsoft.com/office/drawing/2014/main" id="{71308D2F-4DED-4A05-8149-16C4F12FC406}"/>
+                <a16:creationId xmlns:a16="http://schemas.microsoft.com/office/drawing/2014/main" id="{B858E5F3-4136-4F86-B799-FCE992926A04}"/>
               </a:ext>
             </a:extLst>
           </p:cNvPr>
@@ -6818,7 +6818,7 @@
           <p:cNvPr id="8" name="条核心规则完成逐条人工评测-label">
             <a:extLst xmlns:a="http://schemas.openxmlformats.org/drawingml/2006/main">
               <a:ext uri="{FF2B5EF4-FFF2-40B4-BE49-F238E27FC236}">
-                <a16:creationId xmlns:a16="http://schemas.microsoft.com/office/drawing/2014/main" id="{60A93328-18BE-4B11-B1FD-48A7761CF17F}"/>
+                <a16:creationId xmlns:a16="http://schemas.microsoft.com/office/drawing/2014/main" id="{1D63278C-C285-4BA5-8524-BFC2F610572E}"/>
               </a:ext>
             </a:extLst>
           </p:cNvPr>
@@ -6868,7 +6868,7 @@
           <p:cNvPr id="9" name="次 DeepSeek 真实调用并人工复核-value">
             <a:extLst xmlns:a="http://schemas.openxmlformats.org/drawingml/2006/main">
               <a:ext uri="{FF2B5EF4-FFF2-40B4-BE49-F238E27FC236}">
-                <a16:creationId xmlns:a16="http://schemas.microsoft.com/office/drawing/2014/main" id="{876CDB9E-5F02-4C3A-9DAE-4E5B5C99DFA1}"/>
+                <a16:creationId xmlns:a16="http://schemas.microsoft.com/office/drawing/2014/main" id="{DEAD1A6B-E7A2-4D26-A509-91CF5B8D12D1}"/>
               </a:ext>
             </a:extLst>
           </p:cNvPr>
@@ -6918,7 +6918,7 @@
           <p:cNvPr id="10" name="次 DeepSeek 真实调用并人工复核-label">
             <a:extLst xmlns:a="http://schemas.openxmlformats.org/drawingml/2006/main">
               <a:ext uri="{FF2B5EF4-FFF2-40B4-BE49-F238E27FC236}">
-                <a16:creationId xmlns:a16="http://schemas.microsoft.com/office/drawing/2014/main" id="{EC260741-64B4-4099-8FC3-66D961D5E06F}"/>
+                <a16:creationId xmlns:a16="http://schemas.microsoft.com/office/drawing/2014/main" id="{C2079F95-205F-4032-9462-C789167D825B}"/>
               </a:ext>
             </a:extLst>
           </p:cNvPr>
@@ -6968,7 +6968,7 @@
           <p:cNvPr id="11" name="eval-rule">
             <a:extLst xmlns:a="http://schemas.openxmlformats.org/drawingml/2006/main">
               <a:ext uri="{FF2B5EF4-FFF2-40B4-BE49-F238E27FC236}">
-                <a16:creationId xmlns:a16="http://schemas.microsoft.com/office/drawing/2014/main" id="{E5396F1B-378E-4AA4-8931-3A6EFF451199}"/>
+                <a16:creationId xmlns:a16="http://schemas.microsoft.com/office/drawing/2014/main" id="{1F4053CC-E8E1-4A62-8235-660C312D7DC5}"/>
               </a:ext>
             </a:extLst>
           </p:cNvPr>
@@ -7001,7 +7001,7 @@
           <p:cNvPr id="12" name="eval-boundary-title">
             <a:extLst xmlns:a="http://schemas.openxmlformats.org/drawingml/2006/main">
               <a:ext uri="{FF2B5EF4-FFF2-40B4-BE49-F238E27FC236}">
-                <a16:creationId xmlns:a16="http://schemas.microsoft.com/office/drawing/2014/main" id="{76485EE4-1481-4709-9952-EFA101D587D2}"/>
+                <a16:creationId xmlns:a16="http://schemas.microsoft.com/office/drawing/2014/main" id="{EDF99AED-5EB0-4C14-AA75-D753066DA14B}"/>
               </a:ext>
             </a:extLst>
           </p:cNvPr>
@@ -7051,7 +7051,7 @@
           <p:cNvPr id="13" name="eval-boundary">
             <a:extLst xmlns:a="http://schemas.openxmlformats.org/drawingml/2006/main">
               <a:ext uri="{FF2B5EF4-FFF2-40B4-BE49-F238E27FC236}">
-                <a16:creationId xmlns:a16="http://schemas.microsoft.com/office/drawing/2014/main" id="{E1AD19A3-ED42-489C-A5CA-B0654CE6AEF1}"/>
+                <a16:creationId xmlns:a16="http://schemas.microsoft.com/office/drawing/2014/main" id="{76AA5F88-6024-4358-97D2-D90C0D3FA5D6}"/>
               </a:ext>
             </a:extLst>
           </p:cNvPr>
@@ -7133,7 +7133,7 @@
     </p:spTree>
     <p:extLst>
       <p:ext uri="{BB962C8B-B14F-4D97-AF65-F5344CB8AC3E}">
-        <p14:creationId xmlns:p14="http://schemas.microsoft.com/office/powerpoint/2010/main" val="500358765"/>
+        <p14:creationId xmlns:p14="http://schemas.microsoft.com/office/powerpoint/2010/main" val="1752237338"/>
       </p:ext>
     </p:extLst>
   </p:cSld>
@@ -7164,7 +7164,7 @@
           <p:cNvPr id="43" name="kicker-8">
             <a:extLst xmlns:a="http://schemas.openxmlformats.org/drawingml/2006/main">
               <a:ext uri="{FF2B5EF4-FFF2-40B4-BE49-F238E27FC236}">
-                <a16:creationId xmlns:a16="http://schemas.microsoft.com/office/drawing/2014/main" id="{8A762F7F-94E2-4CF0-9C73-2D3EFEC51F1E}"/>
+                <a16:creationId xmlns:a16="http://schemas.microsoft.com/office/drawing/2014/main" id="{1FBB1289-F6F8-4BE8-8EB5-3E0D3F17829F}"/>
               </a:ext>
             </a:extLst>
           </p:cNvPr>
@@ -7214,7 +7214,7 @@
           <p:cNvPr id="2" name="title-8">
             <a:extLst xmlns:a="http://schemas.openxmlformats.org/drawingml/2006/main">
               <a:ext uri="{FF2B5EF4-FFF2-40B4-BE49-F238E27FC236}">
-                <a16:creationId xmlns:a16="http://schemas.microsoft.com/office/drawing/2014/main" id="{EE638017-0185-42C2-BDCA-EA1A3BE32D62}"/>
+                <a16:creationId xmlns:a16="http://schemas.microsoft.com/office/drawing/2014/main" id="{CDBE6948-9CA7-43C2-B3E6-2D0B71D624CD}"/>
               </a:ext>
             </a:extLst>
           </p:cNvPr>
@@ -7264,7 +7264,7 @@
           <p:cNvPr id="3" name="rule-8">
             <a:extLst xmlns:a="http://schemas.openxmlformats.org/drawingml/2006/main">
               <a:ext uri="{FF2B5EF4-FFF2-40B4-BE49-F238E27FC236}">
-                <a16:creationId xmlns:a16="http://schemas.microsoft.com/office/drawing/2014/main" id="{295FDD28-E484-4141-A5A6-728CE57B24A9}"/>
+                <a16:creationId xmlns:a16="http://schemas.microsoft.com/office/drawing/2014/main" id="{A51AC5A2-36E3-4BC9-A9C7-796BD05DE145}"/>
               </a:ext>
             </a:extLst>
           </p:cNvPr>
@@ -7297,7 +7297,7 @@
           <p:cNvPr id="4" name="page-8">
             <a:extLst xmlns:a="http://schemas.openxmlformats.org/drawingml/2006/main">
               <a:ext uri="{FF2B5EF4-FFF2-40B4-BE49-F238E27FC236}">
-                <a16:creationId xmlns:a16="http://schemas.microsoft.com/office/drawing/2014/main" id="{F0366FE3-C19B-48EE-AC9E-43290113951E}"/>
+                <a16:creationId xmlns:a16="http://schemas.microsoft.com/office/drawing/2014/main" id="{C7054B2A-6710-4542-B74F-C5CC41EF78EF}"/>
               </a:ext>
             </a:extLst>
           </p:cNvPr>
@@ -7347,7 +7347,7 @@
           <p:cNvPr id="5" name="compare-head">
             <a:extLst xmlns:a="http://schemas.openxmlformats.org/drawingml/2006/main">
               <a:ext uri="{FF2B5EF4-FFF2-40B4-BE49-F238E27FC236}">
-                <a16:creationId xmlns:a16="http://schemas.microsoft.com/office/drawing/2014/main" id="{F4A46F5F-5C26-43A1-B807-B9F1086C1587}"/>
+                <a16:creationId xmlns:a16="http://schemas.microsoft.com/office/drawing/2014/main" id="{1CB2FB36-F764-4F7F-A227-09BB0EA80152}"/>
               </a:ext>
             </a:extLst>
           </p:cNvPr>
@@ -7380,7 +7380,7 @@
           <p:cNvPr id="6" name="compare-head-0">
             <a:extLst xmlns:a="http://schemas.openxmlformats.org/drawingml/2006/main">
               <a:ext uri="{FF2B5EF4-FFF2-40B4-BE49-F238E27FC236}">
-                <a16:creationId xmlns:a16="http://schemas.microsoft.com/office/drawing/2014/main" id="{C08566F5-E085-4AB4-B50C-1608FDBA466F}"/>
+                <a16:creationId xmlns:a16="http://schemas.microsoft.com/office/drawing/2014/main" id="{EACD0671-F4F5-4130-A43B-2899BF7350BD}"/>
               </a:ext>
             </a:extLst>
           </p:cNvPr>
@@ -7430,7 +7430,7 @@
           <p:cNvPr id="7" name="compare-head-1">
             <a:extLst xmlns:a="http://schemas.openxmlformats.org/drawingml/2006/main">
               <a:ext uri="{FF2B5EF4-FFF2-40B4-BE49-F238E27FC236}">
-                <a16:creationId xmlns:a16="http://schemas.microsoft.com/office/drawing/2014/main" id="{FC0F0482-14A0-4099-B874-CBE0ED13A261}"/>
+                <a16:creationId xmlns:a16="http://schemas.microsoft.com/office/drawing/2014/main" id="{4ED79F5B-CFBF-487E-90A2-15A64A3BD6D0}"/>
               </a:ext>
             </a:extLst>
           </p:cNvPr>
@@ -7480,7 +7480,7 @@
           <p:cNvPr id="8" name="compare-head-2">
             <a:extLst xmlns:a="http://schemas.openxmlformats.org/drawingml/2006/main">
               <a:ext uri="{FF2B5EF4-FFF2-40B4-BE49-F238E27FC236}">
-                <a16:creationId xmlns:a16="http://schemas.microsoft.com/office/drawing/2014/main" id="{3D2D766C-A838-4A1B-A98F-024D380506A6}"/>
+                <a16:creationId xmlns:a16="http://schemas.microsoft.com/office/drawing/2014/main" id="{2D6B9A8F-14F0-43CE-B48F-C71AA01A4E67}"/>
               </a:ext>
             </a:extLst>
           </p:cNvPr>
@@ -7530,7 +7530,7 @@
           <p:cNvPr id="9" name="compare-head-3">
             <a:extLst xmlns:a="http://schemas.openxmlformats.org/drawingml/2006/main">
               <a:ext uri="{FF2B5EF4-FFF2-40B4-BE49-F238E27FC236}">
-                <a16:creationId xmlns:a16="http://schemas.microsoft.com/office/drawing/2014/main" id="{38FF4682-BEB6-4166-8728-69186D658679}"/>
+                <a16:creationId xmlns:a16="http://schemas.microsoft.com/office/drawing/2014/main" id="{5C25AFFE-9F48-4719-B09B-9AE4C137C1BA}"/>
               </a:ext>
             </a:extLst>
           </p:cNvPr>
@@ -7580,7 +7580,7 @@
           <p:cNvPr id="10" name="compare-head-4">
             <a:extLst xmlns:a="http://schemas.openxmlformats.org/drawingml/2006/main">
               <a:ext uri="{FF2B5EF4-FFF2-40B4-BE49-F238E27FC236}">
-                <a16:creationId xmlns:a16="http://schemas.microsoft.com/office/drawing/2014/main" id="{A52E28F6-DD79-4D43-96A4-B89DD211C30F}"/>
+                <a16:creationId xmlns:a16="http://schemas.microsoft.com/office/drawing/2014/main" id="{DFA2E3FB-962E-4AC8-ADC6-A2BEB829D6DE}"/>
               </a:ext>
             </a:extLst>
           </p:cNvPr>
@@ -7630,7 +7630,7 @@
           <p:cNvPr id="11" name="compare-row-0">
             <a:extLst xmlns:a="http://schemas.openxmlformats.org/drawingml/2006/main">
               <a:ext uri="{FF2B5EF4-FFF2-40B4-BE49-F238E27FC236}">
-                <a16:creationId xmlns:a16="http://schemas.microsoft.com/office/drawing/2014/main" id="{79A8854F-9685-4CC2-BF98-8258F019777E}"/>
+                <a16:creationId xmlns:a16="http://schemas.microsoft.com/office/drawing/2014/main" id="{3039600D-B22C-4165-A3A0-79DBD93C7A59}"/>
               </a:ext>
             </a:extLst>
           </p:cNvPr>
@@ -7663,7 +7663,7 @@
           <p:cNvPr id="12" name="compare-0-0">
             <a:extLst xmlns:a="http://schemas.openxmlformats.org/drawingml/2006/main">
               <a:ext uri="{FF2B5EF4-FFF2-40B4-BE49-F238E27FC236}">
-                <a16:creationId xmlns:a16="http://schemas.microsoft.com/office/drawing/2014/main" id="{95542DF2-3B19-4C60-B3F4-E8DC8064D609}"/>
+                <a16:creationId xmlns:a16="http://schemas.microsoft.com/office/drawing/2014/main" id="{39E2521E-003E-4F66-BB72-D37AA06875F6}"/>
               </a:ext>
             </a:extLst>
           </p:cNvPr>
@@ -7713,7 +7713,7 @@
           <p:cNvPr id="13" name="compare-0-1">
             <a:extLst xmlns:a="http://schemas.openxmlformats.org/drawingml/2006/main">
               <a:ext uri="{FF2B5EF4-FFF2-40B4-BE49-F238E27FC236}">
-                <a16:creationId xmlns:a16="http://schemas.microsoft.com/office/drawing/2014/main" id="{287DF087-7CC5-416A-A519-D85C86D1C8D6}"/>
+                <a16:creationId xmlns:a16="http://schemas.microsoft.com/office/drawing/2014/main" id="{73C2D40D-8D94-4A3F-A74D-D93343BC6DF3}"/>
               </a:ext>
             </a:extLst>
           </p:cNvPr>
@@ -7763,7 +7763,7 @@
           <p:cNvPr id="14" name="compare-0-2">
             <a:extLst xmlns:a="http://schemas.openxmlformats.org/drawingml/2006/main">
               <a:ext uri="{FF2B5EF4-FFF2-40B4-BE49-F238E27FC236}">
-                <a16:creationId xmlns:a16="http://schemas.microsoft.com/office/drawing/2014/main" id="{B9559B1B-0E91-41CC-99E5-5ADA0356E6FC}"/>
+                <a16:creationId xmlns:a16="http://schemas.microsoft.com/office/drawing/2014/main" id="{EA378B8B-1C86-4814-BCC3-27E42C2554E6}"/>
               </a:ext>
             </a:extLst>
           </p:cNvPr>
@@ -7813,7 +7813,7 @@
           <p:cNvPr id="15" name="compare-0-3">
             <a:extLst xmlns:a="http://schemas.openxmlformats.org/drawingml/2006/main">
               <a:ext uri="{FF2B5EF4-FFF2-40B4-BE49-F238E27FC236}">
-                <a16:creationId xmlns:a16="http://schemas.microsoft.com/office/drawing/2014/main" id="{D07CB117-AD8D-46EE-A490-CB8F27D30F7A}"/>
+                <a16:creationId xmlns:a16="http://schemas.microsoft.com/office/drawing/2014/main" id="{FDB189B2-6CD3-4F4E-AA89-174BD22979AD}"/>
               </a:ext>
             </a:extLst>
           </p:cNvPr>
@@ -7863,7 +7863,7 @@
           <p:cNvPr id="16" name="compare-0-4">
             <a:extLst xmlns:a="http://schemas.openxmlformats.org/drawingml/2006/main">
               <a:ext uri="{FF2B5EF4-FFF2-40B4-BE49-F238E27FC236}">
-                <a16:creationId xmlns:a16="http://schemas.microsoft.com/office/drawing/2014/main" id="{D84856D3-FF3B-48E3-84F8-D73C0535AFC5}"/>
+                <a16:creationId xmlns:a16="http://schemas.microsoft.com/office/drawing/2014/main" id="{A057E914-CEB8-4467-A056-6BF27C4CF6BA}"/>
               </a:ext>
             </a:extLst>
           </p:cNvPr>
@@ -7913,7 +7913,7 @@
           <p:cNvPr id="17" name="compare-row-1">
             <a:extLst xmlns:a="http://schemas.openxmlformats.org/drawingml/2006/main">
               <a:ext uri="{FF2B5EF4-FFF2-40B4-BE49-F238E27FC236}">
-                <a16:creationId xmlns:a16="http://schemas.microsoft.com/office/drawing/2014/main" id="{755FDA11-5D5C-4F9A-928B-4F2A6701ED52}"/>
+                <a16:creationId xmlns:a16="http://schemas.microsoft.com/office/drawing/2014/main" id="{D8061156-AA9E-4DD0-A661-CBD71A59F059}"/>
               </a:ext>
             </a:extLst>
           </p:cNvPr>
@@ -7946,7 +7946,7 @@
           <p:cNvPr id="18" name="compare-1-0">
             <a:extLst xmlns:a="http://schemas.openxmlformats.org/drawingml/2006/main">
               <a:ext uri="{FF2B5EF4-FFF2-40B4-BE49-F238E27FC236}">
-                <a16:creationId xmlns:a16="http://schemas.microsoft.com/office/drawing/2014/main" id="{E06A1A72-3044-4B84-BEAA-23D7164C89A2}"/>
+                <a16:creationId xmlns:a16="http://schemas.microsoft.com/office/drawing/2014/main" id="{656FDAAE-3BE1-4961-B712-5EABECECC074}"/>
               </a:ext>
             </a:extLst>
           </p:cNvPr>
@@ -7996,7 +7996,7 @@
           <p:cNvPr id="19" name="compare-1-1">
             <a:extLst xmlns:a="http://schemas.openxmlformats.org/drawingml/2006/main">
               <a:ext uri="{FF2B5EF4-FFF2-40B4-BE49-F238E27FC236}">
-                <a16:creationId xmlns:a16="http://schemas.microsoft.com/office/drawing/2014/main" id="{570B8D29-AF3C-4C14-8FE1-7196B7B7D387}"/>
+                <a16:creationId xmlns:a16="http://schemas.microsoft.com/office/drawing/2014/main" id="{762C5F63-61F8-4435-B572-7DD10B5B9954}"/>
               </a:ext>
             </a:extLst>
           </p:cNvPr>
@@ -8046,7 +8046,7 @@
           <p:cNvPr id="20" name="compare-1-2">
             <a:extLst xmlns:a="http://schemas.openxmlformats.org/drawingml/2006/main">
               <a:ext uri="{FF2B5EF4-FFF2-40B4-BE49-F238E27FC236}">
-                <a16:creationId xmlns:a16="http://schemas.microsoft.com/office/drawing/2014/main" id="{C0217A28-F8E9-47AB-B81C-35FDEF927A87}"/>
+                <a16:creationId xmlns:a16="http://schemas.microsoft.com/office/drawing/2014/main" id="{A4A7B22B-0AEF-4756-8C68-6E57F4CF02BD}"/>
               </a:ext>
             </a:extLst>
           </p:cNvPr>
@@ -8096,7 +8096,7 @@
           <p:cNvPr id="21" name="compare-1-3">
             <a:extLst xmlns:a="http://schemas.openxmlformats.org/drawingml/2006/main">
               <a:ext uri="{FF2B5EF4-FFF2-40B4-BE49-F238E27FC236}">
-                <a16:creationId xmlns:a16="http://schemas.microsoft.com/office/drawing/2014/main" id="{AA3DBEF4-8F16-4B5F-9DC5-06A3DADEA5C0}"/>
+                <a16:creationId xmlns:a16="http://schemas.microsoft.com/office/drawing/2014/main" id="{0E06DF14-F05C-4A25-B556-381A7ECE8D61}"/>
               </a:ext>
             </a:extLst>
           </p:cNvPr>
@@ -8146,7 +8146,7 @@
           <p:cNvPr id="22" name="compare-1-4">
             <a:extLst xmlns:a="http://schemas.openxmlformats.org/drawingml/2006/main">
               <a:ext uri="{FF2B5EF4-FFF2-40B4-BE49-F238E27FC236}">
-                <a16:creationId xmlns:a16="http://schemas.microsoft.com/office/drawing/2014/main" id="{AB77EEC2-9C73-44D9-8BC6-B5E18E2C2887}"/>
+                <a16:creationId xmlns:a16="http://schemas.microsoft.com/office/drawing/2014/main" id="{35FCB513-8AB3-4DA4-8809-28CEC3EE1FBC}"/>
               </a:ext>
             </a:extLst>
           </p:cNvPr>
@@ -8196,7 +8196,7 @@
           <p:cNvPr id="23" name="compare-row-2">
             <a:extLst xmlns:a="http://schemas.openxmlformats.org/drawingml/2006/main">
               <a:ext uri="{FF2B5EF4-FFF2-40B4-BE49-F238E27FC236}">
-                <a16:creationId xmlns:a16="http://schemas.microsoft.com/office/drawing/2014/main" id="{204338CD-F80A-402E-A9FF-FF96E94B6744}"/>
+                <a16:creationId xmlns:a16="http://schemas.microsoft.com/office/drawing/2014/main" id="{FBE2AC4D-93D2-42AB-A9C5-50504A8FAC02}"/>
               </a:ext>
             </a:extLst>
           </p:cNvPr>
@@ -8229,7 +8229,7 @@
           <p:cNvPr id="24" name="compare-2-0">
             <a:extLst xmlns:a="http://schemas.openxmlformats.org/drawingml/2006/main">
               <a:ext uri="{FF2B5EF4-FFF2-40B4-BE49-F238E27FC236}">
-                <a16:creationId xmlns:a16="http://schemas.microsoft.com/office/drawing/2014/main" id="{C7FE733F-F6CC-46DE-9FCD-F3FF91BEB247}"/>
+                <a16:creationId xmlns:a16="http://schemas.microsoft.com/office/drawing/2014/main" id="{B3319301-7EC1-4DED-9C16-7E90260DA26D}"/>
               </a:ext>
             </a:extLst>
           </p:cNvPr>
@@ -8279,7 +8279,7 @@
           <p:cNvPr id="25" name="compare-2-1">
             <a:extLst xmlns:a="http://schemas.openxmlformats.org/drawingml/2006/main">
               <a:ext uri="{FF2B5EF4-FFF2-40B4-BE49-F238E27FC236}">
-                <a16:creationId xmlns:a16="http://schemas.microsoft.com/office/drawing/2014/main" id="{FFA34043-332D-462F-82E7-0F42826402A6}"/>
+                <a16:creationId xmlns:a16="http://schemas.microsoft.com/office/drawing/2014/main" id="{FD22CAD1-1399-4D30-A4C5-A9100182B10E}"/>
               </a:ext>
             </a:extLst>
           </p:cNvPr>
@@ -8329,7 +8329,7 @@
           <p:cNvPr id="26" name="compare-2-2">
             <a:extLst xmlns:a="http://schemas.openxmlformats.org/drawingml/2006/main">
               <a:ext uri="{FF2B5EF4-FFF2-40B4-BE49-F238E27FC236}">
-                <a16:creationId xmlns:a16="http://schemas.microsoft.com/office/drawing/2014/main" id="{66A1E856-69E3-48BC-AC28-A3D99DB9018E}"/>
+                <a16:creationId xmlns:a16="http://schemas.microsoft.com/office/drawing/2014/main" id="{F5FE9F8B-9B5F-4ACE-A3E2-4FA7B8C158D2}"/>
               </a:ext>
             </a:extLst>
           </p:cNvPr>
@@ -8379,7 +8379,7 @@
           <p:cNvPr id="27" name="compare-2-3">
             <a:extLst xmlns:a="http://schemas.openxmlformats.org/drawingml/2006/main">
               <a:ext uri="{FF2B5EF4-FFF2-40B4-BE49-F238E27FC236}">
-                <a16:creationId xmlns:a16="http://schemas.microsoft.com/office/drawing/2014/main" id="{9CE8A0F8-3E1A-4D89-8BB2-D7F49FD44D91}"/>
+                <a16:creationId xmlns:a16="http://schemas.microsoft.com/office/drawing/2014/main" id="{249B989A-85DB-4106-BA8A-10AF7D99B6AE}"/>
               </a:ext>
             </a:extLst>
           </p:cNvPr>
@@ -8429,7 +8429,7 @@
           <p:cNvPr id="28" name="compare-2-4">
             <a:extLst xmlns:a="http://schemas.openxmlformats.org/drawingml/2006/main">
               <a:ext uri="{FF2B5EF4-FFF2-40B4-BE49-F238E27FC236}">
-                <a16:creationId xmlns:a16="http://schemas.microsoft.com/office/drawing/2014/main" id="{F674D149-20F9-4CB3-87ED-555FD175B257}"/>
+                <a16:creationId xmlns:a16="http://schemas.microsoft.com/office/drawing/2014/main" id="{020279BD-B88B-411C-B887-1C2F7A198D8A}"/>
               </a:ext>
             </a:extLst>
           </p:cNvPr>
@@ -8479,7 +8479,7 @@
           <p:cNvPr id="29" name="compare-row-3">
             <a:extLst xmlns:a="http://schemas.openxmlformats.org/drawingml/2006/main">
               <a:ext uri="{FF2B5EF4-FFF2-40B4-BE49-F238E27FC236}">
-                <a16:creationId xmlns:a16="http://schemas.microsoft.com/office/drawing/2014/main" id="{183FA15E-C016-4228-A7BA-708059D24DFE}"/>
+                <a16:creationId xmlns:a16="http://schemas.microsoft.com/office/drawing/2014/main" id="{37C7A471-0599-4D00-8C3D-6841D4EF3B2E}"/>
               </a:ext>
             </a:extLst>
           </p:cNvPr>
@@ -8512,7 +8512,7 @@
           <p:cNvPr id="30" name="compare-3-0">
             <a:extLst xmlns:a="http://schemas.openxmlformats.org/drawingml/2006/main">
               <a:ext uri="{FF2B5EF4-FFF2-40B4-BE49-F238E27FC236}">
-                <a16:creationId xmlns:a16="http://schemas.microsoft.com/office/drawing/2014/main" id="{8FDB1BC1-4DDA-4881-A9BF-66AB2E83EA7F}"/>
+                <a16:creationId xmlns:a16="http://schemas.microsoft.com/office/drawing/2014/main" id="{2DF9FD37-657C-4BEE-A074-D2C5BE36F77C}"/>
               </a:ext>
             </a:extLst>
           </p:cNvPr>
@@ -8562,7 +8562,7 @@
           <p:cNvPr id="31" name="compare-3-1">
             <a:extLst xmlns:a="http://schemas.openxmlformats.org/drawingml/2006/main">
               <a:ext uri="{FF2B5EF4-FFF2-40B4-BE49-F238E27FC236}">
-                <a16:creationId xmlns:a16="http://schemas.microsoft.com/office/drawing/2014/main" id="{513A0F82-AE61-4916-9178-D14DD59B8791}"/>
+                <a16:creationId xmlns:a16="http://schemas.microsoft.com/office/drawing/2014/main" id="{7113BE46-1DE0-4A24-9500-98230B37A95B}"/>
               </a:ext>
             </a:extLst>
           </p:cNvPr>
@@ -8612,7 +8612,7 @@
           <p:cNvPr id="32" name="compare-3-2">
             <a:extLst xmlns:a="http://schemas.openxmlformats.org/drawingml/2006/main">
               <a:ext uri="{FF2B5EF4-FFF2-40B4-BE49-F238E27FC236}">
-                <a16:creationId xmlns:a16="http://schemas.microsoft.com/office/drawing/2014/main" id="{480F9302-A2D6-4E00-B03D-BDF4C8937C1F}"/>
+                <a16:creationId xmlns:a16="http://schemas.microsoft.com/office/drawing/2014/main" id="{DF75CC2A-81F7-45BB-8741-BCB92BE8471C}"/>
               </a:ext>
             </a:extLst>
           </p:cNvPr>
@@ -8662,7 +8662,7 @@
           <p:cNvPr id="33" name="compare-3-3">
             <a:extLst xmlns:a="http://schemas.openxmlformats.org/drawingml/2006/main">
               <a:ext uri="{FF2B5EF4-FFF2-40B4-BE49-F238E27FC236}">
-                <a16:creationId xmlns:a16="http://schemas.microsoft.com/office/drawing/2014/main" id="{95BDBD35-C144-45D6-BA11-C2DA2CF6FEAA}"/>
+                <a16:creationId xmlns:a16="http://schemas.microsoft.com/office/drawing/2014/main" id="{B7A8B7D3-2565-43D4-AE9D-28EAD28E4607}"/>
               </a:ext>
             </a:extLst>
           </p:cNvPr>
@@ -8712,7 +8712,7 @@
           <p:cNvPr id="34" name="compare-3-4">
             <a:extLst xmlns:a="http://schemas.openxmlformats.org/drawingml/2006/main">
               <a:ext uri="{FF2B5EF4-FFF2-40B4-BE49-F238E27FC236}">
-                <a16:creationId xmlns:a16="http://schemas.microsoft.com/office/drawing/2014/main" id="{2403F273-B327-4945-B635-E5A9892F2C8C}"/>
+                <a16:creationId xmlns:a16="http://schemas.microsoft.com/office/drawing/2014/main" id="{CF732761-C73D-4551-8BB1-0A6FB5C32473}"/>
               </a:ext>
             </a:extLst>
           </p:cNvPr>
@@ -8762,7 +8762,7 @@
           <p:cNvPr id="35" name="compare-row-4">
             <a:extLst xmlns:a="http://schemas.openxmlformats.org/drawingml/2006/main">
               <a:ext uri="{FF2B5EF4-FFF2-40B4-BE49-F238E27FC236}">
-                <a16:creationId xmlns:a16="http://schemas.microsoft.com/office/drawing/2014/main" id="{52FC0A3A-8057-4E27-856D-621B6B39ED5D}"/>
+                <a16:creationId xmlns:a16="http://schemas.microsoft.com/office/drawing/2014/main" id="{6F69721B-4311-4CE2-945B-B8124F287EA3}"/>
               </a:ext>
             </a:extLst>
           </p:cNvPr>
@@ -8795,7 +8795,7 @@
           <p:cNvPr id="36" name="compare-4-0">
             <a:extLst xmlns:a="http://schemas.openxmlformats.org/drawingml/2006/main">
               <a:ext uri="{FF2B5EF4-FFF2-40B4-BE49-F238E27FC236}">
-                <a16:creationId xmlns:a16="http://schemas.microsoft.com/office/drawing/2014/main" id="{733D4D0C-598D-4952-AE8B-22B7F6096D65}"/>
+                <a16:creationId xmlns:a16="http://schemas.microsoft.com/office/drawing/2014/main" id="{85C8E1C6-644B-43EF-B2E4-7DE7606BD3FB}"/>
               </a:ext>
             </a:extLst>
           </p:cNvPr>
@@ -8845,7 +8845,7 @@
           <p:cNvPr id="37" name="compare-4-1">
             <a:extLst xmlns:a="http://schemas.openxmlformats.org/drawingml/2006/main">
               <a:ext uri="{FF2B5EF4-FFF2-40B4-BE49-F238E27FC236}">
-                <a16:creationId xmlns:a16="http://schemas.microsoft.com/office/drawing/2014/main" id="{975DD16E-5646-4B46-82D1-DD8CFA2238C0}"/>
+                <a16:creationId xmlns:a16="http://schemas.microsoft.com/office/drawing/2014/main" id="{7F8FC10F-0765-4D02-8174-3C49FF15701F}"/>
               </a:ext>
             </a:extLst>
           </p:cNvPr>
@@ -8895,7 +8895,7 @@
           <p:cNvPr id="38" name="compare-4-2">
             <a:extLst xmlns:a="http://schemas.openxmlformats.org/drawingml/2006/main">
               <a:ext uri="{FF2B5EF4-FFF2-40B4-BE49-F238E27FC236}">
-                <a16:creationId xmlns:a16="http://schemas.microsoft.com/office/drawing/2014/main" id="{66868ED3-267B-41CE-8FB3-70E1F85119E0}"/>
+                <a16:creationId xmlns:a16="http://schemas.microsoft.com/office/drawing/2014/main" id="{646B4A0A-A4E3-42A8-ABCE-3DEBE5A57381}"/>
               </a:ext>
             </a:extLst>
           </p:cNvPr>
@@ -8945,7 +8945,7 @@
           <p:cNvPr id="39" name="compare-4-3">
             <a:extLst xmlns:a="http://schemas.openxmlformats.org/drawingml/2006/main">
               <a:ext uri="{FF2B5EF4-FFF2-40B4-BE49-F238E27FC236}">
-                <a16:creationId xmlns:a16="http://schemas.microsoft.com/office/drawing/2014/main" id="{5FBB4BA2-3E12-49A6-BC46-C3E09A24FD96}"/>
+                <a16:creationId xmlns:a16="http://schemas.microsoft.com/office/drawing/2014/main" id="{05F8EB46-4016-4AFF-9A81-DDBDCFD4A092}"/>
               </a:ext>
             </a:extLst>
           </p:cNvPr>
@@ -8995,7 +8995,7 @@
           <p:cNvPr id="40" name="compare-4-4">
             <a:extLst xmlns:a="http://schemas.openxmlformats.org/drawingml/2006/main">
               <a:ext uri="{FF2B5EF4-FFF2-40B4-BE49-F238E27FC236}">
-                <a16:creationId xmlns:a16="http://schemas.microsoft.com/office/drawing/2014/main" id="{5C5CE5A2-7F1C-4C96-A91A-21100E2F9F6C}"/>
+                <a16:creationId xmlns:a16="http://schemas.microsoft.com/office/drawing/2014/main" id="{AFB0BAEB-8B84-429A-BA68-8602C1C89BB3}"/>
               </a:ext>
             </a:extLst>
           </p:cNvPr>
@@ -9045,7 +9045,7 @@
           <p:cNvPr id="41" name="compare-takeaway-bg">
             <a:extLst xmlns:a="http://schemas.openxmlformats.org/drawingml/2006/main">
               <a:ext uri="{FF2B5EF4-FFF2-40B4-BE49-F238E27FC236}">
-                <a16:creationId xmlns:a16="http://schemas.microsoft.com/office/drawing/2014/main" id="{247E6066-FECF-4214-A31A-148A2800D68F}"/>
+                <a16:creationId xmlns:a16="http://schemas.microsoft.com/office/drawing/2014/main" id="{051E0383-B5C8-4975-AB12-C27525B1F879}"/>
               </a:ext>
             </a:extLst>
           </p:cNvPr>
@@ -9078,7 +9078,7 @@
           <p:cNvPr id="42" name="compare-takeaway">
             <a:extLst xmlns:a="http://schemas.openxmlformats.org/drawingml/2006/main">
               <a:ext uri="{FF2B5EF4-FFF2-40B4-BE49-F238E27FC236}">
-                <a16:creationId xmlns:a16="http://schemas.microsoft.com/office/drawing/2014/main" id="{31BAF3B6-164E-4CD1-8E9E-5E2C4A5C3623}"/>
+                <a16:creationId xmlns:a16="http://schemas.microsoft.com/office/drawing/2014/main" id="{F7503380-D23F-47DF-AD20-848E50B2CEDE}"/>
               </a:ext>
             </a:extLst>
           </p:cNvPr>
@@ -9126,7 +9126,7 @@
     </p:spTree>
     <p:extLst>
       <p:ext uri="{BB962C8B-B14F-4D97-AF65-F5344CB8AC3E}">
-        <p14:creationId xmlns:p14="http://schemas.microsoft.com/office/powerpoint/2010/main" val="1280338818"/>
+        <p14:creationId xmlns:p14="http://schemas.microsoft.com/office/powerpoint/2010/main" val="1141723009"/>
       </p:ext>
     </p:extLst>
   </p:cSld>
@@ -9157,7 +9157,7 @@
           <p:cNvPr id="12" name="kicker-9">
             <a:extLst xmlns:a="http://schemas.openxmlformats.org/drawingml/2006/main">
               <a:ext uri="{FF2B5EF4-FFF2-40B4-BE49-F238E27FC236}">
-                <a16:creationId xmlns:a16="http://schemas.microsoft.com/office/drawing/2014/main" id="{D5F0444E-CE23-471A-AD6D-1CACD89E90AF}"/>
+                <a16:creationId xmlns:a16="http://schemas.microsoft.com/office/drawing/2014/main" id="{F2137537-5ABA-475F-A9E5-0EC6FFAECF06}"/>
               </a:ext>
             </a:extLst>
           </p:cNvPr>
@@ -9207,7 +9207,7 @@
           <p:cNvPr id="2" name="title-9">
             <a:extLst xmlns:a="http://schemas.openxmlformats.org/drawingml/2006/main">
               <a:ext uri="{FF2B5EF4-FFF2-40B4-BE49-F238E27FC236}">
-                <a16:creationId xmlns:a16="http://schemas.microsoft.com/office/drawing/2014/main" id="{68C2CF73-6150-446A-B7EB-D9F14ECEEEE3}"/>
+                <a16:creationId xmlns:a16="http://schemas.microsoft.com/office/drawing/2014/main" id="{96888E7D-B61B-439F-A07D-35ADEE298675}"/>
               </a:ext>
             </a:extLst>
           </p:cNvPr>
@@ -9257,7 +9257,7 @@
           <p:cNvPr id="3" name="rule-9">
             <a:extLst xmlns:a="http://schemas.openxmlformats.org/drawingml/2006/main">
               <a:ext uri="{FF2B5EF4-FFF2-40B4-BE49-F238E27FC236}">
-                <a16:creationId xmlns:a16="http://schemas.microsoft.com/office/drawing/2014/main" id="{C3814212-174A-46AD-970C-5296605E161D}"/>
+                <a16:creationId xmlns:a16="http://schemas.microsoft.com/office/drawing/2014/main" id="{369E29F6-EDCB-4017-BB75-2E477C43F6BF}"/>
               </a:ext>
             </a:extLst>
           </p:cNvPr>
@@ -9290,7 +9290,7 @@
           <p:cNvPr id="4" name="page-9">
             <a:extLst xmlns:a="http://schemas.openxmlformats.org/drawingml/2006/main">
               <a:ext uri="{FF2B5EF4-FFF2-40B4-BE49-F238E27FC236}">
-                <a16:creationId xmlns:a16="http://schemas.microsoft.com/office/drawing/2014/main" id="{CC1042BA-72EB-4AFE-8084-2BE0BF2098B0}"/>
+                <a16:creationId xmlns:a16="http://schemas.microsoft.com/office/drawing/2014/main" id="{A0961328-4BA6-43DD-A953-AE19819FDC0D}"/>
               </a:ext>
             </a:extLst>
           </p:cNvPr>
@@ -9340,7 +9340,7 @@
           <p:cNvPr id="5" name="ai-left-bg">
             <a:extLst xmlns:a="http://schemas.openxmlformats.org/drawingml/2006/main">
               <a:ext uri="{FF2B5EF4-FFF2-40B4-BE49-F238E27FC236}">
-                <a16:creationId xmlns:a16="http://schemas.microsoft.com/office/drawing/2014/main" id="{4802503C-FF2B-4437-80AD-EDE3E11B5452}"/>
+                <a16:creationId xmlns:a16="http://schemas.microsoft.com/office/drawing/2014/main" id="{9DF58FB9-62E3-4147-B08B-062A72BDD39D}"/>
               </a:ext>
             </a:extLst>
           </p:cNvPr>
@@ -9373,7 +9373,7 @@
           <p:cNvPr id="6" name="ai-right-bg">
             <a:extLst xmlns:a="http://schemas.openxmlformats.org/drawingml/2006/main">
               <a:ext uri="{FF2B5EF4-FFF2-40B4-BE49-F238E27FC236}">
-                <a16:creationId xmlns:a16="http://schemas.microsoft.com/office/drawing/2014/main" id="{08A1B1F3-9B8C-4127-8085-AF7422BCB118}"/>
+                <a16:creationId xmlns:a16="http://schemas.microsoft.com/office/drawing/2014/main" id="{336C2B4D-35A5-44E3-AB88-FF23E613E388}"/>
               </a:ext>
             </a:extLst>
           </p:cNvPr>
@@ -9406,7 +9406,7 @@
           <p:cNvPr id="7" name="ai-left-title">
             <a:extLst xmlns:a="http://schemas.openxmlformats.org/drawingml/2006/main">
               <a:ext uri="{FF2B5EF4-FFF2-40B4-BE49-F238E27FC236}">
-                <a16:creationId xmlns:a16="http://schemas.microsoft.com/office/drawing/2014/main" id="{31CDBF5C-D7B5-4A04-9847-2B4C8CDACA5D}"/>
+                <a16:creationId xmlns:a16="http://schemas.microsoft.com/office/drawing/2014/main" id="{C80A0705-1D67-4A7A-B8E0-071552FAB4CC}"/>
               </a:ext>
             </a:extLst>
           </p:cNvPr>
@@ -9456,7 +9456,7 @@
           <p:cNvPr id="8" name="ai-left">
             <a:extLst xmlns:a="http://schemas.openxmlformats.org/drawingml/2006/main">
               <a:ext uri="{FF2B5EF4-FFF2-40B4-BE49-F238E27FC236}">
-                <a16:creationId xmlns:a16="http://schemas.microsoft.com/office/drawing/2014/main" id="{6252CD98-7AFE-4CEA-9D86-A66033F69246}"/>
+                <a16:creationId xmlns:a16="http://schemas.microsoft.com/office/drawing/2014/main" id="{8C8ED991-6C18-48C0-A1EE-EBCACF737A81}"/>
               </a:ext>
             </a:extLst>
           </p:cNvPr>
@@ -9540,7 +9540,7 @@
           <p:cNvPr id="9" name="ai-right-title">
             <a:extLst xmlns:a="http://schemas.openxmlformats.org/drawingml/2006/main">
               <a:ext uri="{FF2B5EF4-FFF2-40B4-BE49-F238E27FC236}">
-                <a16:creationId xmlns:a16="http://schemas.microsoft.com/office/drawing/2014/main" id="{B3B7EACA-657D-45DF-8567-962D79E4978D}"/>
+                <a16:creationId xmlns:a16="http://schemas.microsoft.com/office/drawing/2014/main" id="{26ED0250-5693-4D22-A1CA-7D1BC0B01CF8}"/>
               </a:ext>
             </a:extLst>
           </p:cNvPr>
@@ -9590,7 +9590,7 @@
           <p:cNvPr id="10" name="ai-right">
             <a:extLst xmlns:a="http://schemas.openxmlformats.org/drawingml/2006/main">
               <a:ext uri="{FF2B5EF4-FFF2-40B4-BE49-F238E27FC236}">
-                <a16:creationId xmlns:a16="http://schemas.microsoft.com/office/drawing/2014/main" id="{7AD357D9-E705-40A5-BC31-A1B3C8CBF367}"/>
+                <a16:creationId xmlns:a16="http://schemas.microsoft.com/office/drawing/2014/main" id="{13703AB5-70F2-4CBF-A4A6-DC7AD2DC64C0}"/>
               </a:ext>
             </a:extLst>
           </p:cNvPr>
@@ -9674,7 +9674,7 @@
           <p:cNvPr id="11" name="ai-proof">
             <a:extLst xmlns:a="http://schemas.openxmlformats.org/drawingml/2006/main">
               <a:ext uri="{FF2B5EF4-FFF2-40B4-BE49-F238E27FC236}">
-                <a16:creationId xmlns:a16="http://schemas.microsoft.com/office/drawing/2014/main" id="{CFD2DA7E-2520-43ED-8D5E-76CE567FAF26}"/>
+                <a16:creationId xmlns:a16="http://schemas.microsoft.com/office/drawing/2014/main" id="{C6429ADA-4BD1-4A03-9600-51FE005C3AE5}"/>
               </a:ext>
             </a:extLst>
           </p:cNvPr>
@@ -9722,7 +9722,7 @@
     </p:spTree>
     <p:extLst>
       <p:ext uri="{BB962C8B-B14F-4D97-AF65-F5344CB8AC3E}">
-        <p14:creationId xmlns:p14="http://schemas.microsoft.com/office/powerpoint/2010/main" val="1149867817"/>
+        <p14:creationId xmlns:p14="http://schemas.microsoft.com/office/powerpoint/2010/main" val="1147259087"/>
       </p:ext>
     </p:extLst>
   </p:cSld>

</xml_diff>

<commit_message>
Align final materials with implementation evidence
</commit_message>
<xml_diff>
--- a/deliverables/ReproGuard答辩PPT-优化版.pptx
+++ b/deliverables/ReproGuard答辩PPT-优化版.pptx
@@ -2,22 +2,22 @@
 <file path=ppt/presentation.xml><?xml version="1.0" encoding="utf-8"?>
 <p:presentation xmlns:p="http://schemas.openxmlformats.org/presentationml/2006/main">
   <p:sldMasterIdLst>
-    <p:sldMasterId xmlns:r="http://schemas.openxmlformats.org/officeDocument/2006/relationships" id="2147483648" r:id="Rb379545a003d42d3"/>
+    <p:sldMasterId xmlns:r="http://schemas.openxmlformats.org/officeDocument/2006/relationships" id="2147483648" r:id="Rb8d762a2f2f243de"/>
   </p:sldMasterIdLst>
   <p:notesMasterIdLst>
-    <p:notesMasterId xmlns:r="http://schemas.openxmlformats.org/officeDocument/2006/relationships" r:id="R5a6337b866a64a0c"/>
+    <p:notesMasterId xmlns:r="http://schemas.openxmlformats.org/officeDocument/2006/relationships" r:id="R5fc2a0050ca245a9"/>
   </p:notesMasterIdLst>
   <p:sldIdLst>
-    <p:sldId xmlns:r="http://schemas.openxmlformats.org/officeDocument/2006/relationships" id="256" r:id="Rf85c0da8349f4b49"/>
-    <p:sldId xmlns:r="http://schemas.openxmlformats.org/officeDocument/2006/relationships" id="257" r:id="R56f169680d2e4608"/>
-    <p:sldId xmlns:r="http://schemas.openxmlformats.org/officeDocument/2006/relationships" id="258" r:id="Rbac632b6c3f742a8"/>
-    <p:sldId xmlns:r="http://schemas.openxmlformats.org/officeDocument/2006/relationships" id="259" r:id="Rae4206e5bd874393"/>
-    <p:sldId xmlns:r="http://schemas.openxmlformats.org/officeDocument/2006/relationships" id="260" r:id="R5c1c44ed4ae3473c"/>
-    <p:sldId xmlns:r="http://schemas.openxmlformats.org/officeDocument/2006/relationships" id="261" r:id="R290f5994ab9643e0"/>
-    <p:sldId xmlns:r="http://schemas.openxmlformats.org/officeDocument/2006/relationships" id="262" r:id="R4336fcd26db44b18"/>
-    <p:sldId xmlns:r="http://schemas.openxmlformats.org/officeDocument/2006/relationships" id="263" r:id="R5cd2302a080d419e"/>
-    <p:sldId xmlns:r="http://schemas.openxmlformats.org/officeDocument/2006/relationships" id="264" r:id="Rb897023a6cc04d55"/>
-    <p:sldId xmlns:r="http://schemas.openxmlformats.org/officeDocument/2006/relationships" id="265" r:id="Rfe8caa960bab4ef2"/>
+    <p:sldId xmlns:r="http://schemas.openxmlformats.org/officeDocument/2006/relationships" id="256" r:id="R0599d92ed6264031"/>
+    <p:sldId xmlns:r="http://schemas.openxmlformats.org/officeDocument/2006/relationships" id="257" r:id="R2dbaa90894984157"/>
+    <p:sldId xmlns:r="http://schemas.openxmlformats.org/officeDocument/2006/relationships" id="258" r:id="R89acf828698b483a"/>
+    <p:sldId xmlns:r="http://schemas.openxmlformats.org/officeDocument/2006/relationships" id="259" r:id="Rb24b7d086a174d20"/>
+    <p:sldId xmlns:r="http://schemas.openxmlformats.org/officeDocument/2006/relationships" id="260" r:id="R1d9e688e567f476b"/>
+    <p:sldId xmlns:r="http://schemas.openxmlformats.org/officeDocument/2006/relationships" id="261" r:id="Rca8918a8a1b24fd8"/>
+    <p:sldId xmlns:r="http://schemas.openxmlformats.org/officeDocument/2006/relationships" id="262" r:id="R7a0082a4c763426f"/>
+    <p:sldId xmlns:r="http://schemas.openxmlformats.org/officeDocument/2006/relationships" id="263" r:id="R56ba62777cee4dfc"/>
+    <p:sldId xmlns:r="http://schemas.openxmlformats.org/officeDocument/2006/relationships" id="264" r:id="R0fd00e3038e84178"/>
+    <p:sldId xmlns:r="http://schemas.openxmlformats.org/officeDocument/2006/relationships" id="265" r:id="Rd35b8d8fc3c94798"/>
   </p:sldIdLst>
   <p:sldSz cx="12192000" cy="6858000"/>
   <p:notesSz cx="6858000" cy="9144000"/>
@@ -1264,7 +1264,7 @@
   </p:cSld>
   <p:clrMap bg1="lt1" tx1="dk1" bg2="lt2" tx2="dk2" accent1="accent1" accent2="accent2" accent3="accent3" accent4="accent4" accent5="accent5" accent6="accent6" hlink="hlink" folHlink="folHlink"/>
   <p:sldLayoutIdLst>
-    <p:sldLayoutId xmlns:r="http://schemas.openxmlformats.org/officeDocument/2006/relationships" id="2147483649" r:id="R4f900205b42d434e"/>
+    <p:sldLayoutId xmlns:r="http://schemas.openxmlformats.org/officeDocument/2006/relationships" id="2147483649" r:id="R831605c64d614280"/>
   </p:sldLayoutIdLst>
   <p:txStyles>
     <p:titleStyle>
@@ -1815,7 +1815,7 @@
           <p:cNvPr id="7" name="title-kicker">
             <a:extLst xmlns:a="http://schemas.openxmlformats.org/drawingml/2006/main">
               <a:ext uri="{FF2B5EF4-FFF2-40B4-BE49-F238E27FC236}">
-                <a16:creationId xmlns:a16="http://schemas.microsoft.com/office/drawing/2014/main" id="{E698460B-2984-4C54-B8F5-B665F950B9A8}"/>
+                <a16:creationId xmlns:a16="http://schemas.microsoft.com/office/drawing/2014/main" id="{71F8FF0D-74D8-45A2-A6E3-B0E1BD482328}"/>
               </a:ext>
             </a:extLst>
           </p:cNvPr>
@@ -1865,7 +1865,7 @@
           <p:cNvPr id="2" name="title-main">
             <a:extLst xmlns:a="http://schemas.openxmlformats.org/drawingml/2006/main">
               <a:ext uri="{FF2B5EF4-FFF2-40B4-BE49-F238E27FC236}">
-                <a16:creationId xmlns:a16="http://schemas.microsoft.com/office/drawing/2014/main" id="{7ECED063-2B84-45AA-B5FA-1BB06B4A2CB3}"/>
+                <a16:creationId xmlns:a16="http://schemas.microsoft.com/office/drawing/2014/main" id="{D06368AF-C2A7-44EF-AA51-800A519E4123}"/>
               </a:ext>
             </a:extLst>
           </p:cNvPr>
@@ -1932,7 +1932,7 @@
           <p:cNvPr id="3" name="title-sub">
             <a:extLst xmlns:a="http://schemas.openxmlformats.org/drawingml/2006/main">
               <a:ext uri="{FF2B5EF4-FFF2-40B4-BE49-F238E27FC236}">
-                <a16:creationId xmlns:a16="http://schemas.microsoft.com/office/drawing/2014/main" id="{CB423AEB-3A82-4478-AD3B-AB69924D72DD}"/>
+                <a16:creationId xmlns:a16="http://schemas.microsoft.com/office/drawing/2014/main" id="{415330D8-EB84-4AE9-9B2F-8A88207EBEF5}"/>
               </a:ext>
             </a:extLst>
           </p:cNvPr>
@@ -1982,7 +1982,7 @@
           <p:cNvPr id="4" name="title-team">
             <a:extLst xmlns:a="http://schemas.openxmlformats.org/drawingml/2006/main">
               <a:ext uri="{FF2B5EF4-FFF2-40B4-BE49-F238E27FC236}">
-                <a16:creationId xmlns:a16="http://schemas.microsoft.com/office/drawing/2014/main" id="{9B5478DC-FE18-436C-9679-719B5060F5EE}"/>
+                <a16:creationId xmlns:a16="http://schemas.microsoft.com/office/drawing/2014/main" id="{5743942B-1BD0-4747-9B7B-1973B144AF41}"/>
               </a:ext>
             </a:extLst>
           </p:cNvPr>
@@ -2032,7 +2032,7 @@
           <p:cNvPr id="5" name="title-accent">
             <a:extLst xmlns:a="http://schemas.openxmlformats.org/drawingml/2006/main">
               <a:ext uri="{FF2B5EF4-FFF2-40B4-BE49-F238E27FC236}">
-                <a16:creationId xmlns:a16="http://schemas.microsoft.com/office/drawing/2014/main" id="{23867FDE-7B30-4560-AF4D-5AFA131CE3F2}"/>
+                <a16:creationId xmlns:a16="http://schemas.microsoft.com/office/drawing/2014/main" id="{38E81D09-8992-4320-8B5A-E734AE394350}"/>
               </a:ext>
             </a:extLst>
           </p:cNvPr>
@@ -2065,7 +2065,7 @@
           <p:cNvPr id="6" name="title-side">
             <a:extLst xmlns:a="http://schemas.openxmlformats.org/drawingml/2006/main">
               <a:ext uri="{FF2B5EF4-FFF2-40B4-BE49-F238E27FC236}">
-                <a16:creationId xmlns:a16="http://schemas.microsoft.com/office/drawing/2014/main" id="{1F5A36E6-7DE2-4036-9945-80F550B23D24}"/>
+                <a16:creationId xmlns:a16="http://schemas.microsoft.com/office/drawing/2014/main" id="{02DA339C-4C4D-4F16-B58B-748FE62F990B}"/>
               </a:ext>
             </a:extLst>
           </p:cNvPr>
@@ -2181,7 +2181,7 @@
     </p:spTree>
     <p:extLst>
       <p:ext uri="{BB962C8B-B14F-4D97-AF65-F5344CB8AC3E}">
-        <p14:creationId xmlns:p14="http://schemas.microsoft.com/office/powerpoint/2010/main" val="600379165"/>
+        <p14:creationId xmlns:p14="http://schemas.microsoft.com/office/powerpoint/2010/main" val="951920078"/>
       </p:ext>
     </p:extLst>
   </p:cSld>
@@ -2212,7 +2212,7 @@
           <p:cNvPr id="7" name="close-kicker">
             <a:extLst xmlns:a="http://schemas.openxmlformats.org/drawingml/2006/main">
               <a:ext uri="{FF2B5EF4-FFF2-40B4-BE49-F238E27FC236}">
-                <a16:creationId xmlns:a16="http://schemas.microsoft.com/office/drawing/2014/main" id="{8320D7F8-12B0-471C-9E49-E5AE145A2BBE}"/>
+                <a16:creationId xmlns:a16="http://schemas.microsoft.com/office/drawing/2014/main" id="{CD96520A-AAB6-4780-969A-79A923F63B09}"/>
               </a:ext>
             </a:extLst>
           </p:cNvPr>
@@ -2262,7 +2262,7 @@
           <p:cNvPr id="2" name="close-main">
             <a:extLst xmlns:a="http://schemas.openxmlformats.org/drawingml/2006/main">
               <a:ext uri="{FF2B5EF4-FFF2-40B4-BE49-F238E27FC236}">
-                <a16:creationId xmlns:a16="http://schemas.microsoft.com/office/drawing/2014/main" id="{0FC5113D-1562-4976-A163-22E9FFDBF2E8}"/>
+                <a16:creationId xmlns:a16="http://schemas.microsoft.com/office/drawing/2014/main" id="{D90223C0-A00E-4C99-8E2D-5D7B98CF9B1C}"/>
               </a:ext>
             </a:extLst>
           </p:cNvPr>
@@ -2329,7 +2329,7 @@
           <p:cNvPr id="3" name="close-rule">
             <a:extLst xmlns:a="http://schemas.openxmlformats.org/drawingml/2006/main">
               <a:ext uri="{FF2B5EF4-FFF2-40B4-BE49-F238E27FC236}">
-                <a16:creationId xmlns:a16="http://schemas.microsoft.com/office/drawing/2014/main" id="{824E90CF-F0E1-437F-92CB-6EB122A927F8}"/>
+                <a16:creationId xmlns:a16="http://schemas.microsoft.com/office/drawing/2014/main" id="{B4AEE01C-C7F4-4361-9D85-3FB872772854}"/>
               </a:ext>
             </a:extLst>
           </p:cNvPr>
@@ -2362,7 +2362,7 @@
           <p:cNvPr id="4" name="close-status">
             <a:extLst xmlns:a="http://schemas.openxmlformats.org/drawingml/2006/main">
               <a:ext uri="{FF2B5EF4-FFF2-40B4-BE49-F238E27FC236}">
-                <a16:creationId xmlns:a16="http://schemas.microsoft.com/office/drawing/2014/main" id="{A9BC851B-425C-497F-BC4C-B852DAAC28CE}"/>
+                <a16:creationId xmlns:a16="http://schemas.microsoft.com/office/drawing/2014/main" id="{9594FC01-4483-4E12-B293-AC8A4BFED0AC}"/>
               </a:ext>
             </a:extLst>
           </p:cNvPr>
@@ -2412,7 +2412,7 @@
           <p:cNvPr id="5" name="close-next">
             <a:extLst xmlns:a="http://schemas.openxmlformats.org/drawingml/2006/main">
               <a:ext uri="{FF2B5EF4-FFF2-40B4-BE49-F238E27FC236}">
-                <a16:creationId xmlns:a16="http://schemas.microsoft.com/office/drawing/2014/main" id="{B69A0081-B716-4BA9-836D-0D962DF13BF3}"/>
+                <a16:creationId xmlns:a16="http://schemas.microsoft.com/office/drawing/2014/main" id="{9B4C333C-078E-48A1-BA61-676556673CC6}"/>
               </a:ext>
             </a:extLst>
           </p:cNvPr>
@@ -2462,7 +2462,7 @@
           <p:cNvPr id="6" name="close-accent">
             <a:extLst xmlns:a="http://schemas.openxmlformats.org/drawingml/2006/main">
               <a:ext uri="{FF2B5EF4-FFF2-40B4-BE49-F238E27FC236}">
-                <a16:creationId xmlns:a16="http://schemas.microsoft.com/office/drawing/2014/main" id="{A80867D0-98F4-4D1F-9018-EED830AC3D3D}"/>
+                <a16:creationId xmlns:a16="http://schemas.microsoft.com/office/drawing/2014/main" id="{B5F040F4-1E9E-4568-83DF-13CB1F648132}"/>
               </a:ext>
             </a:extLst>
           </p:cNvPr>
@@ -2493,7 +2493,7 @@
     </p:spTree>
     <p:extLst>
       <p:ext uri="{BB962C8B-B14F-4D97-AF65-F5344CB8AC3E}">
-        <p14:creationId xmlns:p14="http://schemas.microsoft.com/office/powerpoint/2010/main" val="661857869"/>
+        <p14:creationId xmlns:p14="http://schemas.microsoft.com/office/powerpoint/2010/main" val="1752314181"/>
       </p:ext>
     </p:extLst>
   </p:cSld>
@@ -2524,7 +2524,7 @@
           <p:cNvPr id="13" name="kicker-2">
             <a:extLst xmlns:a="http://schemas.openxmlformats.org/drawingml/2006/main">
               <a:ext uri="{FF2B5EF4-FFF2-40B4-BE49-F238E27FC236}">
-                <a16:creationId xmlns:a16="http://schemas.microsoft.com/office/drawing/2014/main" id="{43A15C60-7613-4120-975B-992DB68531F0}"/>
+                <a16:creationId xmlns:a16="http://schemas.microsoft.com/office/drawing/2014/main" id="{577B1260-EDE3-4B37-B2C5-CDE9B0B5E74D}"/>
               </a:ext>
             </a:extLst>
           </p:cNvPr>
@@ -2574,7 +2574,7 @@
           <p:cNvPr id="2" name="title-2">
             <a:extLst xmlns:a="http://schemas.openxmlformats.org/drawingml/2006/main">
               <a:ext uri="{FF2B5EF4-FFF2-40B4-BE49-F238E27FC236}">
-                <a16:creationId xmlns:a16="http://schemas.microsoft.com/office/drawing/2014/main" id="{5E8B453B-D4DB-4E04-883F-933D31F87B4F}"/>
+                <a16:creationId xmlns:a16="http://schemas.microsoft.com/office/drawing/2014/main" id="{FB3197FF-035B-4C5D-BB17-99347BC67D31}"/>
               </a:ext>
             </a:extLst>
           </p:cNvPr>
@@ -2624,7 +2624,7 @@
           <p:cNvPr id="3" name="rule-2">
             <a:extLst xmlns:a="http://schemas.openxmlformats.org/drawingml/2006/main">
               <a:ext uri="{FF2B5EF4-FFF2-40B4-BE49-F238E27FC236}">
-                <a16:creationId xmlns:a16="http://schemas.microsoft.com/office/drawing/2014/main" id="{DC2FF730-FBF7-4EB4-81AC-F3DAE81CA7B0}"/>
+                <a16:creationId xmlns:a16="http://schemas.microsoft.com/office/drawing/2014/main" id="{E096A11E-D98F-454F-9661-C641E1C51F09}"/>
               </a:ext>
             </a:extLst>
           </p:cNvPr>
@@ -2657,7 +2657,7 @@
           <p:cNvPr id="4" name="page-2">
             <a:extLst xmlns:a="http://schemas.openxmlformats.org/drawingml/2006/main">
               <a:ext uri="{FF2B5EF4-FFF2-40B4-BE49-F238E27FC236}">
-                <a16:creationId xmlns:a16="http://schemas.microsoft.com/office/drawing/2014/main" id="{E3295B7C-34BC-45D6-B949-C1F3E4031BC9}"/>
+                <a16:creationId xmlns:a16="http://schemas.microsoft.com/office/drawing/2014/main" id="{F8A8570A-E138-4784-9373-9C77B7D70A36}"/>
               </a:ext>
             </a:extLst>
           </p:cNvPr>
@@ -2707,7 +2707,7 @@
           <p:cNvPr id="5" name="problem-left-label">
             <a:extLst xmlns:a="http://schemas.openxmlformats.org/drawingml/2006/main">
               <a:ext uri="{FF2B5EF4-FFF2-40B4-BE49-F238E27FC236}">
-                <a16:creationId xmlns:a16="http://schemas.microsoft.com/office/drawing/2014/main" id="{17E34B5C-6A04-4A0C-AB0F-BA9F1976332F}"/>
+                <a16:creationId xmlns:a16="http://schemas.microsoft.com/office/drawing/2014/main" id="{088C0DB5-4DB0-4557-BB72-9DDB0EB0BFDE}"/>
               </a:ext>
             </a:extLst>
           </p:cNvPr>
@@ -2757,7 +2757,7 @@
           <p:cNvPr id="6" name="problem-left">
             <a:extLst xmlns:a="http://schemas.openxmlformats.org/drawingml/2006/main">
               <a:ext uri="{FF2B5EF4-FFF2-40B4-BE49-F238E27FC236}">
-                <a16:creationId xmlns:a16="http://schemas.microsoft.com/office/drawing/2014/main" id="{2295CA51-E10D-4968-A151-2437B986D51D}"/>
+                <a16:creationId xmlns:a16="http://schemas.microsoft.com/office/drawing/2014/main" id="{26AD4D38-874F-4256-ACE2-14AFFFEFDE73}"/>
               </a:ext>
             </a:extLst>
           </p:cNvPr>
@@ -2858,7 +2858,7 @@
           <p:cNvPr id="7" name="problem-gap">
             <a:extLst xmlns:a="http://schemas.openxmlformats.org/drawingml/2006/main">
               <a:ext uri="{FF2B5EF4-FFF2-40B4-BE49-F238E27FC236}">
-                <a16:creationId xmlns:a16="http://schemas.microsoft.com/office/drawing/2014/main" id="{6C3889CF-D072-4335-A4DF-887BA343B9C1}"/>
+                <a16:creationId xmlns:a16="http://schemas.microsoft.com/office/drawing/2014/main" id="{5C199D58-A13A-4C4D-9B9E-9D8237BF3A6C}"/>
               </a:ext>
             </a:extLst>
           </p:cNvPr>
@@ -2908,7 +2908,7 @@
           <p:cNvPr id="8" name="problem-gap-line">
             <a:extLst xmlns:a="http://schemas.openxmlformats.org/drawingml/2006/main">
               <a:ext uri="{FF2B5EF4-FFF2-40B4-BE49-F238E27FC236}">
-                <a16:creationId xmlns:a16="http://schemas.microsoft.com/office/drawing/2014/main" id="{58EFCE44-152C-427C-85AA-6D648EE63522}"/>
+                <a16:creationId xmlns:a16="http://schemas.microsoft.com/office/drawing/2014/main" id="{40A36DC3-EB40-476C-9FDA-1A74CF40175F}"/>
               </a:ext>
             </a:extLst>
           </p:cNvPr>
@@ -2941,7 +2941,7 @@
           <p:cNvPr id="9" name="problem-right-label">
             <a:extLst xmlns:a="http://schemas.openxmlformats.org/drawingml/2006/main">
               <a:ext uri="{FF2B5EF4-FFF2-40B4-BE49-F238E27FC236}">
-                <a16:creationId xmlns:a16="http://schemas.microsoft.com/office/drawing/2014/main" id="{6C30B190-1B05-4EEA-BF26-F975DD329ACD}"/>
+                <a16:creationId xmlns:a16="http://schemas.microsoft.com/office/drawing/2014/main" id="{6C54C315-8EC1-4FF8-B462-6DAEA65B0F68}"/>
               </a:ext>
             </a:extLst>
           </p:cNvPr>
@@ -2991,7 +2991,7 @@
           <p:cNvPr id="10" name="problem-right">
             <a:extLst xmlns:a="http://schemas.openxmlformats.org/drawingml/2006/main">
               <a:ext uri="{FF2B5EF4-FFF2-40B4-BE49-F238E27FC236}">
-                <a16:creationId xmlns:a16="http://schemas.microsoft.com/office/drawing/2014/main" id="{FFA4EE9D-0BE0-433A-B6AB-ECD98FDFD2E1}"/>
+                <a16:creationId xmlns:a16="http://schemas.microsoft.com/office/drawing/2014/main" id="{E82EA594-D74D-4A29-8DDF-33349775A2CE}"/>
               </a:ext>
             </a:extLst>
           </p:cNvPr>
@@ -3092,7 +3092,7 @@
           <p:cNvPr id="11" name="problem-takeaway-bg">
             <a:extLst xmlns:a="http://schemas.openxmlformats.org/drawingml/2006/main">
               <a:ext uri="{FF2B5EF4-FFF2-40B4-BE49-F238E27FC236}">
-                <a16:creationId xmlns:a16="http://schemas.microsoft.com/office/drawing/2014/main" id="{007A69DF-B2A5-4620-9453-F3AA34E05260}"/>
+                <a16:creationId xmlns:a16="http://schemas.microsoft.com/office/drawing/2014/main" id="{437122E2-CAA6-4ED9-9162-6403BBD396A3}"/>
               </a:ext>
             </a:extLst>
           </p:cNvPr>
@@ -3125,7 +3125,7 @@
           <p:cNvPr id="12" name="problem-takeaway">
             <a:extLst xmlns:a="http://schemas.openxmlformats.org/drawingml/2006/main">
               <a:ext uri="{FF2B5EF4-FFF2-40B4-BE49-F238E27FC236}">
-                <a16:creationId xmlns:a16="http://schemas.microsoft.com/office/drawing/2014/main" id="{9319DF8D-3844-492D-9E19-1D84262CA2B2}"/>
+                <a16:creationId xmlns:a16="http://schemas.microsoft.com/office/drawing/2014/main" id="{2F5F919D-FC38-4ECC-A239-4E9F8F123CB3}"/>
               </a:ext>
             </a:extLst>
           </p:cNvPr>
@@ -3173,7 +3173,7 @@
     </p:spTree>
     <p:extLst>
       <p:ext uri="{BB962C8B-B14F-4D97-AF65-F5344CB8AC3E}">
-        <p14:creationId xmlns:p14="http://schemas.microsoft.com/office/powerpoint/2010/main" val="963226804"/>
+        <p14:creationId xmlns:p14="http://schemas.microsoft.com/office/powerpoint/2010/main" val="961663470"/>
       </p:ext>
     </p:extLst>
   </p:cSld>
@@ -3204,7 +3204,7 @@
           <p:cNvPr id="30" name="kicker-3">
             <a:extLst xmlns:a="http://schemas.openxmlformats.org/drawingml/2006/main">
               <a:ext uri="{FF2B5EF4-FFF2-40B4-BE49-F238E27FC236}">
-                <a16:creationId xmlns:a16="http://schemas.microsoft.com/office/drawing/2014/main" id="{898AABE6-F3C3-48B3-AA2E-8BEDEB254C32}"/>
+                <a16:creationId xmlns:a16="http://schemas.microsoft.com/office/drawing/2014/main" id="{5DBB99A7-7222-4B60-9F6A-5C06898805D7}"/>
               </a:ext>
             </a:extLst>
           </p:cNvPr>
@@ -3254,7 +3254,7 @@
           <p:cNvPr id="2" name="title-3">
             <a:extLst xmlns:a="http://schemas.openxmlformats.org/drawingml/2006/main">
               <a:ext uri="{FF2B5EF4-FFF2-40B4-BE49-F238E27FC236}">
-                <a16:creationId xmlns:a16="http://schemas.microsoft.com/office/drawing/2014/main" id="{CAC6B127-8AB1-41DA-9EA1-A0FEBFE73365}"/>
+                <a16:creationId xmlns:a16="http://schemas.microsoft.com/office/drawing/2014/main" id="{10A1AF9F-8A55-407E-9212-8D685D297D00}"/>
               </a:ext>
             </a:extLst>
           </p:cNvPr>
@@ -3304,7 +3304,7 @@
           <p:cNvPr id="3" name="rule-3">
             <a:extLst xmlns:a="http://schemas.openxmlformats.org/drawingml/2006/main">
               <a:ext uri="{FF2B5EF4-FFF2-40B4-BE49-F238E27FC236}">
-                <a16:creationId xmlns:a16="http://schemas.microsoft.com/office/drawing/2014/main" id="{1CD9B76F-036D-4A1D-B4D4-C57BF5E2760A}"/>
+                <a16:creationId xmlns:a16="http://schemas.microsoft.com/office/drawing/2014/main" id="{D13B4E7D-7D6B-47DD-8577-D2CEF39DFAF7}"/>
               </a:ext>
             </a:extLst>
           </p:cNvPr>
@@ -3337,7 +3337,7 @@
           <p:cNvPr id="4" name="page-3">
             <a:extLst xmlns:a="http://schemas.openxmlformats.org/drawingml/2006/main">
               <a:ext uri="{FF2B5EF4-FFF2-40B4-BE49-F238E27FC236}">
-                <a16:creationId xmlns:a16="http://schemas.microsoft.com/office/drawing/2014/main" id="{4CE1454E-9D1C-4594-9691-C3EF8C695069}"/>
+                <a16:creationId xmlns:a16="http://schemas.microsoft.com/office/drawing/2014/main" id="{8C6C871B-1B6D-4B66-9CF8-6E8EB97ACB26}"/>
               </a:ext>
             </a:extLst>
           </p:cNvPr>
@@ -3387,7 +3387,7 @@
           <p:cNvPr id="5" name="flow-edge-0">
             <a:extLst xmlns:a="http://schemas.openxmlformats.org/drawingml/2006/main">
               <a:ext uri="{FF2B5EF4-FFF2-40B4-BE49-F238E27FC236}">
-                <a16:creationId xmlns:a16="http://schemas.microsoft.com/office/drawing/2014/main" id="{81C2CC70-317A-4C97-AAD7-3E13ECAC1084}"/>
+                <a16:creationId xmlns:a16="http://schemas.microsoft.com/office/drawing/2014/main" id="{1EB0E01A-BAB7-43A4-BFA7-6FD7970D2F26}"/>
               </a:ext>
             </a:extLst>
           </p:cNvPr>
@@ -3420,7 +3420,7 @@
           <p:cNvPr id="6" name="flow-node-0">
             <a:extLst xmlns:a="http://schemas.openxmlformats.org/drawingml/2006/main">
               <a:ext uri="{FF2B5EF4-FFF2-40B4-BE49-F238E27FC236}">
-                <a16:creationId xmlns:a16="http://schemas.microsoft.com/office/drawing/2014/main" id="{BE7192B4-F610-4584-91C8-AEA9E8DDD340}"/>
+                <a16:creationId xmlns:a16="http://schemas.microsoft.com/office/drawing/2014/main" id="{58E80C9C-6A15-4D47-9991-82D143FB2852}"/>
               </a:ext>
             </a:extLst>
           </p:cNvPr>
@@ -3453,7 +3453,7 @@
           <p:cNvPr id="7" name="flow-num-0">
             <a:extLst xmlns:a="http://schemas.openxmlformats.org/drawingml/2006/main">
               <a:ext uri="{FF2B5EF4-FFF2-40B4-BE49-F238E27FC236}">
-                <a16:creationId xmlns:a16="http://schemas.microsoft.com/office/drawing/2014/main" id="{8C164B96-9AE4-4088-B71D-EEC16DF4B950}"/>
+                <a16:creationId xmlns:a16="http://schemas.microsoft.com/office/drawing/2014/main" id="{73CEC3F3-FF5A-4BC6-88CD-EEFA1047A6A4}"/>
               </a:ext>
             </a:extLst>
           </p:cNvPr>
@@ -3503,7 +3503,7 @@
           <p:cNvPr id="8" name="flow-label-0">
             <a:extLst xmlns:a="http://schemas.openxmlformats.org/drawingml/2006/main">
               <a:ext uri="{FF2B5EF4-FFF2-40B4-BE49-F238E27FC236}">
-                <a16:creationId xmlns:a16="http://schemas.microsoft.com/office/drawing/2014/main" id="{BDD60326-2117-4D01-85C8-87A0B7683ACA}"/>
+                <a16:creationId xmlns:a16="http://schemas.microsoft.com/office/drawing/2014/main" id="{EBF0550E-D91C-4677-B6CB-688EA73A5223}"/>
               </a:ext>
             </a:extLst>
           </p:cNvPr>
@@ -3553,7 +3553,7 @@
           <p:cNvPr id="9" name="flow-edge-1">
             <a:extLst xmlns:a="http://schemas.openxmlformats.org/drawingml/2006/main">
               <a:ext uri="{FF2B5EF4-FFF2-40B4-BE49-F238E27FC236}">
-                <a16:creationId xmlns:a16="http://schemas.microsoft.com/office/drawing/2014/main" id="{A7A9F0CE-E972-409D-8FB5-8CD48E9F13C0}"/>
+                <a16:creationId xmlns:a16="http://schemas.microsoft.com/office/drawing/2014/main" id="{38384154-C33C-4532-8553-556FBBE123CC}"/>
               </a:ext>
             </a:extLst>
           </p:cNvPr>
@@ -3586,7 +3586,7 @@
           <p:cNvPr id="10" name="flow-node-1">
             <a:extLst xmlns:a="http://schemas.openxmlformats.org/drawingml/2006/main">
               <a:ext uri="{FF2B5EF4-FFF2-40B4-BE49-F238E27FC236}">
-                <a16:creationId xmlns:a16="http://schemas.microsoft.com/office/drawing/2014/main" id="{8AAEFD5B-1790-4651-A86A-52FDC896E107}"/>
+                <a16:creationId xmlns:a16="http://schemas.microsoft.com/office/drawing/2014/main" id="{596C4A23-3ED1-4D71-A601-2859CB2AEA91}"/>
               </a:ext>
             </a:extLst>
           </p:cNvPr>
@@ -3619,7 +3619,7 @@
           <p:cNvPr id="11" name="flow-num-1">
             <a:extLst xmlns:a="http://schemas.openxmlformats.org/drawingml/2006/main">
               <a:ext uri="{FF2B5EF4-FFF2-40B4-BE49-F238E27FC236}">
-                <a16:creationId xmlns:a16="http://schemas.microsoft.com/office/drawing/2014/main" id="{ABE5FE3F-107B-4863-A2DD-405298BE25DF}"/>
+                <a16:creationId xmlns:a16="http://schemas.microsoft.com/office/drawing/2014/main" id="{A1B423AE-4283-4F86-BF30-FE9238B6F0AE}"/>
               </a:ext>
             </a:extLst>
           </p:cNvPr>
@@ -3669,7 +3669,7 @@
           <p:cNvPr id="12" name="flow-label-1">
             <a:extLst xmlns:a="http://schemas.openxmlformats.org/drawingml/2006/main">
               <a:ext uri="{FF2B5EF4-FFF2-40B4-BE49-F238E27FC236}">
-                <a16:creationId xmlns:a16="http://schemas.microsoft.com/office/drawing/2014/main" id="{F197E598-2404-4438-B402-5F63A2DEEB6C}"/>
+                <a16:creationId xmlns:a16="http://schemas.microsoft.com/office/drawing/2014/main" id="{BE850AFC-FEBC-4C1A-9DFC-0BBEE31B969F}"/>
               </a:ext>
             </a:extLst>
           </p:cNvPr>
@@ -3719,7 +3719,7 @@
           <p:cNvPr id="13" name="flow-edge-2">
             <a:extLst xmlns:a="http://schemas.openxmlformats.org/drawingml/2006/main">
               <a:ext uri="{FF2B5EF4-FFF2-40B4-BE49-F238E27FC236}">
-                <a16:creationId xmlns:a16="http://schemas.microsoft.com/office/drawing/2014/main" id="{3CF97B69-79B5-43AE-B4E2-5D71F42C3EE4}"/>
+                <a16:creationId xmlns:a16="http://schemas.microsoft.com/office/drawing/2014/main" id="{001FCF5C-D252-496C-9F58-0E70F0197C6E}"/>
               </a:ext>
             </a:extLst>
           </p:cNvPr>
@@ -3752,7 +3752,7 @@
           <p:cNvPr id="14" name="flow-node-2">
             <a:extLst xmlns:a="http://schemas.openxmlformats.org/drawingml/2006/main">
               <a:ext uri="{FF2B5EF4-FFF2-40B4-BE49-F238E27FC236}">
-                <a16:creationId xmlns:a16="http://schemas.microsoft.com/office/drawing/2014/main" id="{2E6CC8D9-C141-4020-A243-E5044901280A}"/>
+                <a16:creationId xmlns:a16="http://schemas.microsoft.com/office/drawing/2014/main" id="{13D2F5A1-0F39-4809-B98E-EB29F372E73C}"/>
               </a:ext>
             </a:extLst>
           </p:cNvPr>
@@ -3785,7 +3785,7 @@
           <p:cNvPr id="15" name="flow-num-2">
             <a:extLst xmlns:a="http://schemas.openxmlformats.org/drawingml/2006/main">
               <a:ext uri="{FF2B5EF4-FFF2-40B4-BE49-F238E27FC236}">
-                <a16:creationId xmlns:a16="http://schemas.microsoft.com/office/drawing/2014/main" id="{C5B50183-CEC1-4373-8474-612838E0620B}"/>
+                <a16:creationId xmlns:a16="http://schemas.microsoft.com/office/drawing/2014/main" id="{74D7E5A8-4511-4215-8D63-6128F03CE8EB}"/>
               </a:ext>
             </a:extLst>
           </p:cNvPr>
@@ -3835,7 +3835,7 @@
           <p:cNvPr id="16" name="flow-label-2">
             <a:extLst xmlns:a="http://schemas.openxmlformats.org/drawingml/2006/main">
               <a:ext uri="{FF2B5EF4-FFF2-40B4-BE49-F238E27FC236}">
-                <a16:creationId xmlns:a16="http://schemas.microsoft.com/office/drawing/2014/main" id="{03EBE55C-E93F-470B-9D27-15EF6609BD47}"/>
+                <a16:creationId xmlns:a16="http://schemas.microsoft.com/office/drawing/2014/main" id="{AAA6968E-B46C-46C0-96A0-6E4A78E09029}"/>
               </a:ext>
             </a:extLst>
           </p:cNvPr>
@@ -3885,7 +3885,7 @@
           <p:cNvPr id="17" name="flow-edge-3">
             <a:extLst xmlns:a="http://schemas.openxmlformats.org/drawingml/2006/main">
               <a:ext uri="{FF2B5EF4-FFF2-40B4-BE49-F238E27FC236}">
-                <a16:creationId xmlns:a16="http://schemas.microsoft.com/office/drawing/2014/main" id="{AEA833E6-DD7D-4CB2-8F3E-B14E3625B893}"/>
+                <a16:creationId xmlns:a16="http://schemas.microsoft.com/office/drawing/2014/main" id="{A3E710AA-0663-4A76-926E-63728831DCD9}"/>
               </a:ext>
             </a:extLst>
           </p:cNvPr>
@@ -3918,7 +3918,7 @@
           <p:cNvPr id="18" name="flow-node-3">
             <a:extLst xmlns:a="http://schemas.openxmlformats.org/drawingml/2006/main">
               <a:ext uri="{FF2B5EF4-FFF2-40B4-BE49-F238E27FC236}">
-                <a16:creationId xmlns:a16="http://schemas.microsoft.com/office/drawing/2014/main" id="{DE2D2908-7052-4A5B-91EA-623B30AAE13B}"/>
+                <a16:creationId xmlns:a16="http://schemas.microsoft.com/office/drawing/2014/main" id="{29C0683C-633E-461D-99D4-3DFE2D0F3E55}"/>
               </a:ext>
             </a:extLst>
           </p:cNvPr>
@@ -3951,7 +3951,7 @@
           <p:cNvPr id="19" name="flow-num-3">
             <a:extLst xmlns:a="http://schemas.openxmlformats.org/drawingml/2006/main">
               <a:ext uri="{FF2B5EF4-FFF2-40B4-BE49-F238E27FC236}">
-                <a16:creationId xmlns:a16="http://schemas.microsoft.com/office/drawing/2014/main" id="{21E5BF85-BF81-4284-899D-9B9C300059CD}"/>
+                <a16:creationId xmlns:a16="http://schemas.microsoft.com/office/drawing/2014/main" id="{0C61FF4C-D9BE-4B02-9CBA-D30820ECC0ED}"/>
               </a:ext>
             </a:extLst>
           </p:cNvPr>
@@ -4001,7 +4001,7 @@
           <p:cNvPr id="20" name="flow-label-3">
             <a:extLst xmlns:a="http://schemas.openxmlformats.org/drawingml/2006/main">
               <a:ext uri="{FF2B5EF4-FFF2-40B4-BE49-F238E27FC236}">
-                <a16:creationId xmlns:a16="http://schemas.microsoft.com/office/drawing/2014/main" id="{26F8D32A-7711-4DB8-BD8E-6623F675747E}"/>
+                <a16:creationId xmlns:a16="http://schemas.microsoft.com/office/drawing/2014/main" id="{F7E8E380-6269-40A6-AED3-1232F35C5FB4}"/>
               </a:ext>
             </a:extLst>
           </p:cNvPr>
@@ -4051,7 +4051,7 @@
           <p:cNvPr id="21" name="flow-edge-4">
             <a:extLst xmlns:a="http://schemas.openxmlformats.org/drawingml/2006/main">
               <a:ext uri="{FF2B5EF4-FFF2-40B4-BE49-F238E27FC236}">
-                <a16:creationId xmlns:a16="http://schemas.microsoft.com/office/drawing/2014/main" id="{4FCDD011-95EF-4391-A1A9-5016EC0C7208}"/>
+                <a16:creationId xmlns:a16="http://schemas.microsoft.com/office/drawing/2014/main" id="{4DB5DDB9-4E25-4304-BE4C-9565EF25BE0B}"/>
               </a:ext>
             </a:extLst>
           </p:cNvPr>
@@ -4084,7 +4084,7 @@
           <p:cNvPr id="22" name="flow-node-4">
             <a:extLst xmlns:a="http://schemas.openxmlformats.org/drawingml/2006/main">
               <a:ext uri="{FF2B5EF4-FFF2-40B4-BE49-F238E27FC236}">
-                <a16:creationId xmlns:a16="http://schemas.microsoft.com/office/drawing/2014/main" id="{92BA7F8C-6C2F-4E93-83B0-DA1F037EA382}"/>
+                <a16:creationId xmlns:a16="http://schemas.microsoft.com/office/drawing/2014/main" id="{931035D2-FC89-4D46-AEE3-3D360D1BFE9E}"/>
               </a:ext>
             </a:extLst>
           </p:cNvPr>
@@ -4117,7 +4117,7 @@
           <p:cNvPr id="23" name="flow-num-4">
             <a:extLst xmlns:a="http://schemas.openxmlformats.org/drawingml/2006/main">
               <a:ext uri="{FF2B5EF4-FFF2-40B4-BE49-F238E27FC236}">
-                <a16:creationId xmlns:a16="http://schemas.microsoft.com/office/drawing/2014/main" id="{11A4FE5E-2082-49C7-85D4-BFA039C8F786}"/>
+                <a16:creationId xmlns:a16="http://schemas.microsoft.com/office/drawing/2014/main" id="{E5380E38-6385-408A-9BBE-6E80DC66C15F}"/>
               </a:ext>
             </a:extLst>
           </p:cNvPr>
@@ -4167,7 +4167,7 @@
           <p:cNvPr id="24" name="flow-label-4">
             <a:extLst xmlns:a="http://schemas.openxmlformats.org/drawingml/2006/main">
               <a:ext uri="{FF2B5EF4-FFF2-40B4-BE49-F238E27FC236}">
-                <a16:creationId xmlns:a16="http://schemas.microsoft.com/office/drawing/2014/main" id="{CF7ADEE2-118B-4A45-98B4-3B094B8DD471}"/>
+                <a16:creationId xmlns:a16="http://schemas.microsoft.com/office/drawing/2014/main" id="{25411E00-4D85-4A6D-A254-70684370CD30}"/>
               </a:ext>
             </a:extLst>
           </p:cNvPr>
@@ -4217,7 +4217,7 @@
           <p:cNvPr id="25" name="flow-node-5">
             <a:extLst xmlns:a="http://schemas.openxmlformats.org/drawingml/2006/main">
               <a:ext uri="{FF2B5EF4-FFF2-40B4-BE49-F238E27FC236}">
-                <a16:creationId xmlns:a16="http://schemas.microsoft.com/office/drawing/2014/main" id="{7586AF14-0A8B-4FCF-828A-6FD76113B476}"/>
+                <a16:creationId xmlns:a16="http://schemas.microsoft.com/office/drawing/2014/main" id="{1D5048FE-5C00-4B15-9D32-528D57EE2829}"/>
               </a:ext>
             </a:extLst>
           </p:cNvPr>
@@ -4250,7 +4250,7 @@
           <p:cNvPr id="26" name="flow-num-5">
             <a:extLst xmlns:a="http://schemas.openxmlformats.org/drawingml/2006/main">
               <a:ext uri="{FF2B5EF4-FFF2-40B4-BE49-F238E27FC236}">
-                <a16:creationId xmlns:a16="http://schemas.microsoft.com/office/drawing/2014/main" id="{666819FC-9E80-494B-87FF-DF959B710204}"/>
+                <a16:creationId xmlns:a16="http://schemas.microsoft.com/office/drawing/2014/main" id="{C2DCD779-29A8-49DE-A3D1-0C8ADA1C9D49}"/>
               </a:ext>
             </a:extLst>
           </p:cNvPr>
@@ -4300,7 +4300,7 @@
           <p:cNvPr id="27" name="flow-label-5">
             <a:extLst xmlns:a="http://schemas.openxmlformats.org/drawingml/2006/main">
               <a:ext uri="{FF2B5EF4-FFF2-40B4-BE49-F238E27FC236}">
-                <a16:creationId xmlns:a16="http://schemas.microsoft.com/office/drawing/2014/main" id="{DB7E76B8-D646-40AF-9376-5312443A0224}"/>
+                <a16:creationId xmlns:a16="http://schemas.microsoft.com/office/drawing/2014/main" id="{1C4B5AA3-0C61-4769-AB86-F8373550988E}"/>
               </a:ext>
             </a:extLst>
           </p:cNvPr>
@@ -4350,7 +4350,7 @@
           <p:cNvPr id="28" name="flow-boundary-bg">
             <a:extLst xmlns:a="http://schemas.openxmlformats.org/drawingml/2006/main">
               <a:ext uri="{FF2B5EF4-FFF2-40B4-BE49-F238E27FC236}">
-                <a16:creationId xmlns:a16="http://schemas.microsoft.com/office/drawing/2014/main" id="{ED6590D5-12F9-4458-9FAC-E47E9EC9C272}"/>
+                <a16:creationId xmlns:a16="http://schemas.microsoft.com/office/drawing/2014/main" id="{0718FE37-205C-498D-B078-C5BBA2432B90}"/>
               </a:ext>
             </a:extLst>
           </p:cNvPr>
@@ -4383,7 +4383,7 @@
           <p:cNvPr id="29" name="flow-boundary">
             <a:extLst xmlns:a="http://schemas.openxmlformats.org/drawingml/2006/main">
               <a:ext uri="{FF2B5EF4-FFF2-40B4-BE49-F238E27FC236}">
-                <a16:creationId xmlns:a16="http://schemas.microsoft.com/office/drawing/2014/main" id="{A69960E6-2A9E-41F5-BDD4-C4AC5C175AE9}"/>
+                <a16:creationId xmlns:a16="http://schemas.microsoft.com/office/drawing/2014/main" id="{1AFF0A08-288A-44DE-B89D-B5F9B9D4AF15}"/>
               </a:ext>
             </a:extLst>
           </p:cNvPr>
@@ -4431,7 +4431,7 @@
     </p:spTree>
     <p:extLst>
       <p:ext uri="{BB962C8B-B14F-4D97-AF65-F5344CB8AC3E}">
-        <p14:creationId xmlns:p14="http://schemas.microsoft.com/office/powerpoint/2010/main" val="269667093"/>
+        <p14:creationId xmlns:p14="http://schemas.microsoft.com/office/powerpoint/2010/main" val="1937893347"/>
       </p:ext>
     </p:extLst>
   </p:cSld>
@@ -4462,7 +4462,7 @@
           <p:cNvPr id="16" name="kicker-4">
             <a:extLst xmlns:a="http://schemas.openxmlformats.org/drawingml/2006/main">
               <a:ext uri="{FF2B5EF4-FFF2-40B4-BE49-F238E27FC236}">
-                <a16:creationId xmlns:a16="http://schemas.microsoft.com/office/drawing/2014/main" id="{AA0EC150-B320-4328-BFB5-A84AF5B11C88}"/>
+                <a16:creationId xmlns:a16="http://schemas.microsoft.com/office/drawing/2014/main" id="{CDA7F884-BB9F-4AD5-A3B4-57B3DFF2E44C}"/>
               </a:ext>
             </a:extLst>
           </p:cNvPr>
@@ -4512,7 +4512,7 @@
           <p:cNvPr id="2" name="title-4">
             <a:extLst xmlns:a="http://schemas.openxmlformats.org/drawingml/2006/main">
               <a:ext uri="{FF2B5EF4-FFF2-40B4-BE49-F238E27FC236}">
-                <a16:creationId xmlns:a16="http://schemas.microsoft.com/office/drawing/2014/main" id="{7E016446-B10F-4691-B7C1-2BDB3B67F14F}"/>
+                <a16:creationId xmlns:a16="http://schemas.microsoft.com/office/drawing/2014/main" id="{8D461C58-A7E7-40C0-B3A9-1C14FDB15206}"/>
               </a:ext>
             </a:extLst>
           </p:cNvPr>
@@ -4562,7 +4562,7 @@
           <p:cNvPr id="3" name="rule-4">
             <a:extLst xmlns:a="http://schemas.openxmlformats.org/drawingml/2006/main">
               <a:ext uri="{FF2B5EF4-FFF2-40B4-BE49-F238E27FC236}">
-                <a16:creationId xmlns:a16="http://schemas.microsoft.com/office/drawing/2014/main" id="{304196E5-BFCA-4ACE-807B-B27524A2A652}"/>
+                <a16:creationId xmlns:a16="http://schemas.microsoft.com/office/drawing/2014/main" id="{6B40F9F1-DAB6-437C-857E-9DD54CAD7FD5}"/>
               </a:ext>
             </a:extLst>
           </p:cNvPr>
@@ -4595,7 +4595,7 @@
           <p:cNvPr id="4" name="page-4">
             <a:extLst xmlns:a="http://schemas.openxmlformats.org/drawingml/2006/main">
               <a:ext uri="{FF2B5EF4-FFF2-40B4-BE49-F238E27FC236}">
-                <a16:creationId xmlns:a16="http://schemas.microsoft.com/office/drawing/2014/main" id="{7208C482-915E-4E4E-8847-5F432D0E774A}"/>
+                <a16:creationId xmlns:a16="http://schemas.microsoft.com/office/drawing/2014/main" id="{324AAD6C-937A-4D0E-89A4-A9306ABDC1DD}"/>
               </a:ext>
             </a:extLst>
           </p:cNvPr>
@@ -4645,7 +4645,7 @@
           <p:cNvPr id="5" name="innovation-accent-0">
             <a:extLst xmlns:a="http://schemas.openxmlformats.org/drawingml/2006/main">
               <a:ext uri="{FF2B5EF4-FFF2-40B4-BE49-F238E27FC236}">
-                <a16:creationId xmlns:a16="http://schemas.microsoft.com/office/drawing/2014/main" id="{66660273-DC3E-4971-A5D6-1ED7E1298107}"/>
+                <a16:creationId xmlns:a16="http://schemas.microsoft.com/office/drawing/2014/main" id="{82E8BB8A-C2C3-4822-ABB7-730E4761D4A8}"/>
               </a:ext>
             </a:extLst>
           </p:cNvPr>
@@ -4678,7 +4678,7 @@
           <p:cNvPr id="6" name="innovation-title-0">
             <a:extLst xmlns:a="http://schemas.openxmlformats.org/drawingml/2006/main">
               <a:ext uri="{FF2B5EF4-FFF2-40B4-BE49-F238E27FC236}">
-                <a16:creationId xmlns:a16="http://schemas.microsoft.com/office/drawing/2014/main" id="{B761B322-0986-4F93-B9A5-DEFDC89FDB86}"/>
+                <a16:creationId xmlns:a16="http://schemas.microsoft.com/office/drawing/2014/main" id="{5347DFD6-D7EE-4A49-BF23-3748EEB95616}"/>
               </a:ext>
             </a:extLst>
           </p:cNvPr>
@@ -4728,7 +4728,7 @@
           <p:cNvPr id="7" name="innovation-body-0">
             <a:extLst xmlns:a="http://schemas.openxmlformats.org/drawingml/2006/main">
               <a:ext uri="{FF2B5EF4-FFF2-40B4-BE49-F238E27FC236}">
-                <a16:creationId xmlns:a16="http://schemas.microsoft.com/office/drawing/2014/main" id="{69F50967-93EA-4601-A45F-D6DB8FA8AACA}"/>
+                <a16:creationId xmlns:a16="http://schemas.microsoft.com/office/drawing/2014/main" id="{56B2885C-6BB3-4644-93EC-06C24EB52922}"/>
               </a:ext>
             </a:extLst>
           </p:cNvPr>
@@ -4778,7 +4778,7 @@
           <p:cNvPr id="8" name="innovation-accent-1">
             <a:extLst xmlns:a="http://schemas.openxmlformats.org/drawingml/2006/main">
               <a:ext uri="{FF2B5EF4-FFF2-40B4-BE49-F238E27FC236}">
-                <a16:creationId xmlns:a16="http://schemas.microsoft.com/office/drawing/2014/main" id="{C15F1E01-6740-45C7-AABA-08D2A84F8234}"/>
+                <a16:creationId xmlns:a16="http://schemas.microsoft.com/office/drawing/2014/main" id="{793EC906-4979-4991-B648-8F2597729C5A}"/>
               </a:ext>
             </a:extLst>
           </p:cNvPr>
@@ -4811,7 +4811,7 @@
           <p:cNvPr id="9" name="innovation-title-1">
             <a:extLst xmlns:a="http://schemas.openxmlformats.org/drawingml/2006/main">
               <a:ext uri="{FF2B5EF4-FFF2-40B4-BE49-F238E27FC236}">
-                <a16:creationId xmlns:a16="http://schemas.microsoft.com/office/drawing/2014/main" id="{DBEF640B-5455-4D3D-8EA1-12997AACED33}"/>
+                <a16:creationId xmlns:a16="http://schemas.microsoft.com/office/drawing/2014/main" id="{A1B8FE25-8531-4612-9318-590310EC7554}"/>
               </a:ext>
             </a:extLst>
           </p:cNvPr>
@@ -4861,7 +4861,7 @@
           <p:cNvPr id="10" name="innovation-body-1">
             <a:extLst xmlns:a="http://schemas.openxmlformats.org/drawingml/2006/main">
               <a:ext uri="{FF2B5EF4-FFF2-40B4-BE49-F238E27FC236}">
-                <a16:creationId xmlns:a16="http://schemas.microsoft.com/office/drawing/2014/main" id="{F46609EF-08B9-466A-A5E5-4981DD3AC386}"/>
+                <a16:creationId xmlns:a16="http://schemas.microsoft.com/office/drawing/2014/main" id="{6843836F-19BA-4A40-B0F7-1C19907C7ECB}"/>
               </a:ext>
             </a:extLst>
           </p:cNvPr>
@@ -4911,7 +4911,7 @@
           <p:cNvPr id="11" name="innovation-accent-2">
             <a:extLst xmlns:a="http://schemas.openxmlformats.org/drawingml/2006/main">
               <a:ext uri="{FF2B5EF4-FFF2-40B4-BE49-F238E27FC236}">
-                <a16:creationId xmlns:a16="http://schemas.microsoft.com/office/drawing/2014/main" id="{1DF26909-6891-4B6B-986A-1A0723C2D9FD}"/>
+                <a16:creationId xmlns:a16="http://schemas.microsoft.com/office/drawing/2014/main" id="{AA8B7ECA-E31B-4A05-A702-D3B34457CD79}"/>
               </a:ext>
             </a:extLst>
           </p:cNvPr>
@@ -4944,7 +4944,7 @@
           <p:cNvPr id="12" name="innovation-title-2">
             <a:extLst xmlns:a="http://schemas.openxmlformats.org/drawingml/2006/main">
               <a:ext uri="{FF2B5EF4-FFF2-40B4-BE49-F238E27FC236}">
-                <a16:creationId xmlns:a16="http://schemas.microsoft.com/office/drawing/2014/main" id="{F3A3CA84-A93D-4646-8673-C6D7625E41B8}"/>
+                <a16:creationId xmlns:a16="http://schemas.microsoft.com/office/drawing/2014/main" id="{DF4A8DCE-95AF-422A-AD89-7281C8F648E1}"/>
               </a:ext>
             </a:extLst>
           </p:cNvPr>
@@ -4994,7 +4994,7 @@
           <p:cNvPr id="13" name="innovation-body-2">
             <a:extLst xmlns:a="http://schemas.openxmlformats.org/drawingml/2006/main">
               <a:ext uri="{FF2B5EF4-FFF2-40B4-BE49-F238E27FC236}">
-                <a16:creationId xmlns:a16="http://schemas.microsoft.com/office/drawing/2014/main" id="{523F68DF-1B5D-433C-80BF-106E2866D922}"/>
+                <a16:creationId xmlns:a16="http://schemas.microsoft.com/office/drawing/2014/main" id="{42BEED38-0F67-4AA0-8EE8-8C00DC38890D}"/>
               </a:ext>
             </a:extLst>
           </p:cNvPr>
@@ -5044,7 +5044,7 @@
           <p:cNvPr id="14" name="innovation-bottom-rule">
             <a:extLst xmlns:a="http://schemas.openxmlformats.org/drawingml/2006/main">
               <a:ext uri="{FF2B5EF4-FFF2-40B4-BE49-F238E27FC236}">
-                <a16:creationId xmlns:a16="http://schemas.microsoft.com/office/drawing/2014/main" id="{31454C5B-341E-4D5D-9A32-092A71BB8491}"/>
+                <a16:creationId xmlns:a16="http://schemas.microsoft.com/office/drawing/2014/main" id="{EC854FA1-0273-4FFA-BA6F-D41E740897A4}"/>
               </a:ext>
             </a:extLst>
           </p:cNvPr>
@@ -5077,7 +5077,7 @@
           <p:cNvPr id="15" name="innovation-bottom">
             <a:extLst xmlns:a="http://schemas.openxmlformats.org/drawingml/2006/main">
               <a:ext uri="{FF2B5EF4-FFF2-40B4-BE49-F238E27FC236}">
-                <a16:creationId xmlns:a16="http://schemas.microsoft.com/office/drawing/2014/main" id="{E7474967-96B1-4F02-AC85-5D29ED0422B8}"/>
+                <a16:creationId xmlns:a16="http://schemas.microsoft.com/office/drawing/2014/main" id="{C6F48541-3F7B-458C-839A-54E90B708EC1}"/>
               </a:ext>
             </a:extLst>
           </p:cNvPr>
@@ -5125,7 +5125,7 @@
     </p:spTree>
     <p:extLst>
       <p:ext uri="{BB962C8B-B14F-4D97-AF65-F5344CB8AC3E}">
-        <p14:creationId xmlns:p14="http://schemas.microsoft.com/office/powerpoint/2010/main" val="1769081727"/>
+        <p14:creationId xmlns:p14="http://schemas.microsoft.com/office/powerpoint/2010/main" val="1633611862"/>
       </p:ext>
     </p:extLst>
   </p:cSld>
@@ -5156,7 +5156,7 @@
           <p:cNvPr id="18" name="kicker-5">
             <a:extLst xmlns:a="http://schemas.openxmlformats.org/drawingml/2006/main">
               <a:ext uri="{FF2B5EF4-FFF2-40B4-BE49-F238E27FC236}">
-                <a16:creationId xmlns:a16="http://schemas.microsoft.com/office/drawing/2014/main" id="{1CCF4AB7-7324-4C33-9D02-762225CA4B91}"/>
+                <a16:creationId xmlns:a16="http://schemas.microsoft.com/office/drawing/2014/main" id="{5FC60671-BBB6-4728-ABDF-A962927EE041}"/>
               </a:ext>
             </a:extLst>
           </p:cNvPr>
@@ -5206,7 +5206,7 @@
           <p:cNvPr id="2" name="title-5">
             <a:extLst xmlns:a="http://schemas.openxmlformats.org/drawingml/2006/main">
               <a:ext uri="{FF2B5EF4-FFF2-40B4-BE49-F238E27FC236}">
-                <a16:creationId xmlns:a16="http://schemas.microsoft.com/office/drawing/2014/main" id="{CF0F75DD-AE24-40B0-821E-A1868A0A9B1C}"/>
+                <a16:creationId xmlns:a16="http://schemas.microsoft.com/office/drawing/2014/main" id="{846A0DCF-0B17-473E-87D2-CBF4A5D8B45C}"/>
               </a:ext>
             </a:extLst>
           </p:cNvPr>
@@ -5256,7 +5256,7 @@
           <p:cNvPr id="3" name="rule-5">
             <a:extLst xmlns:a="http://schemas.openxmlformats.org/drawingml/2006/main">
               <a:ext uri="{FF2B5EF4-FFF2-40B4-BE49-F238E27FC236}">
-                <a16:creationId xmlns:a16="http://schemas.microsoft.com/office/drawing/2014/main" id="{4014066B-5E4A-4444-A5DE-DF76CCAF9B65}"/>
+                <a16:creationId xmlns:a16="http://schemas.microsoft.com/office/drawing/2014/main" id="{6F9123C3-A101-4FA3-A150-AAD2CD1D026F}"/>
               </a:ext>
             </a:extLst>
           </p:cNvPr>
@@ -5289,7 +5289,7 @@
           <p:cNvPr id="4" name="page-5">
             <a:extLst xmlns:a="http://schemas.openxmlformats.org/drawingml/2006/main">
               <a:ext uri="{FF2B5EF4-FFF2-40B4-BE49-F238E27FC236}">
-                <a16:creationId xmlns:a16="http://schemas.microsoft.com/office/drawing/2014/main" id="{4F4410A3-6306-4913-8068-7A619AA8AF21}"/>
+                <a16:creationId xmlns:a16="http://schemas.microsoft.com/office/drawing/2014/main" id="{00BF397B-642D-4CE6-8FE6-1AEAAE4F0C29}"/>
               </a:ext>
             </a:extLst>
           </p:cNvPr>
@@ -5339,7 +5339,7 @@
           <p:cNvPr id="5" name="case-fact">
             <a:extLst xmlns:a="http://schemas.openxmlformats.org/drawingml/2006/main">
               <a:ext uri="{FF2B5EF4-FFF2-40B4-BE49-F238E27FC236}">
-                <a16:creationId xmlns:a16="http://schemas.microsoft.com/office/drawing/2014/main" id="{84B9C7C4-ED10-4DD2-B315-9163AD2DC4F3}"/>
+                <a16:creationId xmlns:a16="http://schemas.microsoft.com/office/drawing/2014/main" id="{A90E9FD7-923D-427A-98B7-76587CC5D0F8}"/>
               </a:ext>
             </a:extLst>
           </p:cNvPr>
@@ -5389,7 +5389,7 @@
           <p:cNvPr id="6" name="case-num-0">
             <a:extLst xmlns:a="http://schemas.openxmlformats.org/drawingml/2006/main">
               <a:ext uri="{FF2B5EF4-FFF2-40B4-BE49-F238E27FC236}">
-                <a16:creationId xmlns:a16="http://schemas.microsoft.com/office/drawing/2014/main" id="{408E90AA-53BA-41AD-9120-C40ED131CAD3}"/>
+                <a16:creationId xmlns:a16="http://schemas.microsoft.com/office/drawing/2014/main" id="{8FEFA870-A64C-4CDB-B74D-0C697D32AC2F}"/>
               </a:ext>
             </a:extLst>
           </p:cNvPr>
@@ -5439,7 +5439,7 @@
           <p:cNvPr id="7" name="case-title-0">
             <a:extLst xmlns:a="http://schemas.openxmlformats.org/drawingml/2006/main">
               <a:ext uri="{FF2B5EF4-FFF2-40B4-BE49-F238E27FC236}">
-                <a16:creationId xmlns:a16="http://schemas.microsoft.com/office/drawing/2014/main" id="{D6C53855-31DA-4E79-86E5-62C50AB9D654}"/>
+                <a16:creationId xmlns:a16="http://schemas.microsoft.com/office/drawing/2014/main" id="{193D7129-0937-41D5-8E3C-151F8866BFA6}"/>
               </a:ext>
             </a:extLst>
           </p:cNvPr>
@@ -5489,7 +5489,7 @@
           <p:cNvPr id="8" name="case-body-0">
             <a:extLst xmlns:a="http://schemas.openxmlformats.org/drawingml/2006/main">
               <a:ext uri="{FF2B5EF4-FFF2-40B4-BE49-F238E27FC236}">
-                <a16:creationId xmlns:a16="http://schemas.microsoft.com/office/drawing/2014/main" id="{8784322B-3781-44B8-92C8-21317A9C1511}"/>
+                <a16:creationId xmlns:a16="http://schemas.microsoft.com/office/drawing/2014/main" id="{C54EDB7A-4E96-43BC-9EE4-DFECFC12EB35}"/>
               </a:ext>
             </a:extLst>
           </p:cNvPr>
@@ -5539,7 +5539,7 @@
           <p:cNvPr id="9" name="case-rule-0">
             <a:extLst xmlns:a="http://schemas.openxmlformats.org/drawingml/2006/main">
               <a:ext uri="{FF2B5EF4-FFF2-40B4-BE49-F238E27FC236}">
-                <a16:creationId xmlns:a16="http://schemas.microsoft.com/office/drawing/2014/main" id="{17B4FF45-F582-4829-8200-8EED7A071938}"/>
+                <a16:creationId xmlns:a16="http://schemas.microsoft.com/office/drawing/2014/main" id="{CE3E2700-71BF-42A9-BDE5-D7F627A0E6A4}"/>
               </a:ext>
             </a:extLst>
           </p:cNvPr>
@@ -5572,7 +5572,7 @@
           <p:cNvPr id="10" name="case-num-1">
             <a:extLst xmlns:a="http://schemas.openxmlformats.org/drawingml/2006/main">
               <a:ext uri="{FF2B5EF4-FFF2-40B4-BE49-F238E27FC236}">
-                <a16:creationId xmlns:a16="http://schemas.microsoft.com/office/drawing/2014/main" id="{4FEAAF4B-232B-449E-9E76-E9581B57D557}"/>
+                <a16:creationId xmlns:a16="http://schemas.microsoft.com/office/drawing/2014/main" id="{38AE90F6-98CD-4E26-87EE-A64306160B7B}"/>
               </a:ext>
             </a:extLst>
           </p:cNvPr>
@@ -5622,7 +5622,7 @@
           <p:cNvPr id="11" name="case-title-1">
             <a:extLst xmlns:a="http://schemas.openxmlformats.org/drawingml/2006/main">
               <a:ext uri="{FF2B5EF4-FFF2-40B4-BE49-F238E27FC236}">
-                <a16:creationId xmlns:a16="http://schemas.microsoft.com/office/drawing/2014/main" id="{7715C675-67D0-45C2-BE4F-9C0C2AC37985}"/>
+                <a16:creationId xmlns:a16="http://schemas.microsoft.com/office/drawing/2014/main" id="{50AA5B9A-83BE-485E-BAC1-DBA43276C2DF}"/>
               </a:ext>
             </a:extLst>
           </p:cNvPr>
@@ -5672,7 +5672,7 @@
           <p:cNvPr id="12" name="case-body-1">
             <a:extLst xmlns:a="http://schemas.openxmlformats.org/drawingml/2006/main">
               <a:ext uri="{FF2B5EF4-FFF2-40B4-BE49-F238E27FC236}">
-                <a16:creationId xmlns:a16="http://schemas.microsoft.com/office/drawing/2014/main" id="{62F5E1EE-2EE8-43E8-9379-234ADBC414BE}"/>
+                <a16:creationId xmlns:a16="http://schemas.microsoft.com/office/drawing/2014/main" id="{95B68419-0B2A-4C61-A02C-3C4BB7A85752}"/>
               </a:ext>
             </a:extLst>
           </p:cNvPr>
@@ -5722,7 +5722,7 @@
           <p:cNvPr id="13" name="case-rule-1">
             <a:extLst xmlns:a="http://schemas.openxmlformats.org/drawingml/2006/main">
               <a:ext uri="{FF2B5EF4-FFF2-40B4-BE49-F238E27FC236}">
-                <a16:creationId xmlns:a16="http://schemas.microsoft.com/office/drawing/2014/main" id="{6E1756EE-4CE3-4C2C-AD4E-95D1A7E503CE}"/>
+                <a16:creationId xmlns:a16="http://schemas.microsoft.com/office/drawing/2014/main" id="{6A01D068-DA10-47D0-ABBF-7F381FC3EEA8}"/>
               </a:ext>
             </a:extLst>
           </p:cNvPr>
@@ -5755,7 +5755,7 @@
           <p:cNvPr id="14" name="case-num-2">
             <a:extLst xmlns:a="http://schemas.openxmlformats.org/drawingml/2006/main">
               <a:ext uri="{FF2B5EF4-FFF2-40B4-BE49-F238E27FC236}">
-                <a16:creationId xmlns:a16="http://schemas.microsoft.com/office/drawing/2014/main" id="{0820911E-695D-40B4-8466-E337D90B429F}"/>
+                <a16:creationId xmlns:a16="http://schemas.microsoft.com/office/drawing/2014/main" id="{DE0EC470-0955-437A-9916-D7EC112A990D}"/>
               </a:ext>
             </a:extLst>
           </p:cNvPr>
@@ -5805,7 +5805,7 @@
           <p:cNvPr id="15" name="case-title-2">
             <a:extLst xmlns:a="http://schemas.openxmlformats.org/drawingml/2006/main">
               <a:ext uri="{FF2B5EF4-FFF2-40B4-BE49-F238E27FC236}">
-                <a16:creationId xmlns:a16="http://schemas.microsoft.com/office/drawing/2014/main" id="{6C6852D8-7CD4-4B5C-94AE-750EA06F1A95}"/>
+                <a16:creationId xmlns:a16="http://schemas.microsoft.com/office/drawing/2014/main" id="{AB683C49-A615-4108-9A51-A9810E008AF6}"/>
               </a:ext>
             </a:extLst>
           </p:cNvPr>
@@ -5855,7 +5855,7 @@
           <p:cNvPr id="16" name="case-body-2">
             <a:extLst xmlns:a="http://schemas.openxmlformats.org/drawingml/2006/main">
               <a:ext uri="{FF2B5EF4-FFF2-40B4-BE49-F238E27FC236}">
-                <a16:creationId xmlns:a16="http://schemas.microsoft.com/office/drawing/2014/main" id="{954FDAA3-5D9E-4BA6-9E36-04B827867C64}"/>
+                <a16:creationId xmlns:a16="http://schemas.microsoft.com/office/drawing/2014/main" id="{3CD1ABB5-58E0-403A-8E06-8153B930106D}"/>
               </a:ext>
             </a:extLst>
           </p:cNvPr>
@@ -5905,7 +5905,7 @@
           <p:cNvPr id="17" name="case-caveat">
             <a:extLst xmlns:a="http://schemas.openxmlformats.org/drawingml/2006/main">
               <a:ext uri="{FF2B5EF4-FFF2-40B4-BE49-F238E27FC236}">
-                <a16:creationId xmlns:a16="http://schemas.microsoft.com/office/drawing/2014/main" id="{31722133-34CC-44AF-BC09-319EA2DC4687}"/>
+                <a16:creationId xmlns:a16="http://schemas.microsoft.com/office/drawing/2014/main" id="{4552A5C4-252A-4CC9-9E79-CF20DCBD3659}"/>
               </a:ext>
             </a:extLst>
           </p:cNvPr>
@@ -5953,7 +5953,7 @@
     </p:spTree>
     <p:extLst>
       <p:ext uri="{BB962C8B-B14F-4D97-AF65-F5344CB8AC3E}">
-        <p14:creationId xmlns:p14="http://schemas.microsoft.com/office/powerpoint/2010/main" val="157872095"/>
+        <p14:creationId xmlns:p14="http://schemas.microsoft.com/office/powerpoint/2010/main" val="2096382427"/>
       </p:ext>
     </p:extLst>
   </p:cSld>
@@ -5981,10 +5981,10 @@
       </p:grpSpPr>
       <p:sp>
         <p:nvSpPr>
-          <p:cNvPr id="11" name="kicker-6">
-            <a:extLst xmlns:a="http://schemas.openxmlformats.org/drawingml/2006/main">
-              <a:ext uri="{FF2B5EF4-FFF2-40B4-BE49-F238E27FC236}">
-                <a16:creationId xmlns:a16="http://schemas.microsoft.com/office/drawing/2014/main" id="{6A7D0944-4E02-4063-A41C-74817247748C}"/>
+          <p:cNvPr id="12" name="kicker-6">
+            <a:extLst xmlns:a="http://schemas.openxmlformats.org/drawingml/2006/main">
+              <a:ext uri="{FF2B5EF4-FFF2-40B4-BE49-F238E27FC236}">
+                <a16:creationId xmlns:a16="http://schemas.microsoft.com/office/drawing/2014/main" id="{2940E546-7C8A-4F79-AB91-1894E1ABBBA3}"/>
               </a:ext>
             </a:extLst>
           </p:cNvPr>
@@ -6034,7 +6034,7 @@
           <p:cNvPr id="2" name="title-6">
             <a:extLst xmlns:a="http://schemas.openxmlformats.org/drawingml/2006/main">
               <a:ext uri="{FF2B5EF4-FFF2-40B4-BE49-F238E27FC236}">
-                <a16:creationId xmlns:a16="http://schemas.microsoft.com/office/drawing/2014/main" id="{1F58A9C3-D390-4695-A877-F5AD7FFFD3BF}"/>
+                <a16:creationId xmlns:a16="http://schemas.microsoft.com/office/drawing/2014/main" id="{14EBD2F5-F1C2-4969-80F6-971705A45F6D}"/>
               </a:ext>
             </a:extLst>
           </p:cNvPr>
@@ -6084,7 +6084,7 @@
           <p:cNvPr id="3" name="rule-6">
             <a:extLst xmlns:a="http://schemas.openxmlformats.org/drawingml/2006/main">
               <a:ext uri="{FF2B5EF4-FFF2-40B4-BE49-F238E27FC236}">
-                <a16:creationId xmlns:a16="http://schemas.microsoft.com/office/drawing/2014/main" id="{919E8F12-2EC2-45AC-B322-5D9A991C9205}"/>
+                <a16:creationId xmlns:a16="http://schemas.microsoft.com/office/drawing/2014/main" id="{03613819-852E-4813-BF3A-54DC12C1F516}"/>
               </a:ext>
             </a:extLst>
           </p:cNvPr>
@@ -6117,7 +6117,7 @@
           <p:cNvPr id="4" name="page-6">
             <a:extLst xmlns:a="http://schemas.openxmlformats.org/drawingml/2006/main">
               <a:ext uri="{FF2B5EF4-FFF2-40B4-BE49-F238E27FC236}">
-                <a16:creationId xmlns:a16="http://schemas.microsoft.com/office/drawing/2014/main" id="{E2A6C53B-3929-42B5-8E41-10E7877421CF}"/>
+                <a16:creationId xmlns:a16="http://schemas.microsoft.com/office/drawing/2014/main" id="{5727237F-4ED9-471C-AE7A-099977C21A40}"/>
               </a:ext>
             </a:extLst>
           </p:cNvPr>
@@ -6167,7 +6167,7 @@
           <p:cNvPr id="5" name="action-frame">
             <a:extLst xmlns:a="http://schemas.openxmlformats.org/drawingml/2006/main">
               <a:ext uri="{FF2B5EF4-FFF2-40B4-BE49-F238E27FC236}">
-                <a16:creationId xmlns:a16="http://schemas.microsoft.com/office/drawing/2014/main" id="{760E133E-DDB3-41DA-B666-254E67C3B76D}"/>
+                <a16:creationId xmlns:a16="http://schemas.microsoft.com/office/drawing/2014/main" id="{F85F235A-F909-4AAE-84E0-BAF69D459780}"/>
               </a:ext>
             </a:extLst>
           </p:cNvPr>
@@ -6197,14 +6197,14 @@
       </p:sp>
       <p:pic>
         <p:nvPicPr>
-          <p:cNvPr id="16" name=""/>
+          <p:cNvPr id="17" name=""/>
           <p:cNvPicPr>
             <a:picLocks xmlns:a="http://schemas.openxmlformats.org/drawingml/2006/main" noChangeAspect="1"/>
           </p:cNvPicPr>
           <p:nvPr/>
         </p:nvPicPr>
         <p:blipFill>
-          <a:blip xmlns:r="http://schemas.openxmlformats.org/officeDocument/2006/relationships" xmlns:a="http://schemas.openxmlformats.org/drawingml/2006/main" r:embed="Rd9936e20b1d64efd"/>
+          <a:blip xmlns:r="http://schemas.openxmlformats.org/officeDocument/2006/relationships" xmlns:a="http://schemas.openxmlformats.org/drawingml/2006/main" r:embed="Red5c216250e44ef7"/>
           <a:stretch xmlns:a="http://schemas.openxmlformats.org/drawingml/2006/main"/>
         </p:blipFill>
         <p:spPr>
@@ -6222,7 +6222,7 @@
           <p:cNvPr id="7" name="action-proof-title">
             <a:extLst xmlns:a="http://schemas.openxmlformats.org/drawingml/2006/main">
               <a:ext uri="{FF2B5EF4-FFF2-40B4-BE49-F238E27FC236}">
-                <a16:creationId xmlns:a16="http://schemas.microsoft.com/office/drawing/2014/main" id="{F25EFBFE-B4B0-4A06-8B90-A437D976D563}"/>
+                <a16:creationId xmlns:a16="http://schemas.microsoft.com/office/drawing/2014/main" id="{A1046905-3D1F-4A0B-B66F-F604300662F0}"/>
               </a:ext>
             </a:extLst>
           </p:cNvPr>
@@ -6272,7 +6272,7 @@
           <p:cNvPr id="8" name="action-proof-list">
             <a:extLst xmlns:a="http://schemas.openxmlformats.org/drawingml/2006/main">
               <a:ext uri="{FF2B5EF4-FFF2-40B4-BE49-F238E27FC236}">
-                <a16:creationId xmlns:a16="http://schemas.microsoft.com/office/drawing/2014/main" id="{1FCDE4FB-8384-45AE-8C2D-F5BE6AE3C89F}"/>
+                <a16:creationId xmlns:a16="http://schemas.microsoft.com/office/drawing/2014/main" id="{506BE186-5477-4BE9-BB32-0932E9241EEB}"/>
               </a:ext>
             </a:extLst>
           </p:cNvPr>
@@ -6373,19 +6373,19 @@
           <p:cNvPr id="9" name="action-boundary-bg">
             <a:extLst xmlns:a="http://schemas.openxmlformats.org/drawingml/2006/main">
               <a:ext uri="{FF2B5EF4-FFF2-40B4-BE49-F238E27FC236}">
-                <a16:creationId xmlns:a16="http://schemas.microsoft.com/office/drawing/2014/main" id="{46FCE9E2-F006-48E3-8DE0-E8410EBCEF5A}"/>
-              </a:ext>
-            </a:extLst>
-          </p:cNvPr>
-          <p:cNvSpPr>
-            <a:spLocks xmlns:a="http://schemas.openxmlformats.org/drawingml/2006/main" noGrp="1"/>
-          </p:cNvSpPr>
-          <p:nvPr/>
-        </p:nvSpPr>
-        <p:spPr>
-          <a:xfrm xmlns:a="http://schemas.openxmlformats.org/drawingml/2006/main">
-            <a:off x="5334000" y="4953000"/>
-            <a:ext cx="5715000" cy="762000"/>
+                <a16:creationId xmlns:a16="http://schemas.microsoft.com/office/drawing/2014/main" id="{398C843E-5C83-413F-8CC5-FC84B5ABA658}"/>
+              </a:ext>
+            </a:extLst>
+          </p:cNvPr>
+          <p:cNvSpPr>
+            <a:spLocks xmlns:a="http://schemas.openxmlformats.org/drawingml/2006/main" noGrp="1"/>
+          </p:cNvSpPr>
+          <p:nvPr/>
+        </p:nvSpPr>
+        <p:spPr>
+          <a:xfrm xmlns:a="http://schemas.openxmlformats.org/drawingml/2006/main">
+            <a:off x="5334000" y="4876800"/>
+            <a:ext cx="5715000" cy="914400"/>
           </a:xfrm>
           <a:prstGeom xmlns:a="http://schemas.openxmlformats.org/drawingml/2006/main" prst="rect">
             <a:avLst/>
@@ -6403,22 +6403,22 @@
       </p:sp>
       <p:sp>
         <p:nvSpPr>
-          <p:cNvPr id="10" name="action-boundary">
-            <a:extLst xmlns:a="http://schemas.openxmlformats.org/drawingml/2006/main">
-              <a:ext uri="{FF2B5EF4-FFF2-40B4-BE49-F238E27FC236}">
-                <a16:creationId xmlns:a16="http://schemas.microsoft.com/office/drawing/2014/main" id="{9B425BAF-3213-4761-93E0-4B65529502D7}"/>
-              </a:ext>
-            </a:extLst>
-          </p:cNvPr>
-          <p:cNvSpPr>
-            <a:spLocks xmlns:a="http://schemas.openxmlformats.org/drawingml/2006/main" noGrp="1"/>
-          </p:cNvSpPr>
-          <p:nvPr/>
-        </p:nvSpPr>
-        <p:spPr>
-          <a:xfrm xmlns:a="http://schemas.openxmlformats.org/drawingml/2006/main">
-            <a:off x="5562600" y="5143500"/>
-            <a:ext cx="5238750" cy="438150"/>
+          <p:cNvPr id="10" name="action-code-title">
+            <a:extLst xmlns:a="http://schemas.openxmlformats.org/drawingml/2006/main">
+              <a:ext uri="{FF2B5EF4-FFF2-40B4-BE49-F238E27FC236}">
+                <a16:creationId xmlns:a16="http://schemas.microsoft.com/office/drawing/2014/main" id="{3D4C3D69-0AAE-4079-B031-B66909B036FE}"/>
+              </a:ext>
+            </a:extLst>
+          </p:cNvPr>
+          <p:cNvSpPr>
+            <a:spLocks xmlns:a="http://schemas.openxmlformats.org/drawingml/2006/main" noGrp="1"/>
+          </p:cNvSpPr>
+          <p:nvPr/>
+        </p:nvSpPr>
+        <p:spPr>
+          <a:xfrm xmlns:a="http://schemas.openxmlformats.org/drawingml/2006/main">
+            <a:off x="5562600" y="4991100"/>
+            <a:ext cx="5238750" cy="209550"/>
           </a:xfrm>
           <a:prstGeom xmlns:a="http://schemas.openxmlformats.org/drawingml/2006/main" prst="rect">
             <a:avLst/>
@@ -6434,19 +6434,86 @@
           <a:lstStyle xmlns:a="http://schemas.openxmlformats.org/drawingml/2006/main"/>
           <a:p xmlns:a="http://schemas.openxmlformats.org/drawingml/2006/main">
             <a:pPr>
-              <a:defRPr sz="1275" b="1">
+              <a:defRPr sz="1200" b="1">
                 <a:solidFill>
                   <a:srgbClr val="D3543F"/>
                 </a:solidFill>
               </a:defRPr>
             </a:pPr>
             <a:r>
-              <a:rPr sz="1275" b="1">
+              <a:rPr sz="1200" b="1">
                 <a:solidFill>
                   <a:srgbClr val="D3543F"/>
                 </a:solidFill>
               </a:rPr>
-              <a:t>已完成 uses: ./ 同仓库验收与公开仓库 @v1 跨仓库验证。</a:t>
+              <a:t>可复用接入配置</a:t>
+            </a:r>
+          </a:p>
+        </p:txBody>
+      </p:sp>
+      <p:sp>
+        <p:nvSpPr>
+          <p:cNvPr id="11" name="action-code">
+            <a:extLst xmlns:a="http://schemas.openxmlformats.org/drawingml/2006/main">
+              <a:ext uri="{FF2B5EF4-FFF2-40B4-BE49-F238E27FC236}">
+                <a16:creationId xmlns:a16="http://schemas.microsoft.com/office/drawing/2014/main" id="{22818DAD-8D66-4942-978B-D7C12A1C5D88}"/>
+              </a:ext>
+            </a:extLst>
+          </p:cNvPr>
+          <p:cNvSpPr>
+            <a:spLocks xmlns:a="http://schemas.openxmlformats.org/drawingml/2006/main" noGrp="1"/>
+          </p:cNvSpPr>
+          <p:nvPr/>
+        </p:nvSpPr>
+        <p:spPr>
+          <a:xfrm xmlns:a="http://schemas.openxmlformats.org/drawingml/2006/main">
+            <a:off x="5562600" y="5238750"/>
+            <a:ext cx="5238750" cy="400050"/>
+          </a:xfrm>
+          <a:prstGeom xmlns:a="http://schemas.openxmlformats.org/drawingml/2006/main" prst="rect">
+            <a:avLst/>
+          </a:prstGeom>
+          <a:noFill xmlns:a="http://schemas.openxmlformats.org/drawingml/2006/main"/>
+          <a:ln xmlns:a="http://schemas.openxmlformats.org/drawingml/2006/main" w="0">
+            <a:noFill/>
+            <a:prstDash val="solid"/>
+          </a:ln>
+        </p:spPr>
+        <p:txBody>
+          <a:bodyPr xmlns:a="http://schemas.openxmlformats.org/drawingml/2006/main"/>
+          <a:lstStyle xmlns:a="http://schemas.openxmlformats.org/drawingml/2006/main"/>
+          <a:p xmlns:a="http://schemas.openxmlformats.org/drawingml/2006/main">
+            <a:pPr>
+              <a:defRPr sz="1125">
+                <a:solidFill>
+                  <a:srgbClr val="18212B"/>
+                </a:solidFill>
+              </a:defRPr>
+            </a:pPr>
+            <a:r>
+              <a:rPr sz="1125">
+                <a:solidFill>
+                  <a:srgbClr val="18212B"/>
+                </a:solidFill>
+              </a:rPr>
+              <a:t>uses: hm10629/reproguard@v1</a:t>
+            </a:r>
+          </a:p>
+          <a:p xmlns:a="http://schemas.openxmlformats.org/drawingml/2006/main">
+            <a:pPr>
+              <a:defRPr sz="1125">
+                <a:solidFill>
+                  <a:srgbClr val="18212B"/>
+                </a:solidFill>
+              </a:defRPr>
+            </a:pPr>
+            <a:r>
+              <a:rPr sz="1125">
+                <a:solidFill>
+                  <a:srgbClr val="18212B"/>
+                </a:solidFill>
+              </a:rPr>
+              <a:t>with: constraints: docs/experiment-protocol.md</a:t>
             </a:r>
           </a:p>
         </p:txBody>
@@ -6454,7 +6521,7 @@
     </p:spTree>
     <p:extLst>
       <p:ext uri="{BB962C8B-B14F-4D97-AF65-F5344CB8AC3E}">
-        <p14:creationId xmlns:p14="http://schemas.microsoft.com/office/powerpoint/2010/main" val="1823013144"/>
+        <p14:creationId xmlns:p14="http://schemas.microsoft.com/office/powerpoint/2010/main" val="500579072"/>
       </p:ext>
     </p:extLst>
   </p:cSld>
@@ -6485,7 +6552,7 @@
           <p:cNvPr id="14" name="kicker-7">
             <a:extLst xmlns:a="http://schemas.openxmlformats.org/drawingml/2006/main">
               <a:ext uri="{FF2B5EF4-FFF2-40B4-BE49-F238E27FC236}">
-                <a16:creationId xmlns:a16="http://schemas.microsoft.com/office/drawing/2014/main" id="{51B58B98-2EC6-4427-B96D-3B92D177DEE6}"/>
+                <a16:creationId xmlns:a16="http://schemas.microsoft.com/office/drawing/2014/main" id="{045C3AFA-12C0-4B72-B47A-244CE42DB7F1}"/>
               </a:ext>
             </a:extLst>
           </p:cNvPr>
@@ -6535,7 +6602,7 @@
           <p:cNvPr id="2" name="title-7">
             <a:extLst xmlns:a="http://schemas.openxmlformats.org/drawingml/2006/main">
               <a:ext uri="{FF2B5EF4-FFF2-40B4-BE49-F238E27FC236}">
-                <a16:creationId xmlns:a16="http://schemas.microsoft.com/office/drawing/2014/main" id="{0758E86D-7C47-48AD-AA49-9D8A84901C6F}"/>
+                <a16:creationId xmlns:a16="http://schemas.microsoft.com/office/drawing/2014/main" id="{8CCA46E7-B8B2-4B46-B25F-31A9D26DCD10}"/>
               </a:ext>
             </a:extLst>
           </p:cNvPr>
@@ -6585,7 +6652,7 @@
           <p:cNvPr id="3" name="rule-7">
             <a:extLst xmlns:a="http://schemas.openxmlformats.org/drawingml/2006/main">
               <a:ext uri="{FF2B5EF4-FFF2-40B4-BE49-F238E27FC236}">
-                <a16:creationId xmlns:a16="http://schemas.microsoft.com/office/drawing/2014/main" id="{6B2C4634-F4E8-4E92-90D6-E2043664F980}"/>
+                <a16:creationId xmlns:a16="http://schemas.microsoft.com/office/drawing/2014/main" id="{E568E8BE-0B80-43E9-A084-AFD1D7D29AC1}"/>
               </a:ext>
             </a:extLst>
           </p:cNvPr>
@@ -6618,7 +6685,7 @@
           <p:cNvPr id="4" name="page-7">
             <a:extLst xmlns:a="http://schemas.openxmlformats.org/drawingml/2006/main">
               <a:ext uri="{FF2B5EF4-FFF2-40B4-BE49-F238E27FC236}">
-                <a16:creationId xmlns:a16="http://schemas.microsoft.com/office/drawing/2014/main" id="{5442678F-94DA-4D4D-9485-AC89FA97CEDA}"/>
+                <a16:creationId xmlns:a16="http://schemas.microsoft.com/office/drawing/2014/main" id="{3256056B-6D09-4FBC-B1B8-8213B899ACF3}"/>
               </a:ext>
             </a:extLst>
           </p:cNvPr>
@@ -6668,7 +6735,7 @@
           <p:cNvPr id="5" name="项自动化测试全部通过-value">
             <a:extLst xmlns:a="http://schemas.openxmlformats.org/drawingml/2006/main">
               <a:ext uri="{FF2B5EF4-FFF2-40B4-BE49-F238E27FC236}">
-                <a16:creationId xmlns:a16="http://schemas.microsoft.com/office/drawing/2014/main" id="{B08328D5-F38B-4A10-B7F8-7E70EC90B872}"/>
+                <a16:creationId xmlns:a16="http://schemas.microsoft.com/office/drawing/2014/main" id="{EF78BFDB-6A6C-43E3-9A44-884996F146B6}"/>
               </a:ext>
             </a:extLst>
           </p:cNvPr>
@@ -6718,7 +6785,7 @@
           <p:cNvPr id="6" name="项自动化测试全部通过-label">
             <a:extLst xmlns:a="http://schemas.openxmlformats.org/drawingml/2006/main">
               <a:ext uri="{FF2B5EF4-FFF2-40B4-BE49-F238E27FC236}">
-                <a16:creationId xmlns:a16="http://schemas.microsoft.com/office/drawing/2014/main" id="{3A107B25-6A1A-41FB-B71E-2B2818985EF8}"/>
+                <a16:creationId xmlns:a16="http://schemas.microsoft.com/office/drawing/2014/main" id="{413A6344-D950-4EFC-BACE-382CB31F47B4}"/>
               </a:ext>
             </a:extLst>
           </p:cNvPr>
@@ -6768,7 +6835,7 @@
           <p:cNvPr id="7" name="条核心规则完成逐条人工评测-value">
             <a:extLst xmlns:a="http://schemas.openxmlformats.org/drawingml/2006/main">
               <a:ext uri="{FF2B5EF4-FFF2-40B4-BE49-F238E27FC236}">
-                <a16:creationId xmlns:a16="http://schemas.microsoft.com/office/drawing/2014/main" id="{B858E5F3-4136-4F86-B799-FCE992926A04}"/>
+                <a16:creationId xmlns:a16="http://schemas.microsoft.com/office/drawing/2014/main" id="{CDE109C5-E296-4DA8-9BE4-2B4E34855212}"/>
               </a:ext>
             </a:extLst>
           </p:cNvPr>
@@ -6818,7 +6885,7 @@
           <p:cNvPr id="8" name="条核心规则完成逐条人工评测-label">
             <a:extLst xmlns:a="http://schemas.openxmlformats.org/drawingml/2006/main">
               <a:ext uri="{FF2B5EF4-FFF2-40B4-BE49-F238E27FC236}">
-                <a16:creationId xmlns:a16="http://schemas.microsoft.com/office/drawing/2014/main" id="{1D63278C-C285-4BA5-8524-BFC2F610572E}"/>
+                <a16:creationId xmlns:a16="http://schemas.microsoft.com/office/drawing/2014/main" id="{4BA40C1A-659C-4EBF-AB9D-5A9145918512}"/>
               </a:ext>
             </a:extLst>
           </p:cNvPr>
@@ -6868,7 +6935,7 @@
           <p:cNvPr id="9" name="次 DeepSeek 真实调用并人工复核-value">
             <a:extLst xmlns:a="http://schemas.openxmlformats.org/drawingml/2006/main">
               <a:ext uri="{FF2B5EF4-FFF2-40B4-BE49-F238E27FC236}">
-                <a16:creationId xmlns:a16="http://schemas.microsoft.com/office/drawing/2014/main" id="{DEAD1A6B-E7A2-4D26-A509-91CF5B8D12D1}"/>
+                <a16:creationId xmlns:a16="http://schemas.microsoft.com/office/drawing/2014/main" id="{567FB76D-76A2-43A8-811F-48C2FCD81A6D}"/>
               </a:ext>
             </a:extLst>
           </p:cNvPr>
@@ -6918,7 +6985,7 @@
           <p:cNvPr id="10" name="次 DeepSeek 真实调用并人工复核-label">
             <a:extLst xmlns:a="http://schemas.openxmlformats.org/drawingml/2006/main">
               <a:ext uri="{FF2B5EF4-FFF2-40B4-BE49-F238E27FC236}">
-                <a16:creationId xmlns:a16="http://schemas.microsoft.com/office/drawing/2014/main" id="{C2079F95-205F-4032-9462-C789167D825B}"/>
+                <a16:creationId xmlns:a16="http://schemas.microsoft.com/office/drawing/2014/main" id="{0412FCAC-4438-448F-ACB2-0F090C4077CC}"/>
               </a:ext>
             </a:extLst>
           </p:cNvPr>
@@ -6968,7 +7035,7 @@
           <p:cNvPr id="11" name="eval-rule">
             <a:extLst xmlns:a="http://schemas.openxmlformats.org/drawingml/2006/main">
               <a:ext uri="{FF2B5EF4-FFF2-40B4-BE49-F238E27FC236}">
-                <a16:creationId xmlns:a16="http://schemas.microsoft.com/office/drawing/2014/main" id="{1F4053CC-E8E1-4A62-8235-660C312D7DC5}"/>
+                <a16:creationId xmlns:a16="http://schemas.microsoft.com/office/drawing/2014/main" id="{2A9CD36A-8947-4C60-B71D-0CD6586A5E14}"/>
               </a:ext>
             </a:extLst>
           </p:cNvPr>
@@ -7001,7 +7068,7 @@
           <p:cNvPr id="12" name="eval-boundary-title">
             <a:extLst xmlns:a="http://schemas.openxmlformats.org/drawingml/2006/main">
               <a:ext uri="{FF2B5EF4-FFF2-40B4-BE49-F238E27FC236}">
-                <a16:creationId xmlns:a16="http://schemas.microsoft.com/office/drawing/2014/main" id="{EDF99AED-5EB0-4C14-AA75-D753066DA14B}"/>
+                <a16:creationId xmlns:a16="http://schemas.microsoft.com/office/drawing/2014/main" id="{8831560B-A8A5-40DA-93EC-F5FD69B8BF72}"/>
               </a:ext>
             </a:extLst>
           </p:cNvPr>
@@ -7051,7 +7118,7 @@
           <p:cNvPr id="13" name="eval-boundary">
             <a:extLst xmlns:a="http://schemas.openxmlformats.org/drawingml/2006/main">
               <a:ext uri="{FF2B5EF4-FFF2-40B4-BE49-F238E27FC236}">
-                <a16:creationId xmlns:a16="http://schemas.microsoft.com/office/drawing/2014/main" id="{76AA5F88-6024-4358-97D2-D90C0D3FA5D6}"/>
+                <a16:creationId xmlns:a16="http://schemas.microsoft.com/office/drawing/2014/main" id="{75E7EDAD-4E83-4E39-931B-6A79F07499DA}"/>
               </a:ext>
             </a:extLst>
           </p:cNvPr>
@@ -7133,7 +7200,7 @@
     </p:spTree>
     <p:extLst>
       <p:ext uri="{BB962C8B-B14F-4D97-AF65-F5344CB8AC3E}">
-        <p14:creationId xmlns:p14="http://schemas.microsoft.com/office/powerpoint/2010/main" val="1752237338"/>
+        <p14:creationId xmlns:p14="http://schemas.microsoft.com/office/powerpoint/2010/main" val="125650124"/>
       </p:ext>
     </p:extLst>
   </p:cSld>
@@ -7164,7 +7231,7 @@
           <p:cNvPr id="43" name="kicker-8">
             <a:extLst xmlns:a="http://schemas.openxmlformats.org/drawingml/2006/main">
               <a:ext uri="{FF2B5EF4-FFF2-40B4-BE49-F238E27FC236}">
-                <a16:creationId xmlns:a16="http://schemas.microsoft.com/office/drawing/2014/main" id="{1FBB1289-F6F8-4BE8-8EB5-3E0D3F17829F}"/>
+                <a16:creationId xmlns:a16="http://schemas.microsoft.com/office/drawing/2014/main" id="{E2223DBB-E6CD-427E-BA58-1CD992964C63}"/>
               </a:ext>
             </a:extLst>
           </p:cNvPr>
@@ -7214,7 +7281,7 @@
           <p:cNvPr id="2" name="title-8">
             <a:extLst xmlns:a="http://schemas.openxmlformats.org/drawingml/2006/main">
               <a:ext uri="{FF2B5EF4-FFF2-40B4-BE49-F238E27FC236}">
-                <a16:creationId xmlns:a16="http://schemas.microsoft.com/office/drawing/2014/main" id="{CDBE6948-9CA7-43C2-B3E6-2D0B71D624CD}"/>
+                <a16:creationId xmlns:a16="http://schemas.microsoft.com/office/drawing/2014/main" id="{A7AAEDF7-0AC5-4D2D-A92D-7FADDE3418E0}"/>
               </a:ext>
             </a:extLst>
           </p:cNvPr>
@@ -7264,7 +7331,7 @@
           <p:cNvPr id="3" name="rule-8">
             <a:extLst xmlns:a="http://schemas.openxmlformats.org/drawingml/2006/main">
               <a:ext uri="{FF2B5EF4-FFF2-40B4-BE49-F238E27FC236}">
-                <a16:creationId xmlns:a16="http://schemas.microsoft.com/office/drawing/2014/main" id="{A51AC5A2-36E3-4BC9-A9C7-796BD05DE145}"/>
+                <a16:creationId xmlns:a16="http://schemas.microsoft.com/office/drawing/2014/main" id="{8B733DCB-5D8A-4CEF-BBD2-F6FEAC33FB2F}"/>
               </a:ext>
             </a:extLst>
           </p:cNvPr>
@@ -7297,7 +7364,7 @@
           <p:cNvPr id="4" name="page-8">
             <a:extLst xmlns:a="http://schemas.openxmlformats.org/drawingml/2006/main">
               <a:ext uri="{FF2B5EF4-FFF2-40B4-BE49-F238E27FC236}">
-                <a16:creationId xmlns:a16="http://schemas.microsoft.com/office/drawing/2014/main" id="{C7054B2A-6710-4542-B74F-C5CC41EF78EF}"/>
+                <a16:creationId xmlns:a16="http://schemas.microsoft.com/office/drawing/2014/main" id="{68E2CC74-3A92-47CC-AC0A-E8C0D061B440}"/>
               </a:ext>
             </a:extLst>
           </p:cNvPr>
@@ -7347,7 +7414,7 @@
           <p:cNvPr id="5" name="compare-head">
             <a:extLst xmlns:a="http://schemas.openxmlformats.org/drawingml/2006/main">
               <a:ext uri="{FF2B5EF4-FFF2-40B4-BE49-F238E27FC236}">
-                <a16:creationId xmlns:a16="http://schemas.microsoft.com/office/drawing/2014/main" id="{1CB2FB36-F764-4F7F-A227-09BB0EA80152}"/>
+                <a16:creationId xmlns:a16="http://schemas.microsoft.com/office/drawing/2014/main" id="{55C1B7E3-058B-4E28-936D-D3C87441C8BC}"/>
               </a:ext>
             </a:extLst>
           </p:cNvPr>
@@ -7380,7 +7447,7 @@
           <p:cNvPr id="6" name="compare-head-0">
             <a:extLst xmlns:a="http://schemas.openxmlformats.org/drawingml/2006/main">
               <a:ext uri="{FF2B5EF4-FFF2-40B4-BE49-F238E27FC236}">
-                <a16:creationId xmlns:a16="http://schemas.microsoft.com/office/drawing/2014/main" id="{EACD0671-F4F5-4130-A43B-2899BF7350BD}"/>
+                <a16:creationId xmlns:a16="http://schemas.microsoft.com/office/drawing/2014/main" id="{3F6B2709-683A-4914-9CFB-8744E4D47514}"/>
               </a:ext>
             </a:extLst>
           </p:cNvPr>
@@ -7430,7 +7497,7 @@
           <p:cNvPr id="7" name="compare-head-1">
             <a:extLst xmlns:a="http://schemas.openxmlformats.org/drawingml/2006/main">
               <a:ext uri="{FF2B5EF4-FFF2-40B4-BE49-F238E27FC236}">
-                <a16:creationId xmlns:a16="http://schemas.microsoft.com/office/drawing/2014/main" id="{4ED79F5B-CFBF-487E-90A2-15A64A3BD6D0}"/>
+                <a16:creationId xmlns:a16="http://schemas.microsoft.com/office/drawing/2014/main" id="{8AC34883-35A8-4253-9901-F5AB3809C244}"/>
               </a:ext>
             </a:extLst>
           </p:cNvPr>
@@ -7480,7 +7547,7 @@
           <p:cNvPr id="8" name="compare-head-2">
             <a:extLst xmlns:a="http://schemas.openxmlformats.org/drawingml/2006/main">
               <a:ext uri="{FF2B5EF4-FFF2-40B4-BE49-F238E27FC236}">
-                <a16:creationId xmlns:a16="http://schemas.microsoft.com/office/drawing/2014/main" id="{2D6B9A8F-14F0-43CE-B48F-C71AA01A4E67}"/>
+                <a16:creationId xmlns:a16="http://schemas.microsoft.com/office/drawing/2014/main" id="{466677B4-FBCF-47A8-B7C8-4FA6E1875341}"/>
               </a:ext>
             </a:extLst>
           </p:cNvPr>
@@ -7530,7 +7597,7 @@
           <p:cNvPr id="9" name="compare-head-3">
             <a:extLst xmlns:a="http://schemas.openxmlformats.org/drawingml/2006/main">
               <a:ext uri="{FF2B5EF4-FFF2-40B4-BE49-F238E27FC236}">
-                <a16:creationId xmlns:a16="http://schemas.microsoft.com/office/drawing/2014/main" id="{5C25AFFE-9F48-4719-B09B-9AE4C137C1BA}"/>
+                <a16:creationId xmlns:a16="http://schemas.microsoft.com/office/drawing/2014/main" id="{7CFA17E4-663A-4D8C-86AC-289FFD98F586}"/>
               </a:ext>
             </a:extLst>
           </p:cNvPr>
@@ -7580,7 +7647,7 @@
           <p:cNvPr id="10" name="compare-head-4">
             <a:extLst xmlns:a="http://schemas.openxmlformats.org/drawingml/2006/main">
               <a:ext uri="{FF2B5EF4-FFF2-40B4-BE49-F238E27FC236}">
-                <a16:creationId xmlns:a16="http://schemas.microsoft.com/office/drawing/2014/main" id="{DFA2E3FB-962E-4AC8-ADC6-A2BEB829D6DE}"/>
+                <a16:creationId xmlns:a16="http://schemas.microsoft.com/office/drawing/2014/main" id="{65EB6325-6944-4291-950E-CAE7D0B6D7D7}"/>
               </a:ext>
             </a:extLst>
           </p:cNvPr>
@@ -7630,7 +7697,7 @@
           <p:cNvPr id="11" name="compare-row-0">
             <a:extLst xmlns:a="http://schemas.openxmlformats.org/drawingml/2006/main">
               <a:ext uri="{FF2B5EF4-FFF2-40B4-BE49-F238E27FC236}">
-                <a16:creationId xmlns:a16="http://schemas.microsoft.com/office/drawing/2014/main" id="{3039600D-B22C-4165-A3A0-79DBD93C7A59}"/>
+                <a16:creationId xmlns:a16="http://schemas.microsoft.com/office/drawing/2014/main" id="{2B3F8665-9E7F-44FA-968F-8AA125BF80A6}"/>
               </a:ext>
             </a:extLst>
           </p:cNvPr>
@@ -7663,7 +7730,7 @@
           <p:cNvPr id="12" name="compare-0-0">
             <a:extLst xmlns:a="http://schemas.openxmlformats.org/drawingml/2006/main">
               <a:ext uri="{FF2B5EF4-FFF2-40B4-BE49-F238E27FC236}">
-                <a16:creationId xmlns:a16="http://schemas.microsoft.com/office/drawing/2014/main" id="{39E2521E-003E-4F66-BB72-D37AA06875F6}"/>
+                <a16:creationId xmlns:a16="http://schemas.microsoft.com/office/drawing/2014/main" id="{3FBD5126-6ED5-4827-AC2B-DE21A31FB458}"/>
               </a:ext>
             </a:extLst>
           </p:cNvPr>
@@ -7713,7 +7780,7 @@
           <p:cNvPr id="13" name="compare-0-1">
             <a:extLst xmlns:a="http://schemas.openxmlformats.org/drawingml/2006/main">
               <a:ext uri="{FF2B5EF4-FFF2-40B4-BE49-F238E27FC236}">
-                <a16:creationId xmlns:a16="http://schemas.microsoft.com/office/drawing/2014/main" id="{73C2D40D-8D94-4A3F-A74D-D93343BC6DF3}"/>
+                <a16:creationId xmlns:a16="http://schemas.microsoft.com/office/drawing/2014/main" id="{0815D07A-B6C5-4825-9304-3712BD6059B1}"/>
               </a:ext>
             </a:extLst>
           </p:cNvPr>
@@ -7763,7 +7830,7 @@
           <p:cNvPr id="14" name="compare-0-2">
             <a:extLst xmlns:a="http://schemas.openxmlformats.org/drawingml/2006/main">
               <a:ext uri="{FF2B5EF4-FFF2-40B4-BE49-F238E27FC236}">
-                <a16:creationId xmlns:a16="http://schemas.microsoft.com/office/drawing/2014/main" id="{EA378B8B-1C86-4814-BCC3-27E42C2554E6}"/>
+                <a16:creationId xmlns:a16="http://schemas.microsoft.com/office/drawing/2014/main" id="{CDF3DBBB-C6F8-4574-B521-BF9E3C52A1B1}"/>
               </a:ext>
             </a:extLst>
           </p:cNvPr>
@@ -7813,7 +7880,7 @@
           <p:cNvPr id="15" name="compare-0-3">
             <a:extLst xmlns:a="http://schemas.openxmlformats.org/drawingml/2006/main">
               <a:ext uri="{FF2B5EF4-FFF2-40B4-BE49-F238E27FC236}">
-                <a16:creationId xmlns:a16="http://schemas.microsoft.com/office/drawing/2014/main" id="{FDB189B2-6CD3-4F4E-AA89-174BD22979AD}"/>
+                <a16:creationId xmlns:a16="http://schemas.microsoft.com/office/drawing/2014/main" id="{1940CDEB-E8AA-4D3B-8A2C-219B091A6615}"/>
               </a:ext>
             </a:extLst>
           </p:cNvPr>
@@ -7863,7 +7930,7 @@
           <p:cNvPr id="16" name="compare-0-4">
             <a:extLst xmlns:a="http://schemas.openxmlformats.org/drawingml/2006/main">
               <a:ext uri="{FF2B5EF4-FFF2-40B4-BE49-F238E27FC236}">
-                <a16:creationId xmlns:a16="http://schemas.microsoft.com/office/drawing/2014/main" id="{A057E914-CEB8-4467-A056-6BF27C4CF6BA}"/>
+                <a16:creationId xmlns:a16="http://schemas.microsoft.com/office/drawing/2014/main" id="{BD1FD6CA-A12F-47E9-A2A4-AB1B6B646AD4}"/>
               </a:ext>
             </a:extLst>
           </p:cNvPr>
@@ -7913,7 +7980,7 @@
           <p:cNvPr id="17" name="compare-row-1">
             <a:extLst xmlns:a="http://schemas.openxmlformats.org/drawingml/2006/main">
               <a:ext uri="{FF2B5EF4-FFF2-40B4-BE49-F238E27FC236}">
-                <a16:creationId xmlns:a16="http://schemas.microsoft.com/office/drawing/2014/main" id="{D8061156-AA9E-4DD0-A661-CBD71A59F059}"/>
+                <a16:creationId xmlns:a16="http://schemas.microsoft.com/office/drawing/2014/main" id="{5B5C02C3-B28A-4369-B7DF-1AED7F3EFEA4}"/>
               </a:ext>
             </a:extLst>
           </p:cNvPr>
@@ -7946,7 +8013,7 @@
           <p:cNvPr id="18" name="compare-1-0">
             <a:extLst xmlns:a="http://schemas.openxmlformats.org/drawingml/2006/main">
               <a:ext uri="{FF2B5EF4-FFF2-40B4-BE49-F238E27FC236}">
-                <a16:creationId xmlns:a16="http://schemas.microsoft.com/office/drawing/2014/main" id="{656FDAAE-3BE1-4961-B712-5EABECECC074}"/>
+                <a16:creationId xmlns:a16="http://schemas.microsoft.com/office/drawing/2014/main" id="{506C0F3E-8574-46D4-9BFC-C2364A0EA878}"/>
               </a:ext>
             </a:extLst>
           </p:cNvPr>
@@ -7996,7 +8063,7 @@
           <p:cNvPr id="19" name="compare-1-1">
             <a:extLst xmlns:a="http://schemas.openxmlformats.org/drawingml/2006/main">
               <a:ext uri="{FF2B5EF4-FFF2-40B4-BE49-F238E27FC236}">
-                <a16:creationId xmlns:a16="http://schemas.microsoft.com/office/drawing/2014/main" id="{762C5F63-61F8-4435-B572-7DD10B5B9954}"/>
+                <a16:creationId xmlns:a16="http://schemas.microsoft.com/office/drawing/2014/main" id="{C6772611-854D-49FF-A27A-3A2D2163D13E}"/>
               </a:ext>
             </a:extLst>
           </p:cNvPr>
@@ -8046,7 +8113,7 @@
           <p:cNvPr id="20" name="compare-1-2">
             <a:extLst xmlns:a="http://schemas.openxmlformats.org/drawingml/2006/main">
               <a:ext uri="{FF2B5EF4-FFF2-40B4-BE49-F238E27FC236}">
-                <a16:creationId xmlns:a16="http://schemas.microsoft.com/office/drawing/2014/main" id="{A4A7B22B-0AEF-4756-8C68-6E57F4CF02BD}"/>
+                <a16:creationId xmlns:a16="http://schemas.microsoft.com/office/drawing/2014/main" id="{859540F8-2C57-4B49-8D70-D3573232480E}"/>
               </a:ext>
             </a:extLst>
           </p:cNvPr>
@@ -8096,7 +8163,7 @@
           <p:cNvPr id="21" name="compare-1-3">
             <a:extLst xmlns:a="http://schemas.openxmlformats.org/drawingml/2006/main">
               <a:ext uri="{FF2B5EF4-FFF2-40B4-BE49-F238E27FC236}">
-                <a16:creationId xmlns:a16="http://schemas.microsoft.com/office/drawing/2014/main" id="{0E06DF14-F05C-4A25-B556-381A7ECE8D61}"/>
+                <a16:creationId xmlns:a16="http://schemas.microsoft.com/office/drawing/2014/main" id="{752D9AED-99A2-476F-927F-B0939E5C08A5}"/>
               </a:ext>
             </a:extLst>
           </p:cNvPr>
@@ -8146,7 +8213,7 @@
           <p:cNvPr id="22" name="compare-1-4">
             <a:extLst xmlns:a="http://schemas.openxmlformats.org/drawingml/2006/main">
               <a:ext uri="{FF2B5EF4-FFF2-40B4-BE49-F238E27FC236}">
-                <a16:creationId xmlns:a16="http://schemas.microsoft.com/office/drawing/2014/main" id="{35FCB513-8AB3-4DA4-8809-28CEC3EE1FBC}"/>
+                <a16:creationId xmlns:a16="http://schemas.microsoft.com/office/drawing/2014/main" id="{08768F97-5205-455D-9875-6A812EE06843}"/>
               </a:ext>
             </a:extLst>
           </p:cNvPr>
@@ -8196,7 +8263,7 @@
           <p:cNvPr id="23" name="compare-row-2">
             <a:extLst xmlns:a="http://schemas.openxmlformats.org/drawingml/2006/main">
               <a:ext uri="{FF2B5EF4-FFF2-40B4-BE49-F238E27FC236}">
-                <a16:creationId xmlns:a16="http://schemas.microsoft.com/office/drawing/2014/main" id="{FBE2AC4D-93D2-42AB-A9C5-50504A8FAC02}"/>
+                <a16:creationId xmlns:a16="http://schemas.microsoft.com/office/drawing/2014/main" id="{F5978A2A-AD23-4979-A63B-C029D76AFAA3}"/>
               </a:ext>
             </a:extLst>
           </p:cNvPr>
@@ -8229,7 +8296,7 @@
           <p:cNvPr id="24" name="compare-2-0">
             <a:extLst xmlns:a="http://schemas.openxmlformats.org/drawingml/2006/main">
               <a:ext uri="{FF2B5EF4-FFF2-40B4-BE49-F238E27FC236}">
-                <a16:creationId xmlns:a16="http://schemas.microsoft.com/office/drawing/2014/main" id="{B3319301-7EC1-4DED-9C16-7E90260DA26D}"/>
+                <a16:creationId xmlns:a16="http://schemas.microsoft.com/office/drawing/2014/main" id="{525AB071-3327-4573-83BF-E0E5BC9F0A0E}"/>
               </a:ext>
             </a:extLst>
           </p:cNvPr>
@@ -8279,7 +8346,7 @@
           <p:cNvPr id="25" name="compare-2-1">
             <a:extLst xmlns:a="http://schemas.openxmlformats.org/drawingml/2006/main">
               <a:ext uri="{FF2B5EF4-FFF2-40B4-BE49-F238E27FC236}">
-                <a16:creationId xmlns:a16="http://schemas.microsoft.com/office/drawing/2014/main" id="{FD22CAD1-1399-4D30-A4C5-A9100182B10E}"/>
+                <a16:creationId xmlns:a16="http://schemas.microsoft.com/office/drawing/2014/main" id="{81667EB7-79A3-4B51-A581-D38EEFAD319F}"/>
               </a:ext>
             </a:extLst>
           </p:cNvPr>
@@ -8329,7 +8396,7 @@
           <p:cNvPr id="26" name="compare-2-2">
             <a:extLst xmlns:a="http://schemas.openxmlformats.org/drawingml/2006/main">
               <a:ext uri="{FF2B5EF4-FFF2-40B4-BE49-F238E27FC236}">
-                <a16:creationId xmlns:a16="http://schemas.microsoft.com/office/drawing/2014/main" id="{F5FE9F8B-9B5F-4ACE-A3E2-4FA7B8C158D2}"/>
+                <a16:creationId xmlns:a16="http://schemas.microsoft.com/office/drawing/2014/main" id="{727108A8-A927-4F21-83C0-DF8D9E1B12D2}"/>
               </a:ext>
             </a:extLst>
           </p:cNvPr>
@@ -8379,7 +8446,7 @@
           <p:cNvPr id="27" name="compare-2-3">
             <a:extLst xmlns:a="http://schemas.openxmlformats.org/drawingml/2006/main">
               <a:ext uri="{FF2B5EF4-FFF2-40B4-BE49-F238E27FC236}">
-                <a16:creationId xmlns:a16="http://schemas.microsoft.com/office/drawing/2014/main" id="{249B989A-85DB-4106-BA8A-10AF7D99B6AE}"/>
+                <a16:creationId xmlns:a16="http://schemas.microsoft.com/office/drawing/2014/main" id="{6AAFB8AE-21B8-44C1-9330-CEE475694D03}"/>
               </a:ext>
             </a:extLst>
           </p:cNvPr>
@@ -8429,7 +8496,7 @@
           <p:cNvPr id="28" name="compare-2-4">
             <a:extLst xmlns:a="http://schemas.openxmlformats.org/drawingml/2006/main">
               <a:ext uri="{FF2B5EF4-FFF2-40B4-BE49-F238E27FC236}">
-                <a16:creationId xmlns:a16="http://schemas.microsoft.com/office/drawing/2014/main" id="{020279BD-B88B-411C-B887-1C2F7A198D8A}"/>
+                <a16:creationId xmlns:a16="http://schemas.microsoft.com/office/drawing/2014/main" id="{E5A5043A-C7F8-4B1A-A9B1-8A4463362FD3}"/>
               </a:ext>
             </a:extLst>
           </p:cNvPr>
@@ -8479,7 +8546,7 @@
           <p:cNvPr id="29" name="compare-row-3">
             <a:extLst xmlns:a="http://schemas.openxmlformats.org/drawingml/2006/main">
               <a:ext uri="{FF2B5EF4-FFF2-40B4-BE49-F238E27FC236}">
-                <a16:creationId xmlns:a16="http://schemas.microsoft.com/office/drawing/2014/main" id="{37C7A471-0599-4D00-8C3D-6841D4EF3B2E}"/>
+                <a16:creationId xmlns:a16="http://schemas.microsoft.com/office/drawing/2014/main" id="{5711B849-F143-4EC6-B13C-A85AFB198139}"/>
               </a:ext>
             </a:extLst>
           </p:cNvPr>
@@ -8512,7 +8579,7 @@
           <p:cNvPr id="30" name="compare-3-0">
             <a:extLst xmlns:a="http://schemas.openxmlformats.org/drawingml/2006/main">
               <a:ext uri="{FF2B5EF4-FFF2-40B4-BE49-F238E27FC236}">
-                <a16:creationId xmlns:a16="http://schemas.microsoft.com/office/drawing/2014/main" id="{2DF9FD37-657C-4BEE-A074-D2C5BE36F77C}"/>
+                <a16:creationId xmlns:a16="http://schemas.microsoft.com/office/drawing/2014/main" id="{29399649-C878-4D55-AA8C-726A29A6942D}"/>
               </a:ext>
             </a:extLst>
           </p:cNvPr>
@@ -8562,7 +8629,7 @@
           <p:cNvPr id="31" name="compare-3-1">
             <a:extLst xmlns:a="http://schemas.openxmlformats.org/drawingml/2006/main">
               <a:ext uri="{FF2B5EF4-FFF2-40B4-BE49-F238E27FC236}">
-                <a16:creationId xmlns:a16="http://schemas.microsoft.com/office/drawing/2014/main" id="{7113BE46-1DE0-4A24-9500-98230B37A95B}"/>
+                <a16:creationId xmlns:a16="http://schemas.microsoft.com/office/drawing/2014/main" id="{626AE3C4-59ED-439A-961E-FEEDAEC09C08}"/>
               </a:ext>
             </a:extLst>
           </p:cNvPr>
@@ -8612,7 +8679,7 @@
           <p:cNvPr id="32" name="compare-3-2">
             <a:extLst xmlns:a="http://schemas.openxmlformats.org/drawingml/2006/main">
               <a:ext uri="{FF2B5EF4-FFF2-40B4-BE49-F238E27FC236}">
-                <a16:creationId xmlns:a16="http://schemas.microsoft.com/office/drawing/2014/main" id="{DF75CC2A-81F7-45BB-8741-BCB92BE8471C}"/>
+                <a16:creationId xmlns:a16="http://schemas.microsoft.com/office/drawing/2014/main" id="{F30F0525-4081-4DD0-AB28-99B64060CB1F}"/>
               </a:ext>
             </a:extLst>
           </p:cNvPr>
@@ -8662,7 +8729,7 @@
           <p:cNvPr id="33" name="compare-3-3">
             <a:extLst xmlns:a="http://schemas.openxmlformats.org/drawingml/2006/main">
               <a:ext uri="{FF2B5EF4-FFF2-40B4-BE49-F238E27FC236}">
-                <a16:creationId xmlns:a16="http://schemas.microsoft.com/office/drawing/2014/main" id="{B7A8B7D3-2565-43D4-AE9D-28EAD28E4607}"/>
+                <a16:creationId xmlns:a16="http://schemas.microsoft.com/office/drawing/2014/main" id="{3B2263AE-245B-41A1-8AD4-D14ECDEF3481}"/>
               </a:ext>
             </a:extLst>
           </p:cNvPr>
@@ -8712,7 +8779,7 @@
           <p:cNvPr id="34" name="compare-3-4">
             <a:extLst xmlns:a="http://schemas.openxmlformats.org/drawingml/2006/main">
               <a:ext uri="{FF2B5EF4-FFF2-40B4-BE49-F238E27FC236}">
-                <a16:creationId xmlns:a16="http://schemas.microsoft.com/office/drawing/2014/main" id="{CF732761-C73D-4551-8BB1-0A6FB5C32473}"/>
+                <a16:creationId xmlns:a16="http://schemas.microsoft.com/office/drawing/2014/main" id="{ED5EB2A1-3B7E-432B-B04C-6484CD3B6F6A}"/>
               </a:ext>
             </a:extLst>
           </p:cNvPr>
@@ -8762,7 +8829,7 @@
           <p:cNvPr id="35" name="compare-row-4">
             <a:extLst xmlns:a="http://schemas.openxmlformats.org/drawingml/2006/main">
               <a:ext uri="{FF2B5EF4-FFF2-40B4-BE49-F238E27FC236}">
-                <a16:creationId xmlns:a16="http://schemas.microsoft.com/office/drawing/2014/main" id="{6F69721B-4311-4CE2-945B-B8124F287EA3}"/>
+                <a16:creationId xmlns:a16="http://schemas.microsoft.com/office/drawing/2014/main" id="{2A86A80A-4813-4226-B1E8-747D22A6B42D}"/>
               </a:ext>
             </a:extLst>
           </p:cNvPr>
@@ -8795,7 +8862,7 @@
           <p:cNvPr id="36" name="compare-4-0">
             <a:extLst xmlns:a="http://schemas.openxmlformats.org/drawingml/2006/main">
               <a:ext uri="{FF2B5EF4-FFF2-40B4-BE49-F238E27FC236}">
-                <a16:creationId xmlns:a16="http://schemas.microsoft.com/office/drawing/2014/main" id="{85C8E1C6-644B-43EF-B2E4-7DE7606BD3FB}"/>
+                <a16:creationId xmlns:a16="http://schemas.microsoft.com/office/drawing/2014/main" id="{12BD6426-B276-4983-903C-52AC6FCF6B13}"/>
               </a:ext>
             </a:extLst>
           </p:cNvPr>
@@ -8845,7 +8912,7 @@
           <p:cNvPr id="37" name="compare-4-1">
             <a:extLst xmlns:a="http://schemas.openxmlformats.org/drawingml/2006/main">
               <a:ext uri="{FF2B5EF4-FFF2-40B4-BE49-F238E27FC236}">
-                <a16:creationId xmlns:a16="http://schemas.microsoft.com/office/drawing/2014/main" id="{7F8FC10F-0765-4D02-8174-3C49FF15701F}"/>
+                <a16:creationId xmlns:a16="http://schemas.microsoft.com/office/drawing/2014/main" id="{091AC556-2B62-48D9-9257-826B61919686}"/>
               </a:ext>
             </a:extLst>
           </p:cNvPr>
@@ -8895,7 +8962,7 @@
           <p:cNvPr id="38" name="compare-4-2">
             <a:extLst xmlns:a="http://schemas.openxmlformats.org/drawingml/2006/main">
               <a:ext uri="{FF2B5EF4-FFF2-40B4-BE49-F238E27FC236}">
-                <a16:creationId xmlns:a16="http://schemas.microsoft.com/office/drawing/2014/main" id="{646B4A0A-A4E3-42A8-ABCE-3DEBE5A57381}"/>
+                <a16:creationId xmlns:a16="http://schemas.microsoft.com/office/drawing/2014/main" id="{ACEEDF84-A05A-49A9-B4A8-20BAF561BE20}"/>
               </a:ext>
             </a:extLst>
           </p:cNvPr>
@@ -8945,7 +9012,7 @@
           <p:cNvPr id="39" name="compare-4-3">
             <a:extLst xmlns:a="http://schemas.openxmlformats.org/drawingml/2006/main">
               <a:ext uri="{FF2B5EF4-FFF2-40B4-BE49-F238E27FC236}">
-                <a16:creationId xmlns:a16="http://schemas.microsoft.com/office/drawing/2014/main" id="{05F8EB46-4016-4AFF-9A81-DDBDCFD4A092}"/>
+                <a16:creationId xmlns:a16="http://schemas.microsoft.com/office/drawing/2014/main" id="{9244F168-3654-4551-90EA-5C6F3E056367}"/>
               </a:ext>
             </a:extLst>
           </p:cNvPr>
@@ -8995,7 +9062,7 @@
           <p:cNvPr id="40" name="compare-4-4">
             <a:extLst xmlns:a="http://schemas.openxmlformats.org/drawingml/2006/main">
               <a:ext uri="{FF2B5EF4-FFF2-40B4-BE49-F238E27FC236}">
-                <a16:creationId xmlns:a16="http://schemas.microsoft.com/office/drawing/2014/main" id="{AFB0BAEB-8B84-429A-BA68-8602C1C89BB3}"/>
+                <a16:creationId xmlns:a16="http://schemas.microsoft.com/office/drawing/2014/main" id="{5BAC0B5D-0DC0-43F2-9B66-C9665A1FD5AF}"/>
               </a:ext>
             </a:extLst>
           </p:cNvPr>
@@ -9045,7 +9112,7 @@
           <p:cNvPr id="41" name="compare-takeaway-bg">
             <a:extLst xmlns:a="http://schemas.openxmlformats.org/drawingml/2006/main">
               <a:ext uri="{FF2B5EF4-FFF2-40B4-BE49-F238E27FC236}">
-                <a16:creationId xmlns:a16="http://schemas.microsoft.com/office/drawing/2014/main" id="{051E0383-B5C8-4975-AB12-C27525B1F879}"/>
+                <a16:creationId xmlns:a16="http://schemas.microsoft.com/office/drawing/2014/main" id="{9E210C06-C4EC-4BCD-BA5D-35B1A181DDB5}"/>
               </a:ext>
             </a:extLst>
           </p:cNvPr>
@@ -9078,7 +9145,7 @@
           <p:cNvPr id="42" name="compare-takeaway">
             <a:extLst xmlns:a="http://schemas.openxmlformats.org/drawingml/2006/main">
               <a:ext uri="{FF2B5EF4-FFF2-40B4-BE49-F238E27FC236}">
-                <a16:creationId xmlns:a16="http://schemas.microsoft.com/office/drawing/2014/main" id="{F7503380-D23F-47DF-AD20-848E50B2CEDE}"/>
+                <a16:creationId xmlns:a16="http://schemas.microsoft.com/office/drawing/2014/main" id="{14A38B28-17E7-49B5-AC26-F0D4EF3FAFE6}"/>
               </a:ext>
             </a:extLst>
           </p:cNvPr>
@@ -9126,7 +9193,7 @@
     </p:spTree>
     <p:extLst>
       <p:ext uri="{BB962C8B-B14F-4D97-AF65-F5344CB8AC3E}">
-        <p14:creationId xmlns:p14="http://schemas.microsoft.com/office/powerpoint/2010/main" val="1141723009"/>
+        <p14:creationId xmlns:p14="http://schemas.microsoft.com/office/powerpoint/2010/main" val="2107242189"/>
       </p:ext>
     </p:extLst>
   </p:cSld>
@@ -9157,7 +9224,7 @@
           <p:cNvPr id="12" name="kicker-9">
             <a:extLst xmlns:a="http://schemas.openxmlformats.org/drawingml/2006/main">
               <a:ext uri="{FF2B5EF4-FFF2-40B4-BE49-F238E27FC236}">
-                <a16:creationId xmlns:a16="http://schemas.microsoft.com/office/drawing/2014/main" id="{F2137537-5ABA-475F-A9E5-0EC6FFAECF06}"/>
+                <a16:creationId xmlns:a16="http://schemas.microsoft.com/office/drawing/2014/main" id="{5DA95D5A-8CB0-4625-A2BD-E1C1A0F313F5}"/>
               </a:ext>
             </a:extLst>
           </p:cNvPr>
@@ -9207,7 +9274,7 @@
           <p:cNvPr id="2" name="title-9">
             <a:extLst xmlns:a="http://schemas.openxmlformats.org/drawingml/2006/main">
               <a:ext uri="{FF2B5EF4-FFF2-40B4-BE49-F238E27FC236}">
-                <a16:creationId xmlns:a16="http://schemas.microsoft.com/office/drawing/2014/main" id="{96888E7D-B61B-439F-A07D-35ADEE298675}"/>
+                <a16:creationId xmlns:a16="http://schemas.microsoft.com/office/drawing/2014/main" id="{572444E7-72BC-4E9C-99C0-574725014947}"/>
               </a:ext>
             </a:extLst>
           </p:cNvPr>
@@ -9257,7 +9324,7 @@
           <p:cNvPr id="3" name="rule-9">
             <a:extLst xmlns:a="http://schemas.openxmlformats.org/drawingml/2006/main">
               <a:ext uri="{FF2B5EF4-FFF2-40B4-BE49-F238E27FC236}">
-                <a16:creationId xmlns:a16="http://schemas.microsoft.com/office/drawing/2014/main" id="{369E29F6-EDCB-4017-BB75-2E477C43F6BF}"/>
+                <a16:creationId xmlns:a16="http://schemas.microsoft.com/office/drawing/2014/main" id="{51A6FAC4-9DB4-4A3D-83CD-A742A7873659}"/>
               </a:ext>
             </a:extLst>
           </p:cNvPr>
@@ -9290,7 +9357,7 @@
           <p:cNvPr id="4" name="page-9">
             <a:extLst xmlns:a="http://schemas.openxmlformats.org/drawingml/2006/main">
               <a:ext uri="{FF2B5EF4-FFF2-40B4-BE49-F238E27FC236}">
-                <a16:creationId xmlns:a16="http://schemas.microsoft.com/office/drawing/2014/main" id="{A0961328-4BA6-43DD-A953-AE19819FDC0D}"/>
+                <a16:creationId xmlns:a16="http://schemas.microsoft.com/office/drawing/2014/main" id="{E44D87CB-53D7-48E3-85DF-FD2F538959D0}"/>
               </a:ext>
             </a:extLst>
           </p:cNvPr>
@@ -9340,7 +9407,7 @@
           <p:cNvPr id="5" name="ai-left-bg">
             <a:extLst xmlns:a="http://schemas.openxmlformats.org/drawingml/2006/main">
               <a:ext uri="{FF2B5EF4-FFF2-40B4-BE49-F238E27FC236}">
-                <a16:creationId xmlns:a16="http://schemas.microsoft.com/office/drawing/2014/main" id="{9DF58FB9-62E3-4147-B08B-062A72BDD39D}"/>
+                <a16:creationId xmlns:a16="http://schemas.microsoft.com/office/drawing/2014/main" id="{521C66B7-9740-4F7D-8EE4-E6CC18952A18}"/>
               </a:ext>
             </a:extLst>
           </p:cNvPr>
@@ -9373,7 +9440,7 @@
           <p:cNvPr id="6" name="ai-right-bg">
             <a:extLst xmlns:a="http://schemas.openxmlformats.org/drawingml/2006/main">
               <a:ext uri="{FF2B5EF4-FFF2-40B4-BE49-F238E27FC236}">
-                <a16:creationId xmlns:a16="http://schemas.microsoft.com/office/drawing/2014/main" id="{336C2B4D-35A5-44E3-AB88-FF23E613E388}"/>
+                <a16:creationId xmlns:a16="http://schemas.microsoft.com/office/drawing/2014/main" id="{18239307-7135-4F1C-B527-A3DBFB09E2A4}"/>
               </a:ext>
             </a:extLst>
           </p:cNvPr>
@@ -9406,7 +9473,7 @@
           <p:cNvPr id="7" name="ai-left-title">
             <a:extLst xmlns:a="http://schemas.openxmlformats.org/drawingml/2006/main">
               <a:ext uri="{FF2B5EF4-FFF2-40B4-BE49-F238E27FC236}">
-                <a16:creationId xmlns:a16="http://schemas.microsoft.com/office/drawing/2014/main" id="{C80A0705-1D67-4A7A-B8E0-071552FAB4CC}"/>
+                <a16:creationId xmlns:a16="http://schemas.microsoft.com/office/drawing/2014/main" id="{0F3BE3BE-AF5A-483A-8E35-5ED80EC93FEE}"/>
               </a:ext>
             </a:extLst>
           </p:cNvPr>
@@ -9456,7 +9523,7 @@
           <p:cNvPr id="8" name="ai-left">
             <a:extLst xmlns:a="http://schemas.openxmlformats.org/drawingml/2006/main">
               <a:ext uri="{FF2B5EF4-FFF2-40B4-BE49-F238E27FC236}">
-                <a16:creationId xmlns:a16="http://schemas.microsoft.com/office/drawing/2014/main" id="{8C8ED991-6C18-48C0-A1EE-EBCACF737A81}"/>
+                <a16:creationId xmlns:a16="http://schemas.microsoft.com/office/drawing/2014/main" id="{1E025EEE-DEDD-4484-81DD-9F5B6CAE05D6}"/>
               </a:ext>
             </a:extLst>
           </p:cNvPr>
@@ -9540,7 +9607,7 @@
           <p:cNvPr id="9" name="ai-right-title">
             <a:extLst xmlns:a="http://schemas.openxmlformats.org/drawingml/2006/main">
               <a:ext uri="{FF2B5EF4-FFF2-40B4-BE49-F238E27FC236}">
-                <a16:creationId xmlns:a16="http://schemas.microsoft.com/office/drawing/2014/main" id="{26ED0250-5693-4D22-A1CA-7D1BC0B01CF8}"/>
+                <a16:creationId xmlns:a16="http://schemas.microsoft.com/office/drawing/2014/main" id="{54C2B36D-2EA8-484F-A8C1-5773A7F5DA40}"/>
               </a:ext>
             </a:extLst>
           </p:cNvPr>
@@ -9590,7 +9657,7 @@
           <p:cNvPr id="10" name="ai-right">
             <a:extLst xmlns:a="http://schemas.openxmlformats.org/drawingml/2006/main">
               <a:ext uri="{FF2B5EF4-FFF2-40B4-BE49-F238E27FC236}">
-                <a16:creationId xmlns:a16="http://schemas.microsoft.com/office/drawing/2014/main" id="{13703AB5-70F2-4CBF-A4A6-DC7AD2DC64C0}"/>
+                <a16:creationId xmlns:a16="http://schemas.microsoft.com/office/drawing/2014/main" id="{F358624B-2F26-4D5A-8D7E-140839047B11}"/>
               </a:ext>
             </a:extLst>
           </p:cNvPr>
@@ -9674,7 +9741,7 @@
           <p:cNvPr id="11" name="ai-proof">
             <a:extLst xmlns:a="http://schemas.openxmlformats.org/drawingml/2006/main">
               <a:ext uri="{FF2B5EF4-FFF2-40B4-BE49-F238E27FC236}">
-                <a16:creationId xmlns:a16="http://schemas.microsoft.com/office/drawing/2014/main" id="{C6429ADA-4BD1-4A03-9600-51FE005C3AE5}"/>
+                <a16:creationId xmlns:a16="http://schemas.microsoft.com/office/drawing/2014/main" id="{FE127B3F-34DC-44D3-B636-2C5C5B99C327}"/>
               </a:ext>
             </a:extLst>
           </p:cNvPr>
@@ -9722,7 +9789,7 @@
     </p:spTree>
     <p:extLst>
       <p:ext uri="{BB962C8B-B14F-4D97-AF65-F5344CB8AC3E}">
-        <p14:creationId xmlns:p14="http://schemas.microsoft.com/office/powerpoint/2010/main" val="1147259087"/>
+        <p14:creationId xmlns:p14="http://schemas.microsoft.com/office/powerpoint/2010/main" val="916897944"/>
       </p:ext>
     </p:extLst>
   </p:cSld>

</xml_diff>